<commit_message>
Agregar desglose de tipos de variable y mencion de conexion GA4 en la presentacion
</commit_message>
<xml_diff>
--- a/Preentrega - Sofia Algamiz.pptx
+++ b/Preentrega - Sofia Algamiz.pptx
@@ -5,20 +5,20 @@
     <p:sldMasterId id="2147483648" r:id="rId1"/>
   </p:sldMasterIdLst>
   <p:sldIdLst>
-    <p:sldId id="256" r:id="rId2"/>
-    <p:sldId id="257" r:id="rId3"/>
-    <p:sldId id="258" r:id="rId4"/>
-    <p:sldId id="259" r:id="rId5"/>
-    <p:sldId id="260" r:id="rId6"/>
-    <p:sldId id="261" r:id="rId7"/>
-    <p:sldId id="262" r:id="rId8"/>
-    <p:sldId id="263" r:id="rId9"/>
-    <p:sldId id="264" r:id="rId10"/>
-    <p:sldId id="265" r:id="rId11"/>
-    <p:sldId id="266" r:id="rId12"/>
-    <p:sldId id="267" r:id="rId13"/>
+    <p:sldId id="256" r:id="rId7"/>
+    <p:sldId id="257" r:id="rId8"/>
+    <p:sldId id="258" r:id="rId9"/>
+    <p:sldId id="259" r:id="rId10"/>
+    <p:sldId id="260" r:id="rId11"/>
+    <p:sldId id="261" r:id="rId12"/>
+    <p:sldId id="262" r:id="rId13"/>
+    <p:sldId id="263" r:id="rId14"/>
+    <p:sldId id="264" r:id="rId15"/>
+    <p:sldId id="265" r:id="rId16"/>
+    <p:sldId id="266" r:id="rId17"/>
+    <p:sldId id="267" r:id="rId18"/>
   </p:sldIdLst>
-  <p:sldSz cx="12192000" cy="6858000"/>
+  <p:sldSz cx="12191695" cy="6858000" type="screen4x3"/>
   <p:notesSz cx="6858000" cy="9144000"/>
   <p:defaultTextStyle>
     <a:defPPr>
@@ -115,35 +115,14 @@
       </a:defRPr>
     </a:lvl9pPr>
   </p:defaultTextStyle>
-  <p:extLst>
-    <p:ext uri="{EFAFB233-063F-42B5-8137-9DF3F51BA10A}">
-      <p15:sldGuideLst xmlns:p15="http://schemas.microsoft.com/office/powerpoint/2012/main">
-        <p15:guide id="1" orient="horz" pos="2160">
-          <p15:clr>
-            <a:srgbClr val="A4A3A4"/>
-          </p15:clr>
-        </p15:guide>
-        <p15:guide id="2" pos="2880">
-          <p15:clr>
-            <a:srgbClr val="A4A3A4"/>
-          </p15:clr>
-        </p15:guide>
-      </p15:sldGuideLst>
-    </p:ext>
-  </p:extLst>
 </p:presentation>
 </file>
 
 <file path=ppt/charts/chart1.xml><?xml version="1.0" encoding="utf-8"?>
-<c:chartSpace xmlns:c="http://schemas.openxmlformats.org/drawingml/2006/chart" xmlns:a="http://schemas.openxmlformats.org/drawingml/2006/main" xmlns:r="http://schemas.openxmlformats.org/officeDocument/2006/relationships" xmlns:c16r2="http://schemas.microsoft.com/office/drawing/2015/06/chart">
-  <c:date1904 val="1"/>
-  <c:lang val="es-ES"/>
-  <c:roundedCorners val="1"/>
-  <c:style val="2"/>
+<c:chartSpace xmlns:c="http://schemas.openxmlformats.org/drawingml/2006/chart" xmlns:a="http://schemas.openxmlformats.org/drawingml/2006/main" xmlns:r="http://schemas.openxmlformats.org/officeDocument/2006/relationships">
   <c:chart>
     <c:autoTitleDeleted val="1"/>
     <c:plotArea>
-      <c:layout/>
       <c:scatterChart>
         <c:scatterStyle val="lineMarker"/>
         <c:varyColors val="0"/>
@@ -185,112 +164,112 @@
                 <c:formatCode>General</c:formatCode>
                 <c:ptCount val="36"/>
                 <c:pt idx="0">
-                  <c:v>83</c:v>
+                  <c:v>83.0</c:v>
                 </c:pt>
                 <c:pt idx="1">
-                  <c:v>244</c:v>
+                  <c:v>244.0</c:v>
                 </c:pt>
                 <c:pt idx="2">
-                  <c:v>232</c:v>
+                  <c:v>232.0</c:v>
                 </c:pt>
                 <c:pt idx="3">
-                  <c:v>580</c:v>
+                  <c:v>580.0</c:v>
                 </c:pt>
                 <c:pt idx="4">
-                  <c:v>152</c:v>
+                  <c:v>152.0</c:v>
                 </c:pt>
                 <c:pt idx="5">
-                  <c:v>168</c:v>
+                  <c:v>168.0</c:v>
                 </c:pt>
                 <c:pt idx="6">
-                  <c:v>229</c:v>
+                  <c:v>229.0</c:v>
                 </c:pt>
                 <c:pt idx="7">
-                  <c:v>282</c:v>
+                  <c:v>282.0</c:v>
                 </c:pt>
                 <c:pt idx="8">
-                  <c:v>144</c:v>
+                  <c:v>144.0</c:v>
                 </c:pt>
                 <c:pt idx="9">
-                  <c:v>377</c:v>
+                  <c:v>377.0</c:v>
                 </c:pt>
                 <c:pt idx="10">
-                  <c:v>185</c:v>
+                  <c:v>185.0</c:v>
                 </c:pt>
                 <c:pt idx="11">
-                  <c:v>151</c:v>
+                  <c:v>151.0</c:v>
                 </c:pt>
                 <c:pt idx="12">
-                  <c:v>178</c:v>
+                  <c:v>178.0</c:v>
                 </c:pt>
                 <c:pt idx="13">
-                  <c:v>87</c:v>
+                  <c:v>87.0</c:v>
                 </c:pt>
                 <c:pt idx="14">
-                  <c:v>550</c:v>
+                  <c:v>550.0</c:v>
                 </c:pt>
                 <c:pt idx="15">
-                  <c:v>89</c:v>
+                  <c:v>89.0</c:v>
                 </c:pt>
                 <c:pt idx="16">
-                  <c:v>184</c:v>
+                  <c:v>184.0</c:v>
                 </c:pt>
                 <c:pt idx="17">
-                  <c:v>484</c:v>
+                  <c:v>484.0</c:v>
                 </c:pt>
                 <c:pt idx="18">
-                  <c:v>120</c:v>
+                  <c:v>120.0</c:v>
                 </c:pt>
                 <c:pt idx="19">
-                  <c:v>142</c:v>
+                  <c:v>142.0</c:v>
                 </c:pt>
                 <c:pt idx="20">
-                  <c:v>94</c:v>
+                  <c:v>94.0</c:v>
                 </c:pt>
                 <c:pt idx="21">
-                  <c:v>203</c:v>
+                  <c:v>203.0</c:v>
                 </c:pt>
                 <c:pt idx="22">
-                  <c:v>523</c:v>
+                  <c:v>523.0</c:v>
                 </c:pt>
                 <c:pt idx="23">
-                  <c:v>154</c:v>
+                  <c:v>154.0</c:v>
                 </c:pt>
                 <c:pt idx="24">
-                  <c:v>178</c:v>
+                  <c:v>178.0</c:v>
                 </c:pt>
                 <c:pt idx="25">
-                  <c:v>668</c:v>
+                  <c:v>668.0</c:v>
                 </c:pt>
                 <c:pt idx="26">
-                  <c:v>141</c:v>
+                  <c:v>141.0</c:v>
                 </c:pt>
                 <c:pt idx="27">
-                  <c:v>296</c:v>
+                  <c:v>296.0</c:v>
                 </c:pt>
                 <c:pt idx="28">
-                  <c:v>105</c:v>
+                  <c:v>105.0</c:v>
                 </c:pt>
                 <c:pt idx="29">
-                  <c:v>111</c:v>
+                  <c:v>111.0</c:v>
                 </c:pt>
                 <c:pt idx="30">
-                  <c:v>112</c:v>
+                  <c:v>112.0</c:v>
                 </c:pt>
                 <c:pt idx="31">
-                  <c:v>165</c:v>
+                  <c:v>165.0</c:v>
                 </c:pt>
                 <c:pt idx="32">
-                  <c:v>83</c:v>
+                  <c:v>83.0</c:v>
                 </c:pt>
                 <c:pt idx="33">
-                  <c:v>119</c:v>
+                  <c:v>119.0</c:v>
                 </c:pt>
                 <c:pt idx="34">
-                  <c:v>115</c:v>
+                  <c:v>115.0</c:v>
                 </c:pt>
                 <c:pt idx="35">
-                  <c:v>19</c:v>
+                  <c:v>19.0</c:v>
                 </c:pt>
               </c:numCache>
             </c:numRef>
@@ -302,10 +281,10 @@
                 <c:formatCode>General</c:formatCode>
                 <c:ptCount val="36"/>
                 <c:pt idx="0">
-                  <c:v>95296.294687500005</c:v>
+                  <c:v>95296.2946875</c:v>
                 </c:pt>
                 <c:pt idx="1">
-                  <c:v>94636.527563195152</c:v>
+                  <c:v>94636.52756319515</c:v>
                 </c:pt>
                 <c:pt idx="2">
                   <c:v>111233.82917948719</c:v>
@@ -317,16 +296,16 @@
                   <c:v>111609.22807017544</c:v>
                 </c:pt>
                 <c:pt idx="5">
-                  <c:v>77505.696774193551</c:v>
+                  <c:v>77505.69677419355</c:v>
                 </c:pt>
                 <c:pt idx="6">
-                  <c:v>98286.752547619049</c:v>
+                  <c:v>98286.75254761905</c:v>
                 </c:pt>
                 <c:pt idx="7">
                   <c:v>101357.4290131579</c:v>
                 </c:pt>
                 <c:pt idx="8">
-                  <c:v>87714.487159090917</c:v>
+                  <c:v>87714.48715909092</c:v>
                 </c:pt>
                 <c:pt idx="9">
                   <c:v>93143.42558333333</c:v>
@@ -347,7 +326,7 @@
                   <c:v>100285.08449329359</c:v>
                 </c:pt>
                 <c:pt idx="15">
-                  <c:v>92265.722666666668</c:v>
+                  <c:v>92265.72266666667</c:v>
                 </c:pt>
                 <c:pt idx="16">
                   <c:v>133578.88638888887</c:v>
@@ -356,13 +335,13 @@
                   <c:v>135289.86217410714</c:v>
                 </c:pt>
                 <c:pt idx="18">
-                  <c:v>97506.412222222221</c:v>
+                  <c:v>97506.41222222222</c:v>
                 </c:pt>
                 <c:pt idx="19">
                   <c:v>96303.16127659574</c:v>
                 </c:pt>
                 <c:pt idx="20">
-                  <c:v>76039.959999999992</c:v>
+                  <c:v>76039.95999999999</c:v>
                 </c:pt>
                 <c:pt idx="21">
                   <c:v>221324.06597333332</c:v>
@@ -374,7 +353,7 @@
                   <c:v>106174.70230263157</c:v>
                 </c:pt>
                 <c:pt idx="24">
-                  <c:v>86871.088041958035</c:v>
+                  <c:v>86871.08804195804</c:v>
                 </c:pt>
                 <c:pt idx="25">
                   <c:v>115760.25142725598</c:v>
@@ -383,50 +362,37 @@
                   <c:v>101935.96846153846</c:v>
                 </c:pt>
                 <c:pt idx="27">
-                  <c:v>107021.34544671691</c:v>
+                  <c:v>107021.3454467169</c:v>
                 </c:pt>
                 <c:pt idx="28">
                   <c:v>117771.87948979592</c:v>
                 </c:pt>
                 <c:pt idx="29">
-                  <c:v>84075.351481481484</c:v>
+                  <c:v>84075.35148148148</c:v>
                 </c:pt>
                 <c:pt idx="30">
-                  <c:v>92851.043214285717</c:v>
+                  <c:v>92851.04321428572</c:v>
                 </c:pt>
                 <c:pt idx="31">
-                  <c:v>83705.827692307692</c:v>
+                  <c:v>83705.82769230769</c:v>
                 </c:pt>
                 <c:pt idx="32">
-                  <c:v>80100.151290322581</c:v>
+                  <c:v>80100.15129032258</c:v>
                 </c:pt>
                 <c:pt idx="33">
-                  <c:v>62099.819999999992</c:v>
+                  <c:v>62099.81999999999</c:v>
                 </c:pt>
                 <c:pt idx="34">
-                  <c:v>86402.187999999995</c:v>
+                  <c:v>86402.188</c:v>
                 </c:pt>
                 <c:pt idx="35">
-                  <c:v>101990</c:v>
+                  <c:v>101990.0</c:v>
                 </c:pt>
               </c:numCache>
             </c:numRef>
           </c:yVal>
           <c:smooth val="0"/>
-          <c:extLst>
-            <c:ext xmlns:c16="http://schemas.microsoft.com/office/drawing/2014/chart" uri="{C3380CC4-5D6E-409C-BE32-E72D297353CC}">
-              <c16:uniqueId val="{00000000-6FC8-413F-84B8-85D9241B2E45}"/>
-            </c:ext>
-          </c:extLst>
         </c:ser>
-        <c:dLbls>
-          <c:showLegendKey val="0"/>
-          <c:showVal val="0"/>
-          <c:showCatName val="0"/>
-          <c:showSerName val="0"/>
-          <c:showPercent val="0"/>
-          <c:showBubbleSize val="0"/>
-        </c:dLbls>
         <c:axId val="-2128940872"/>
         <c:axId val="-2129643912"/>
       </c:scatterChart>
@@ -444,7 +410,7 @@
               <a:lstStyle/>
               <a:p>
                 <a:r>
-                  <a:rPr lang="es-ES" sz="1100">
+                  <a:rPr sz="1100">
                     <a:solidFill>
                       <a:srgbClr val="6B7280"/>
                     </a:solidFill>
@@ -455,6 +421,7 @@
               </a:p>
             </c:rich>
           </c:tx>
+          <c:layout/>
           <c:overlay val="0"/>
         </c:title>
         <c:numFmt formatCode="General" sourceLinked="1"/>
@@ -473,7 +440,6 @@
                 <a:latin typeface="Calibri"/>
               </a:defRPr>
             </a:pPr>
-            <a:endParaRPr lang="es-AR"/>
           </a:p>
         </c:txPr>
         <c:crossAx val="-2129643912"/>
@@ -503,7 +469,7 @@
               <a:lstStyle/>
               <a:p>
                 <a:r>
-                  <a:rPr lang="es-ES" sz="1100">
+                  <a:rPr sz="1100">
                     <a:solidFill>
                       <a:srgbClr val="6B7280"/>
                     </a:solidFill>
@@ -514,6 +480,7 @@
               </a:p>
             </c:rich>
           </c:tx>
+          <c:layout/>
           <c:overlay val="0"/>
         </c:title>
         <c:numFmt formatCode="General" sourceLinked="1"/>
@@ -532,7 +499,6 @@
                 <a:latin typeface="Calibri"/>
               </a:defRPr>
             </a:pPr>
-            <a:endParaRPr lang="es-AR"/>
           </a:p>
         </c:txPr>
         <c:crossAx val="-2128940872"/>
@@ -561,19 +527,14 @@
 </file>
 
 <file path=ppt/charts/chart2.xml><?xml version="1.0" encoding="utf-8"?>
-<c:chartSpace xmlns:c="http://schemas.openxmlformats.org/drawingml/2006/chart" xmlns:a="http://schemas.openxmlformats.org/drawingml/2006/main" xmlns:r="http://schemas.openxmlformats.org/officeDocument/2006/relationships" xmlns:c16r2="http://schemas.microsoft.com/office/drawing/2015/06/chart">
+<c:chartSpace xmlns:c="http://schemas.openxmlformats.org/drawingml/2006/chart" xmlns:a="http://schemas.openxmlformats.org/drawingml/2006/main" xmlns:r="http://schemas.openxmlformats.org/officeDocument/2006/relationships">
   <c:date1904 val="0"/>
-  <c:lang val="es-ES"/>
-  <c:roundedCorners val="1"/>
-  <c:style val="2"/>
   <c:chart>
     <c:autoTitleDeleted val="1"/>
     <c:plotArea>
-      <c:layout/>
       <c:barChart>
         <c:barDir val="col"/>
         <c:grouping val="clustered"/>
-        <c:varyColors val="1"/>
         <c:ser>
           <c:idx val="0"/>
           <c:order val="0"/>
@@ -596,44 +557,6 @@
               <a:noFill/>
             </a:ln>
           </c:spPr>
-          <c:invertIfNegative val="1"/>
-          <c:dLbls>
-            <c:numFmt formatCode="&quot;$&quot;#,##0" sourceLinked="0"/>
-            <c:spPr>
-              <a:noFill/>
-              <a:ln>
-                <a:noFill/>
-              </a:ln>
-              <a:effectLst/>
-            </c:spPr>
-            <c:txPr>
-              <a:bodyPr/>
-              <a:lstStyle/>
-              <a:p>
-                <a:pPr>
-                  <a:defRPr sz="1000">
-                    <a:solidFill>
-                      <a:srgbClr val="1B1F3B"/>
-                    </a:solidFill>
-                    <a:latin typeface="Calibri"/>
-                  </a:defRPr>
-                </a:pPr>
-                <a:endParaRPr lang="es-AR"/>
-              </a:p>
-            </c:txPr>
-            <c:showLegendKey val="0"/>
-            <c:showVal val="1"/>
-            <c:showCatName val="0"/>
-            <c:showSerName val="0"/>
-            <c:showPercent val="0"/>
-            <c:showBubbleSize val="0"/>
-            <c:showLeaderLines val="0"/>
-            <c:extLst>
-              <c:ext xmlns:c15="http://schemas.microsoft.com/office/drawing/2012/chart" uri="{CE6537A1-D6FC-4f65-9D91-7224C49458BB}">
-                <c15:showLeaderLines val="0"/>
-              </c:ext>
-            </c:extLst>
-          </c:dLbls>
           <c:cat>
             <c:strRef>
               <c:f>Sheet1!$A$2:$A$5</c:f>
@@ -661,47 +584,45 @@
                 <c:formatCode>General</c:formatCode>
                 <c:ptCount val="4"/>
                 <c:pt idx="0">
-                  <c:v>113289</c:v>
+                  <c:v>113289.0</c:v>
                 </c:pt>
                 <c:pt idx="1">
-                  <c:v>116970</c:v>
+                  <c:v>116970.0</c:v>
                 </c:pt>
                 <c:pt idx="2">
-                  <c:v>124457</c:v>
+                  <c:v>124457.0</c:v>
                 </c:pt>
                 <c:pt idx="3">
-                  <c:v>126696</c:v>
+                  <c:v>126696.0</c:v>
                 </c:pt>
               </c:numCache>
             </c:numRef>
           </c:val>
-          <c:extLst>
-            <c:ext xmlns:c14="http://schemas.microsoft.com/office/drawing/2007/8/2/chart" uri="{6F2FDCE9-48DA-4B69-8628-5D25D57E5C99}">
-              <c14:invertSolidFillFmt>
-                <c14:spPr xmlns:c14="http://schemas.microsoft.com/office/drawing/2007/8/2/chart">
-                  <a:solidFill>
-                    <a:srgbClr val="FFFFFF"/>
-                  </a:solidFill>
-                  <a:ln>
-                    <a:noFill/>
-                  </a:ln>
-                </c14:spPr>
-              </c14:invertSolidFillFmt>
-            </c:ext>
-            <c:ext xmlns:c16="http://schemas.microsoft.com/office/drawing/2014/chart" uri="{C3380CC4-5D6E-409C-BE32-E72D297353CC}">
-              <c16:uniqueId val="{00000000-0103-4C5D-8583-9C0637F48CD5}"/>
-            </c:ext>
-          </c:extLst>
         </c:ser>
         <c:dLbls>
+          <c:numFmt formatCode="&quot;$&quot;#,##0" sourceLinked="0"/>
+          <c:txPr>
+            <a:bodyPr/>
+            <a:lstStyle/>
+            <a:p>
+              <a:pPr>
+                <a:defRPr sz="1000">
+                  <a:solidFill>
+                    <a:srgbClr val="1B1F3B"/>
+                  </a:solidFill>
+                  <a:latin typeface="Calibri"/>
+                </a:defRPr>
+              </a:pPr>
+            </a:p>
+          </c:txPr>
           <c:showLegendKey val="0"/>
           <c:showVal val="1"/>
           <c:showCatName val="0"/>
           <c:showSerName val="0"/>
           <c:showPercent val="0"/>
           <c:showBubbleSize val="0"/>
+          <c:showLeaderLines val="1"/>
         </c:dLbls>
-        <c:gapWidth val="150"/>
         <c:axId val="-2068027336"/>
         <c:axId val="-2113994440"/>
       </c:barChart>
@@ -719,7 +640,7 @@
               <a:lstStyle/>
               <a:p>
                 <a:r>
-                  <a:rPr lang="es-AR" sz="1100">
+                  <a:rPr sz="1100">
                     <a:solidFill>
                       <a:srgbClr val="6B7280"/>
                     </a:solidFill>
@@ -730,9 +651,9 @@
               </a:p>
             </c:rich>
           </c:tx>
+          <c:layout/>
           <c:overlay val="0"/>
         </c:title>
-        <c:numFmt formatCode="General" sourceLinked="0"/>
         <c:majorTickMark val="out"/>
         <c:minorTickMark val="none"/>
         <c:tickLblPos val="nextTo"/>
@@ -755,7 +676,6 @@
                 <a:latin typeface="Calibri"/>
               </a:defRPr>
             </a:pPr>
-            <a:endParaRPr lang="es-AR"/>
           </a:p>
         </c:txPr>
         <c:crossAx val="-2113994440"/>
@@ -767,9 +687,7 @@
       </c:catAx>
       <c:valAx>
         <c:axId val="-2113994440"/>
-        <c:scaling>
-          <c:orientation val="minMax"/>
-        </c:scaling>
+        <c:scaling/>
         <c:delete val="0"/>
         <c:axPos val="l"/>
         <c:majorGridlines>
@@ -788,7 +706,7 @@
               <a:lstStyle/>
               <a:p>
                 <a:r>
-                  <a:rPr lang="es-ES" sz="1100">
+                  <a:rPr sz="1100">
                     <a:solidFill>
                       <a:srgbClr val="6B7280"/>
                     </a:solidFill>
@@ -799,9 +717,9 @@
               </a:p>
             </c:rich>
           </c:tx>
+          <c:layout/>
           <c:overlay val="0"/>
         </c:title>
-        <c:numFmt formatCode="General" sourceLinked="1"/>
         <c:majorTickMark val="out"/>
         <c:minorTickMark val="none"/>
         <c:tickLblPos val="nextTo"/>
@@ -822,17 +740,13 @@
                 <a:latin typeface="Calibri"/>
               </a:defRPr>
             </a:pPr>
-            <a:endParaRPr lang="es-AR"/>
           </a:p>
         </c:txPr>
         <c:crossAx val="-2068027336"/>
         <c:crosses val="autoZero"/>
-        <c:crossBetween val="between"/>
       </c:valAx>
     </c:plotArea>
-    <c:plotVisOnly val="1"/>
     <c:dispBlanksAs val="gap"/>
-    <c:showDLblsOverMax val="1"/>
   </c:chart>
   <c:txPr>
     <a:bodyPr/>
@@ -851,19 +765,14 @@
 </file>
 
 <file path=ppt/charts/chart3.xml><?xml version="1.0" encoding="utf-8"?>
-<c:chartSpace xmlns:c="http://schemas.openxmlformats.org/drawingml/2006/chart" xmlns:a="http://schemas.openxmlformats.org/drawingml/2006/main" xmlns:r="http://schemas.openxmlformats.org/officeDocument/2006/relationships" xmlns:c16r2="http://schemas.microsoft.com/office/drawing/2015/06/chart">
+<c:chartSpace xmlns:c="http://schemas.openxmlformats.org/drawingml/2006/chart" xmlns:a="http://schemas.openxmlformats.org/drawingml/2006/main" xmlns:r="http://schemas.openxmlformats.org/officeDocument/2006/relationships">
   <c:date1904 val="0"/>
-  <c:lang val="es-ES"/>
-  <c:roundedCorners val="1"/>
-  <c:style val="2"/>
   <c:chart>
     <c:autoTitleDeleted val="1"/>
     <c:plotArea>
-      <c:layout/>
       <c:barChart>
         <c:barDir val="bar"/>
         <c:grouping val="clustered"/>
-        <c:varyColors val="1"/>
         <c:ser>
           <c:idx val="0"/>
           <c:order val="0"/>
@@ -886,44 +795,6 @@
               <a:noFill/>
             </a:ln>
           </c:spPr>
-          <c:invertIfNegative val="1"/>
-          <c:dLbls>
-            <c:numFmt formatCode="0&quot;%&quot;" sourceLinked="0"/>
-            <c:spPr>
-              <a:noFill/>
-              <a:ln>
-                <a:noFill/>
-              </a:ln>
-              <a:effectLst/>
-            </c:spPr>
-            <c:txPr>
-              <a:bodyPr/>
-              <a:lstStyle/>
-              <a:p>
-                <a:pPr>
-                  <a:defRPr sz="1000">
-                    <a:solidFill>
-                      <a:srgbClr val="1B1F3B"/>
-                    </a:solidFill>
-                    <a:latin typeface="Calibri"/>
-                  </a:defRPr>
-                </a:pPr>
-                <a:endParaRPr lang="es-AR"/>
-              </a:p>
-            </c:txPr>
-            <c:showLegendKey val="0"/>
-            <c:showVal val="1"/>
-            <c:showCatName val="0"/>
-            <c:showSerName val="0"/>
-            <c:showPercent val="0"/>
-            <c:showBubbleSize val="0"/>
-            <c:showLeaderLines val="0"/>
-            <c:extLst>
-              <c:ext xmlns:c15="http://schemas.microsoft.com/office/drawing/2012/chart" uri="{CE6537A1-D6FC-4f65-9D91-7224C49458BB}">
-                <c15:showLeaderLines val="0"/>
-              </c:ext>
-            </c:extLst>
-          </c:dLbls>
           <c:cat>
             <c:strRef>
               <c:f>Sheet1!$A$2:$A$9</c:f>
@@ -972,7 +843,7 @@
                   <c:v>6.2</c:v>
                 </c:pt>
                 <c:pt idx="3">
-                  <c:v>8</c:v>
+                  <c:v>8.0</c:v>
                 </c:pt>
                 <c:pt idx="4">
                   <c:v>14.6</c:v>
@@ -989,33 +860,31 @@
               </c:numCache>
             </c:numRef>
           </c:val>
-          <c:extLst>
-            <c:ext xmlns:c14="http://schemas.microsoft.com/office/drawing/2007/8/2/chart" uri="{6F2FDCE9-48DA-4B69-8628-5D25D57E5C99}">
-              <c14:invertSolidFillFmt>
-                <c14:spPr xmlns:c14="http://schemas.microsoft.com/office/drawing/2007/8/2/chart">
-                  <a:solidFill>
-                    <a:srgbClr val="FFFFFF"/>
-                  </a:solidFill>
-                  <a:ln>
-                    <a:noFill/>
-                  </a:ln>
-                </c14:spPr>
-              </c14:invertSolidFillFmt>
-            </c:ext>
-            <c:ext xmlns:c16="http://schemas.microsoft.com/office/drawing/2014/chart" uri="{C3380CC4-5D6E-409C-BE32-E72D297353CC}">
-              <c16:uniqueId val="{00000000-1CAC-438A-A0D9-519121D9F5E7}"/>
-            </c:ext>
-          </c:extLst>
         </c:ser>
         <c:dLbls>
+          <c:numFmt formatCode="0&quot;%&quot;" sourceLinked="0"/>
+          <c:txPr>
+            <a:bodyPr/>
+            <a:lstStyle/>
+            <a:p>
+              <a:pPr>
+                <a:defRPr sz="1000">
+                  <a:solidFill>
+                    <a:srgbClr val="1B1F3B"/>
+                  </a:solidFill>
+                  <a:latin typeface="Calibri"/>
+                </a:defRPr>
+              </a:pPr>
+            </a:p>
+          </c:txPr>
           <c:showLegendKey val="0"/>
           <c:showVal val="1"/>
           <c:showCatName val="0"/>
           <c:showSerName val="0"/>
           <c:showPercent val="0"/>
           <c:showBubbleSize val="0"/>
+          <c:showLeaderLines val="1"/>
         </c:dLbls>
-        <c:gapWidth val="150"/>
         <c:axId val="-2068027336"/>
         <c:axId val="-2113994440"/>
       </c:barChart>
@@ -1026,7 +895,6 @@
         </c:scaling>
         <c:delete val="0"/>
         <c:axPos val="l"/>
-        <c:numFmt formatCode="General" sourceLinked="0"/>
         <c:majorTickMark val="out"/>
         <c:minorTickMark val="none"/>
         <c:tickLblPos val="nextTo"/>
@@ -1049,7 +917,6 @@
                 <a:latin typeface="Calibri"/>
               </a:defRPr>
             </a:pPr>
-            <a:endParaRPr lang="es-AR"/>
           </a:p>
         </c:txPr>
         <c:crossAx val="-2113994440"/>
@@ -1061,9 +928,7 @@
       </c:catAx>
       <c:valAx>
         <c:axId val="-2113994440"/>
-        <c:scaling>
-          <c:orientation val="minMax"/>
-        </c:scaling>
+        <c:scaling/>
         <c:delete val="0"/>
         <c:axPos val="b"/>
         <c:majorGridlines>
@@ -1082,7 +947,7 @@
               <a:lstStyle/>
               <a:p>
                 <a:r>
-                  <a:rPr lang="es-ES" sz="1100">
+                  <a:rPr sz="1100">
                     <a:solidFill>
                       <a:srgbClr val="6B7280"/>
                     </a:solidFill>
@@ -1093,9 +958,9 @@
               </a:p>
             </c:rich>
           </c:tx>
+          <c:layout/>
           <c:overlay val="0"/>
         </c:title>
-        <c:numFmt formatCode="General" sourceLinked="1"/>
         <c:majorTickMark val="out"/>
         <c:minorTickMark val="none"/>
         <c:tickLblPos val="nextTo"/>
@@ -1116,17 +981,13 @@
                 <a:latin typeface="Calibri"/>
               </a:defRPr>
             </a:pPr>
-            <a:endParaRPr lang="es-AR"/>
           </a:p>
         </c:txPr>
         <c:crossAx val="-2068027336"/>
         <c:crosses val="autoZero"/>
-        <c:crossBetween val="between"/>
       </c:valAx>
     </c:plotArea>
-    <c:plotVisOnly val="1"/>
     <c:dispBlanksAs val="gap"/>
-    <c:showDLblsOverMax val="1"/>
   </c:chart>
   <c:txPr>
     <a:bodyPr/>
@@ -1145,19 +1006,14 @@
 </file>
 
 <file path=ppt/charts/chart4.xml><?xml version="1.0" encoding="utf-8"?>
-<c:chartSpace xmlns:c="http://schemas.openxmlformats.org/drawingml/2006/chart" xmlns:a="http://schemas.openxmlformats.org/drawingml/2006/main" xmlns:r="http://schemas.openxmlformats.org/officeDocument/2006/relationships" xmlns:c16r2="http://schemas.microsoft.com/office/drawing/2015/06/chart">
+<c:chartSpace xmlns:c="http://schemas.openxmlformats.org/drawingml/2006/chart" xmlns:a="http://schemas.openxmlformats.org/drawingml/2006/main" xmlns:r="http://schemas.openxmlformats.org/officeDocument/2006/relationships">
   <c:date1904 val="0"/>
-  <c:lang val="es-ES"/>
-  <c:roundedCorners val="1"/>
-  <c:style val="2"/>
   <c:chart>
     <c:autoTitleDeleted val="1"/>
     <c:plotArea>
-      <c:layout/>
       <c:barChart>
         <c:barDir val="col"/>
         <c:grouping val="clustered"/>
-        <c:varyColors val="1"/>
         <c:ser>
           <c:idx val="0"/>
           <c:order val="0"/>
@@ -1180,44 +1036,6 @@
               <a:noFill/>
             </a:ln>
           </c:spPr>
-          <c:invertIfNegative val="1"/>
-          <c:dLbls>
-            <c:numFmt formatCode="&quot;$&quot;#,##0" sourceLinked="0"/>
-            <c:spPr>
-              <a:noFill/>
-              <a:ln>
-                <a:noFill/>
-              </a:ln>
-              <a:effectLst/>
-            </c:spPr>
-            <c:txPr>
-              <a:bodyPr/>
-              <a:lstStyle/>
-              <a:p>
-                <a:pPr>
-                  <a:defRPr sz="1000">
-                    <a:solidFill>
-                      <a:srgbClr val="1B1F3B"/>
-                    </a:solidFill>
-                    <a:latin typeface="Calibri"/>
-                  </a:defRPr>
-                </a:pPr>
-                <a:endParaRPr lang="es-AR"/>
-              </a:p>
-            </c:txPr>
-            <c:showLegendKey val="0"/>
-            <c:showVal val="1"/>
-            <c:showCatName val="0"/>
-            <c:showSerName val="0"/>
-            <c:showPercent val="0"/>
-            <c:showBubbleSize val="0"/>
-            <c:showLeaderLines val="0"/>
-            <c:extLst>
-              <c:ext xmlns:c15="http://schemas.microsoft.com/office/drawing/2012/chart" uri="{CE6537A1-D6FC-4f65-9D91-7224C49458BB}">
-                <c15:showLeaderLines val="0"/>
-              </c:ext>
-            </c:extLst>
-          </c:dLbls>
           <c:cat>
             <c:strRef>
               <c:f>Sheet1!$A$2:$A$9</c:f>
@@ -1283,33 +1101,31 @@
               </c:numCache>
             </c:numRef>
           </c:val>
-          <c:extLst>
-            <c:ext xmlns:c14="http://schemas.microsoft.com/office/drawing/2007/8/2/chart" uri="{6F2FDCE9-48DA-4B69-8628-5D25D57E5C99}">
-              <c14:invertSolidFillFmt>
-                <c14:spPr xmlns:c14="http://schemas.microsoft.com/office/drawing/2007/8/2/chart">
-                  <a:solidFill>
-                    <a:srgbClr val="FFFFFF"/>
-                  </a:solidFill>
-                  <a:ln>
-                    <a:noFill/>
-                  </a:ln>
-                </c14:spPr>
-              </c14:invertSolidFillFmt>
-            </c:ext>
-            <c:ext xmlns:c16="http://schemas.microsoft.com/office/drawing/2014/chart" uri="{C3380CC4-5D6E-409C-BE32-E72D297353CC}">
-              <c16:uniqueId val="{00000000-64A8-4F49-9F21-F1ADDF3B0C72}"/>
-            </c:ext>
-          </c:extLst>
         </c:ser>
         <c:dLbls>
+          <c:numFmt formatCode="&quot;$&quot;#,##0" sourceLinked="0"/>
+          <c:txPr>
+            <a:bodyPr/>
+            <a:lstStyle/>
+            <a:p>
+              <a:pPr>
+                <a:defRPr sz="1000">
+                  <a:solidFill>
+                    <a:srgbClr val="1B1F3B"/>
+                  </a:solidFill>
+                  <a:latin typeface="Calibri"/>
+                </a:defRPr>
+              </a:pPr>
+            </a:p>
+          </c:txPr>
           <c:showLegendKey val="0"/>
           <c:showVal val="1"/>
           <c:showCatName val="0"/>
           <c:showSerName val="0"/>
           <c:showPercent val="0"/>
           <c:showBubbleSize val="0"/>
+          <c:showLeaderLines val="1"/>
         </c:dLbls>
-        <c:gapWidth val="150"/>
         <c:axId val="-2068027336"/>
         <c:axId val="-2113994440"/>
       </c:barChart>
@@ -1320,7 +1136,6 @@
         </c:scaling>
         <c:delete val="0"/>
         <c:axPos val="b"/>
-        <c:numFmt formatCode="General" sourceLinked="0"/>
         <c:majorTickMark val="out"/>
         <c:minorTickMark val="none"/>
         <c:tickLblPos val="nextTo"/>
@@ -1343,7 +1158,6 @@
                 <a:latin typeface="Calibri"/>
               </a:defRPr>
             </a:pPr>
-            <a:endParaRPr lang="es-AR"/>
           </a:p>
         </c:txPr>
         <c:crossAx val="-2113994440"/>
@@ -1355,9 +1169,7 @@
       </c:catAx>
       <c:valAx>
         <c:axId val="-2113994440"/>
-        <c:scaling>
-          <c:orientation val="minMax"/>
-        </c:scaling>
+        <c:scaling/>
         <c:delete val="0"/>
         <c:axPos val="l"/>
         <c:majorGridlines>
@@ -1376,7 +1188,7 @@
               <a:lstStyle/>
               <a:p>
                 <a:r>
-                  <a:rPr lang="es-ES" sz="1100">
+                  <a:rPr sz="1100">
                     <a:solidFill>
                       <a:srgbClr val="6B7280"/>
                     </a:solidFill>
@@ -1387,9 +1199,9 @@
               </a:p>
             </c:rich>
           </c:tx>
+          <c:layout/>
           <c:overlay val="0"/>
         </c:title>
-        <c:numFmt formatCode="General" sourceLinked="1"/>
         <c:majorTickMark val="out"/>
         <c:minorTickMark val="none"/>
         <c:tickLblPos val="nextTo"/>
@@ -1410,17 +1222,13 @@
                 <a:latin typeface="Calibri"/>
               </a:defRPr>
             </a:pPr>
-            <a:endParaRPr lang="es-AR"/>
           </a:p>
         </c:txPr>
         <c:crossAx val="-2068027336"/>
         <c:crosses val="autoZero"/>
-        <c:crossBetween val="between"/>
       </c:valAx>
     </c:plotArea>
-    <c:plotVisOnly val="1"/>
     <c:dispBlanksAs val="gap"/>
-    <c:showDLblsOverMax val="1"/>
   </c:chart>
   <c:txPr>
     <a:bodyPr/>
@@ -1476,9 +1284,10 @@
           <a:lstStyle/>
           <a:p>
             <a:r>
-              <a:rPr lang="en-US"/>
+              <a:rPr lang="en-US" smtClean="0"/>
               <a:t>Click to edit Master title style</a:t>
             </a:r>
+            <a:endParaRPr lang="en-US"/>
           </a:p>
         </p:txBody>
       </p:sp>
@@ -1594,9 +1403,10 @@
           </a:lstStyle>
           <a:p>
             <a:r>
-              <a:rPr lang="en-US"/>
+              <a:rPr lang="en-US" smtClean="0"/>
               <a:t>Click to edit Master subtitle style</a:t>
             </a:r>
+            <a:endParaRPr lang="en-US"/>
           </a:p>
         </p:txBody>
       </p:sp>
@@ -1617,7 +1427,7 @@
           <a:p>
             <a:fld id="{5BCAD085-E8A6-8845-BD4E-CB4CCA059FC4}" type="datetimeFigureOut">
               <a:rPr lang="en-US" smtClean="0"/>
-              <a:t>8/6/2026</a:t>
+              <a:t>1/27/13</a:t>
             </a:fld>
             <a:endParaRPr lang="en-US"/>
           </a:p>
@@ -1659,7 +1469,7 @@
           <a:p>
             <a:fld id="{C1FF6DA9-008F-8B48-92A6-B652298478BF}" type="slidenum">
               <a:rPr lang="en-US" smtClean="0"/>
-              <a:t>‹Nº›</a:t>
+              <a:t>‹#›</a:t>
             </a:fld>
             <a:endParaRPr lang="en-US"/>
           </a:p>
@@ -1711,9 +1521,10 @@
           <a:lstStyle/>
           <a:p>
             <a:r>
-              <a:rPr lang="en-US"/>
+              <a:rPr lang="en-US" smtClean="0"/>
               <a:t>Click to edit Master title style</a:t>
             </a:r>
+            <a:endParaRPr lang="en-US"/>
           </a:p>
         </p:txBody>
       </p:sp>
@@ -1734,37 +1545,38 @@
           <a:p>
             <a:pPr lvl="0"/>
             <a:r>
-              <a:rPr lang="en-US"/>
+              <a:rPr lang="en-US" smtClean="0"/>
               <a:t>Click to edit Master text styles</a:t>
             </a:r>
           </a:p>
           <a:p>
             <a:pPr lvl="1"/>
             <a:r>
-              <a:rPr lang="en-US"/>
+              <a:rPr lang="en-US" smtClean="0"/>
               <a:t>Second level</a:t>
             </a:r>
           </a:p>
           <a:p>
             <a:pPr lvl="2"/>
             <a:r>
-              <a:rPr lang="en-US"/>
+              <a:rPr lang="en-US" smtClean="0"/>
               <a:t>Third level</a:t>
             </a:r>
           </a:p>
           <a:p>
             <a:pPr lvl="3"/>
             <a:r>
-              <a:rPr lang="en-US"/>
+              <a:rPr lang="en-US" smtClean="0"/>
               <a:t>Fourth level</a:t>
             </a:r>
           </a:p>
           <a:p>
             <a:pPr lvl="4"/>
             <a:r>
-              <a:rPr lang="en-US"/>
+              <a:rPr lang="en-US" smtClean="0"/>
               <a:t>Fifth level</a:t>
             </a:r>
+            <a:endParaRPr lang="en-US"/>
           </a:p>
         </p:txBody>
       </p:sp>
@@ -1785,7 +1597,7 @@
           <a:p>
             <a:fld id="{5BCAD085-E8A6-8845-BD4E-CB4CCA059FC4}" type="datetimeFigureOut">
               <a:rPr lang="en-US" smtClean="0"/>
-              <a:t>8/6/2026</a:t>
+              <a:t>1/27/13</a:t>
             </a:fld>
             <a:endParaRPr lang="en-US"/>
           </a:p>
@@ -1827,7 +1639,7 @@
           <a:p>
             <a:fld id="{C1FF6DA9-008F-8B48-92A6-B652298478BF}" type="slidenum">
               <a:rPr lang="en-US" smtClean="0"/>
-              <a:t>‹Nº›</a:t>
+              <a:t>‹#›</a:t>
             </a:fld>
             <a:endParaRPr lang="en-US"/>
           </a:p>
@@ -1884,9 +1696,10 @@
           <a:lstStyle/>
           <a:p>
             <a:r>
-              <a:rPr lang="en-US"/>
+              <a:rPr lang="en-US" smtClean="0"/>
               <a:t>Click to edit Master title style</a:t>
             </a:r>
+            <a:endParaRPr lang="en-US"/>
           </a:p>
         </p:txBody>
       </p:sp>
@@ -1912,37 +1725,38 @@
           <a:p>
             <a:pPr lvl="0"/>
             <a:r>
-              <a:rPr lang="en-US"/>
+              <a:rPr lang="en-US" smtClean="0"/>
               <a:t>Click to edit Master text styles</a:t>
             </a:r>
           </a:p>
           <a:p>
             <a:pPr lvl="1"/>
             <a:r>
-              <a:rPr lang="en-US"/>
+              <a:rPr lang="en-US" smtClean="0"/>
               <a:t>Second level</a:t>
             </a:r>
           </a:p>
           <a:p>
             <a:pPr lvl="2"/>
             <a:r>
-              <a:rPr lang="en-US"/>
+              <a:rPr lang="en-US" smtClean="0"/>
               <a:t>Third level</a:t>
             </a:r>
           </a:p>
           <a:p>
             <a:pPr lvl="3"/>
             <a:r>
-              <a:rPr lang="en-US"/>
+              <a:rPr lang="en-US" smtClean="0"/>
               <a:t>Fourth level</a:t>
             </a:r>
           </a:p>
           <a:p>
             <a:pPr lvl="4"/>
             <a:r>
-              <a:rPr lang="en-US"/>
+              <a:rPr lang="en-US" smtClean="0"/>
               <a:t>Fifth level</a:t>
             </a:r>
+            <a:endParaRPr lang="en-US"/>
           </a:p>
         </p:txBody>
       </p:sp>
@@ -1963,7 +1777,7 @@
           <a:p>
             <a:fld id="{5BCAD085-E8A6-8845-BD4E-CB4CCA059FC4}" type="datetimeFigureOut">
               <a:rPr lang="en-US" smtClean="0"/>
-              <a:t>8/6/2026</a:t>
+              <a:t>1/27/13</a:t>
             </a:fld>
             <a:endParaRPr lang="en-US"/>
           </a:p>
@@ -2005,7 +1819,7 @@
           <a:p>
             <a:fld id="{C1FF6DA9-008F-8B48-92A6-B652298478BF}" type="slidenum">
               <a:rPr lang="en-US" smtClean="0"/>
-              <a:t>‹Nº›</a:t>
+              <a:t>‹#›</a:t>
             </a:fld>
             <a:endParaRPr lang="en-US"/>
           </a:p>
@@ -2057,9 +1871,10 @@
           <a:lstStyle/>
           <a:p>
             <a:r>
-              <a:rPr lang="en-US"/>
+              <a:rPr lang="en-US" smtClean="0"/>
               <a:t>Click to edit Master title style</a:t>
             </a:r>
+            <a:endParaRPr lang="en-US"/>
           </a:p>
         </p:txBody>
       </p:sp>
@@ -2080,37 +1895,38 @@
           <a:p>
             <a:pPr lvl="0"/>
             <a:r>
-              <a:rPr lang="en-US"/>
+              <a:rPr lang="en-US" smtClean="0"/>
               <a:t>Click to edit Master text styles</a:t>
             </a:r>
           </a:p>
           <a:p>
             <a:pPr lvl="1"/>
             <a:r>
-              <a:rPr lang="en-US"/>
+              <a:rPr lang="en-US" smtClean="0"/>
               <a:t>Second level</a:t>
             </a:r>
           </a:p>
           <a:p>
             <a:pPr lvl="2"/>
             <a:r>
-              <a:rPr lang="en-US"/>
+              <a:rPr lang="en-US" smtClean="0"/>
               <a:t>Third level</a:t>
             </a:r>
           </a:p>
           <a:p>
             <a:pPr lvl="3"/>
             <a:r>
-              <a:rPr lang="en-US"/>
+              <a:rPr lang="en-US" smtClean="0"/>
               <a:t>Fourth level</a:t>
             </a:r>
           </a:p>
           <a:p>
             <a:pPr lvl="4"/>
             <a:r>
-              <a:rPr lang="en-US"/>
+              <a:rPr lang="en-US" smtClean="0"/>
               <a:t>Fifth level</a:t>
             </a:r>
+            <a:endParaRPr lang="en-US"/>
           </a:p>
         </p:txBody>
       </p:sp>
@@ -2131,7 +1947,7 @@
           <a:p>
             <a:fld id="{5BCAD085-E8A6-8845-BD4E-CB4CCA059FC4}" type="datetimeFigureOut">
               <a:rPr lang="en-US" smtClean="0"/>
-              <a:t>8/6/2026</a:t>
+              <a:t>1/27/13</a:t>
             </a:fld>
             <a:endParaRPr lang="en-US"/>
           </a:p>
@@ -2173,7 +1989,7 @@
           <a:p>
             <a:fld id="{C1FF6DA9-008F-8B48-92A6-B652298478BF}" type="slidenum">
               <a:rPr lang="en-US" smtClean="0"/>
-              <a:t>‹Nº›</a:t>
+              <a:t>‹#›</a:t>
             </a:fld>
             <a:endParaRPr lang="en-US"/>
           </a:p>
@@ -2234,9 +2050,10 @@
           </a:lstStyle>
           <a:p>
             <a:r>
-              <a:rPr lang="en-US"/>
+              <a:rPr lang="en-US" smtClean="0"/>
               <a:t>Click to edit Master title style</a:t>
             </a:r>
+            <a:endParaRPr lang="en-US"/>
           </a:p>
         </p:txBody>
       </p:sp>
@@ -2353,7 +2170,7 @@
           <a:p>
             <a:pPr lvl="0"/>
             <a:r>
-              <a:rPr lang="en-US"/>
+              <a:rPr lang="en-US" smtClean="0"/>
               <a:t>Click to edit Master text styles</a:t>
             </a:r>
           </a:p>
@@ -2376,7 +2193,7 @@
           <a:p>
             <a:fld id="{5BCAD085-E8A6-8845-BD4E-CB4CCA059FC4}" type="datetimeFigureOut">
               <a:rPr lang="en-US" smtClean="0"/>
-              <a:t>8/6/2026</a:t>
+              <a:t>1/27/13</a:t>
             </a:fld>
             <a:endParaRPr lang="en-US"/>
           </a:p>
@@ -2418,7 +2235,7 @@
           <a:p>
             <a:fld id="{C1FF6DA9-008F-8B48-92A6-B652298478BF}" type="slidenum">
               <a:rPr lang="en-US" smtClean="0"/>
-              <a:t>‹Nº›</a:t>
+              <a:t>‹#›</a:t>
             </a:fld>
             <a:endParaRPr lang="en-US"/>
           </a:p>
@@ -2470,9 +2287,10 @@
           <a:lstStyle/>
           <a:p>
             <a:r>
-              <a:rPr lang="en-US"/>
+              <a:rPr lang="en-US" smtClean="0"/>
               <a:t>Click to edit Master title style</a:t>
             </a:r>
+            <a:endParaRPr lang="en-US"/>
           </a:p>
         </p:txBody>
       </p:sp>
@@ -2526,37 +2344,38 @@
           <a:p>
             <a:pPr lvl="0"/>
             <a:r>
-              <a:rPr lang="en-US"/>
+              <a:rPr lang="en-US" smtClean="0"/>
               <a:t>Click to edit Master text styles</a:t>
             </a:r>
           </a:p>
           <a:p>
             <a:pPr lvl="1"/>
             <a:r>
-              <a:rPr lang="en-US"/>
+              <a:rPr lang="en-US" smtClean="0"/>
               <a:t>Second level</a:t>
             </a:r>
           </a:p>
           <a:p>
             <a:pPr lvl="2"/>
             <a:r>
-              <a:rPr lang="en-US"/>
+              <a:rPr lang="en-US" smtClean="0"/>
               <a:t>Third level</a:t>
             </a:r>
           </a:p>
           <a:p>
             <a:pPr lvl="3"/>
             <a:r>
-              <a:rPr lang="en-US"/>
+              <a:rPr lang="en-US" smtClean="0"/>
               <a:t>Fourth level</a:t>
             </a:r>
           </a:p>
           <a:p>
             <a:pPr lvl="4"/>
             <a:r>
-              <a:rPr lang="en-US"/>
+              <a:rPr lang="en-US" smtClean="0"/>
               <a:t>Fifth level</a:t>
             </a:r>
+            <a:endParaRPr lang="en-US"/>
           </a:p>
         </p:txBody>
       </p:sp>
@@ -2610,37 +2429,38 @@
           <a:p>
             <a:pPr lvl="0"/>
             <a:r>
-              <a:rPr lang="en-US"/>
+              <a:rPr lang="en-US" smtClean="0"/>
               <a:t>Click to edit Master text styles</a:t>
             </a:r>
           </a:p>
           <a:p>
             <a:pPr lvl="1"/>
             <a:r>
-              <a:rPr lang="en-US"/>
+              <a:rPr lang="en-US" smtClean="0"/>
               <a:t>Second level</a:t>
             </a:r>
           </a:p>
           <a:p>
             <a:pPr lvl="2"/>
             <a:r>
-              <a:rPr lang="en-US"/>
+              <a:rPr lang="en-US" smtClean="0"/>
               <a:t>Third level</a:t>
             </a:r>
           </a:p>
           <a:p>
             <a:pPr lvl="3"/>
             <a:r>
-              <a:rPr lang="en-US"/>
+              <a:rPr lang="en-US" smtClean="0"/>
               <a:t>Fourth level</a:t>
             </a:r>
           </a:p>
           <a:p>
             <a:pPr lvl="4"/>
             <a:r>
-              <a:rPr lang="en-US"/>
+              <a:rPr lang="en-US" smtClean="0"/>
               <a:t>Fifth level</a:t>
             </a:r>
+            <a:endParaRPr lang="en-US"/>
           </a:p>
         </p:txBody>
       </p:sp>
@@ -2661,7 +2481,7 @@
           <a:p>
             <a:fld id="{5BCAD085-E8A6-8845-BD4E-CB4CCA059FC4}" type="datetimeFigureOut">
               <a:rPr lang="en-US" smtClean="0"/>
-              <a:t>8/6/2026</a:t>
+              <a:t>1/27/13</a:t>
             </a:fld>
             <a:endParaRPr lang="en-US"/>
           </a:p>
@@ -2703,7 +2523,7 @@
           <a:p>
             <a:fld id="{C1FF6DA9-008F-8B48-92A6-B652298478BF}" type="slidenum">
               <a:rPr lang="en-US" smtClean="0"/>
-              <a:t>‹Nº›</a:t>
+              <a:t>‹#›</a:t>
             </a:fld>
             <a:endParaRPr lang="en-US"/>
           </a:p>
@@ -2759,9 +2579,10 @@
           </a:lstStyle>
           <a:p>
             <a:r>
-              <a:rPr lang="en-US"/>
+              <a:rPr lang="en-US" smtClean="0"/>
               <a:t>Click to edit Master title style</a:t>
             </a:r>
+            <a:endParaRPr lang="en-US"/>
           </a:p>
         </p:txBody>
       </p:sp>
@@ -2824,7 +2645,7 @@
           <a:p>
             <a:pPr lvl="0"/>
             <a:r>
-              <a:rPr lang="en-US"/>
+              <a:rPr lang="en-US" smtClean="0"/>
               <a:t>Click to edit Master text styles</a:t>
             </a:r>
           </a:p>
@@ -2880,37 +2701,38 @@
           <a:p>
             <a:pPr lvl="0"/>
             <a:r>
-              <a:rPr lang="en-US"/>
+              <a:rPr lang="en-US" smtClean="0"/>
               <a:t>Click to edit Master text styles</a:t>
             </a:r>
           </a:p>
           <a:p>
             <a:pPr lvl="1"/>
             <a:r>
-              <a:rPr lang="en-US"/>
+              <a:rPr lang="en-US" smtClean="0"/>
               <a:t>Second level</a:t>
             </a:r>
           </a:p>
           <a:p>
             <a:pPr lvl="2"/>
             <a:r>
-              <a:rPr lang="en-US"/>
+              <a:rPr lang="en-US" smtClean="0"/>
               <a:t>Third level</a:t>
             </a:r>
           </a:p>
           <a:p>
             <a:pPr lvl="3"/>
             <a:r>
-              <a:rPr lang="en-US"/>
+              <a:rPr lang="en-US" smtClean="0"/>
               <a:t>Fourth level</a:t>
             </a:r>
           </a:p>
           <a:p>
             <a:pPr lvl="4"/>
             <a:r>
-              <a:rPr lang="en-US"/>
+              <a:rPr lang="en-US" smtClean="0"/>
               <a:t>Fifth level</a:t>
             </a:r>
+            <a:endParaRPr lang="en-US"/>
           </a:p>
         </p:txBody>
       </p:sp>
@@ -2973,7 +2795,7 @@
           <a:p>
             <a:pPr lvl="0"/>
             <a:r>
-              <a:rPr lang="en-US"/>
+              <a:rPr lang="en-US" smtClean="0"/>
               <a:t>Click to edit Master text styles</a:t>
             </a:r>
           </a:p>
@@ -3029,37 +2851,38 @@
           <a:p>
             <a:pPr lvl="0"/>
             <a:r>
-              <a:rPr lang="en-US"/>
+              <a:rPr lang="en-US" smtClean="0"/>
               <a:t>Click to edit Master text styles</a:t>
             </a:r>
           </a:p>
           <a:p>
             <a:pPr lvl="1"/>
             <a:r>
-              <a:rPr lang="en-US"/>
+              <a:rPr lang="en-US" smtClean="0"/>
               <a:t>Second level</a:t>
             </a:r>
           </a:p>
           <a:p>
             <a:pPr lvl="2"/>
             <a:r>
-              <a:rPr lang="en-US"/>
+              <a:rPr lang="en-US" smtClean="0"/>
               <a:t>Third level</a:t>
             </a:r>
           </a:p>
           <a:p>
             <a:pPr lvl="3"/>
             <a:r>
-              <a:rPr lang="en-US"/>
+              <a:rPr lang="en-US" smtClean="0"/>
               <a:t>Fourth level</a:t>
             </a:r>
           </a:p>
           <a:p>
             <a:pPr lvl="4"/>
             <a:r>
-              <a:rPr lang="en-US"/>
+              <a:rPr lang="en-US" smtClean="0"/>
               <a:t>Fifth level</a:t>
             </a:r>
+            <a:endParaRPr lang="en-US"/>
           </a:p>
         </p:txBody>
       </p:sp>
@@ -3080,7 +2903,7 @@
           <a:p>
             <a:fld id="{5BCAD085-E8A6-8845-BD4E-CB4CCA059FC4}" type="datetimeFigureOut">
               <a:rPr lang="en-US" smtClean="0"/>
-              <a:t>8/6/2026</a:t>
+              <a:t>1/27/13</a:t>
             </a:fld>
             <a:endParaRPr lang="en-US"/>
           </a:p>
@@ -3122,7 +2945,7 @@
           <a:p>
             <a:fld id="{C1FF6DA9-008F-8B48-92A6-B652298478BF}" type="slidenum">
               <a:rPr lang="en-US" smtClean="0"/>
-              <a:t>‹Nº›</a:t>
+              <a:t>‹#›</a:t>
             </a:fld>
             <a:endParaRPr lang="en-US"/>
           </a:p>
@@ -3174,9 +2997,10 @@
           <a:lstStyle/>
           <a:p>
             <a:r>
-              <a:rPr lang="en-US"/>
+              <a:rPr lang="en-US" smtClean="0"/>
               <a:t>Click to edit Master title style</a:t>
             </a:r>
+            <a:endParaRPr lang="en-US"/>
           </a:p>
         </p:txBody>
       </p:sp>
@@ -3197,7 +3021,7 @@
           <a:p>
             <a:fld id="{5BCAD085-E8A6-8845-BD4E-CB4CCA059FC4}" type="datetimeFigureOut">
               <a:rPr lang="en-US" smtClean="0"/>
-              <a:t>8/6/2026</a:t>
+              <a:t>1/27/13</a:t>
             </a:fld>
             <a:endParaRPr lang="en-US"/>
           </a:p>
@@ -3239,7 +3063,7 @@
           <a:p>
             <a:fld id="{C1FF6DA9-008F-8B48-92A6-B652298478BF}" type="slidenum">
               <a:rPr lang="en-US" smtClean="0"/>
-              <a:t>‹Nº›</a:t>
+              <a:t>‹#›</a:t>
             </a:fld>
             <a:endParaRPr lang="en-US"/>
           </a:p>
@@ -3292,7 +3116,7 @@
           <a:p>
             <a:fld id="{5BCAD085-E8A6-8845-BD4E-CB4CCA059FC4}" type="datetimeFigureOut">
               <a:rPr lang="en-US" smtClean="0"/>
-              <a:t>8/6/2026</a:t>
+              <a:t>1/27/13</a:t>
             </a:fld>
             <a:endParaRPr lang="en-US"/>
           </a:p>
@@ -3334,7 +3158,7 @@
           <a:p>
             <a:fld id="{C1FF6DA9-008F-8B48-92A6-B652298478BF}" type="slidenum">
               <a:rPr lang="en-US" smtClean="0"/>
-              <a:t>‹Nº›</a:t>
+              <a:t>‹#›</a:t>
             </a:fld>
             <a:endParaRPr lang="en-US"/>
           </a:p>
@@ -3395,9 +3219,10 @@
           </a:lstStyle>
           <a:p>
             <a:r>
-              <a:rPr lang="en-US"/>
+              <a:rPr lang="en-US" smtClean="0"/>
               <a:t>Click to edit Master title style</a:t>
             </a:r>
+            <a:endParaRPr lang="en-US"/>
           </a:p>
         </p:txBody>
       </p:sp>
@@ -3451,37 +3276,38 @@
           <a:p>
             <a:pPr lvl="0"/>
             <a:r>
-              <a:rPr lang="en-US"/>
+              <a:rPr lang="en-US" smtClean="0"/>
               <a:t>Click to edit Master text styles</a:t>
             </a:r>
           </a:p>
           <a:p>
             <a:pPr lvl="1"/>
             <a:r>
-              <a:rPr lang="en-US"/>
+              <a:rPr lang="en-US" smtClean="0"/>
               <a:t>Second level</a:t>
             </a:r>
           </a:p>
           <a:p>
             <a:pPr lvl="2"/>
             <a:r>
-              <a:rPr lang="en-US"/>
+              <a:rPr lang="en-US" smtClean="0"/>
               <a:t>Third level</a:t>
             </a:r>
           </a:p>
           <a:p>
             <a:pPr lvl="3"/>
             <a:r>
-              <a:rPr lang="en-US"/>
+              <a:rPr lang="en-US" smtClean="0"/>
               <a:t>Fourth level</a:t>
             </a:r>
           </a:p>
           <a:p>
             <a:pPr lvl="4"/>
             <a:r>
-              <a:rPr lang="en-US"/>
+              <a:rPr lang="en-US" smtClean="0"/>
               <a:t>Fifth level</a:t>
             </a:r>
+            <a:endParaRPr lang="en-US"/>
           </a:p>
         </p:txBody>
       </p:sp>
@@ -3544,7 +3370,7 @@
           <a:p>
             <a:pPr lvl="0"/>
             <a:r>
-              <a:rPr lang="en-US"/>
+              <a:rPr lang="en-US" smtClean="0"/>
               <a:t>Click to edit Master text styles</a:t>
             </a:r>
           </a:p>
@@ -3567,7 +3393,7 @@
           <a:p>
             <a:fld id="{5BCAD085-E8A6-8845-BD4E-CB4CCA059FC4}" type="datetimeFigureOut">
               <a:rPr lang="en-US" smtClean="0"/>
-              <a:t>8/6/2026</a:t>
+              <a:t>1/27/13</a:t>
             </a:fld>
             <a:endParaRPr lang="en-US"/>
           </a:p>
@@ -3609,7 +3435,7 @@
           <a:p>
             <a:fld id="{C1FF6DA9-008F-8B48-92A6-B652298478BF}" type="slidenum">
               <a:rPr lang="en-US" smtClean="0"/>
-              <a:t>‹Nº›</a:t>
+              <a:t>‹#›</a:t>
             </a:fld>
             <a:endParaRPr lang="en-US"/>
           </a:p>
@@ -3670,9 +3496,10 @@
           </a:lstStyle>
           <a:p>
             <a:r>
-              <a:rPr lang="en-US"/>
+              <a:rPr lang="en-US" smtClean="0"/>
               <a:t>Click to edit Master title style</a:t>
             </a:r>
+            <a:endParaRPr lang="en-US"/>
           </a:p>
         </p:txBody>
       </p:sp>
@@ -3796,7 +3623,7 @@
           <a:p>
             <a:pPr lvl="0"/>
             <a:r>
-              <a:rPr lang="en-US"/>
+              <a:rPr lang="en-US" smtClean="0"/>
               <a:t>Click to edit Master text styles</a:t>
             </a:r>
           </a:p>
@@ -3819,7 +3646,7 @@
           <a:p>
             <a:fld id="{5BCAD085-E8A6-8845-BD4E-CB4CCA059FC4}" type="datetimeFigureOut">
               <a:rPr lang="en-US" smtClean="0"/>
-              <a:t>8/6/2026</a:t>
+              <a:t>1/27/13</a:t>
             </a:fld>
             <a:endParaRPr lang="en-US"/>
           </a:p>
@@ -3861,7 +3688,7 @@
           <a:p>
             <a:fld id="{C1FF6DA9-008F-8B48-92A6-B652298478BF}" type="slidenum">
               <a:rPr lang="en-US" smtClean="0"/>
-              <a:t>‹Nº›</a:t>
+              <a:t>‹#›</a:t>
             </a:fld>
             <a:endParaRPr lang="en-US"/>
           </a:p>
@@ -3928,9 +3755,10 @@
           <a:lstStyle/>
           <a:p>
             <a:r>
-              <a:rPr lang="en-US"/>
+              <a:rPr lang="en-US" smtClean="0"/>
               <a:t>Click to edit Master title style</a:t>
             </a:r>
+            <a:endParaRPr lang="en-US"/>
           </a:p>
         </p:txBody>
       </p:sp>
@@ -3961,37 +3789,38 @@
           <a:p>
             <a:pPr lvl="0"/>
             <a:r>
-              <a:rPr lang="en-US"/>
+              <a:rPr lang="en-US" smtClean="0"/>
               <a:t>Click to edit Master text styles</a:t>
             </a:r>
           </a:p>
           <a:p>
             <a:pPr lvl="1"/>
             <a:r>
-              <a:rPr lang="en-US"/>
+              <a:rPr lang="en-US" smtClean="0"/>
               <a:t>Second level</a:t>
             </a:r>
           </a:p>
           <a:p>
             <a:pPr lvl="2"/>
             <a:r>
-              <a:rPr lang="en-US"/>
+              <a:rPr lang="en-US" smtClean="0"/>
               <a:t>Third level</a:t>
             </a:r>
           </a:p>
           <a:p>
             <a:pPr lvl="3"/>
             <a:r>
-              <a:rPr lang="en-US"/>
+              <a:rPr lang="en-US" smtClean="0"/>
               <a:t>Fourth level</a:t>
             </a:r>
           </a:p>
           <a:p>
             <a:pPr lvl="4"/>
             <a:r>
-              <a:rPr lang="en-US"/>
+              <a:rPr lang="en-US" smtClean="0"/>
               <a:t>Fifth level</a:t>
             </a:r>
+            <a:endParaRPr lang="en-US"/>
           </a:p>
         </p:txBody>
       </p:sp>
@@ -4030,7 +3859,7 @@
           <a:p>
             <a:fld id="{5BCAD085-E8A6-8845-BD4E-CB4CCA059FC4}" type="datetimeFigureOut">
               <a:rPr lang="en-US" smtClean="0"/>
-              <a:t>8/6/2026</a:t>
+              <a:t>1/27/13</a:t>
             </a:fld>
             <a:endParaRPr lang="en-US"/>
           </a:p>
@@ -4108,7 +3937,7 @@
           <a:p>
             <a:fld id="{C1FF6DA9-008F-8B48-92A6-B652298478BF}" type="slidenum">
               <a:rPr lang="en-US" smtClean="0"/>
-              <a:t>‹Nº›</a:t>
+              <a:t>‹#›</a:t>
             </a:fld>
             <a:endParaRPr lang="en-US"/>
           </a:p>
@@ -4389,7 +4218,7 @@
 </file>
 
 <file path=ppt/slides/slide1.xml><?xml version="1.0" encoding="utf-8"?>
-<p:sld xmlns:a="http://schemas.openxmlformats.org/drawingml/2006/main" xmlns:r="http://schemas.openxmlformats.org/officeDocument/2006/relationships" xmlns:p="http://schemas.openxmlformats.org/presentationml/2006/main">
+<p:sld xmlns:a="http://schemas.openxmlformats.org/drawingml/2006/main" xmlns:p="http://schemas.openxmlformats.org/presentationml/2006/main" xmlns:r="http://schemas.openxmlformats.org/officeDocument/2006/relationships">
   <p:cSld>
     <p:spTree>
       <p:nvGrpSpPr>
@@ -4397,14 +4226,7 @@
         <p:cNvGrpSpPr/>
         <p:nvPr/>
       </p:nvGrpSpPr>
-      <p:grpSpPr>
-        <a:xfrm>
-          <a:off x="0" y="0"/>
-          <a:ext cx="0" cy="0"/>
-          <a:chOff x="0" y="0"/>
-          <a:chExt cx="0" cy="0"/>
-        </a:xfrm>
-      </p:grpSpPr>
+      <p:grpSpPr/>
       <p:sp>
         <p:nvSpPr>
           <p:cNvPr id="2" name="Rectangle 1"/>
@@ -4446,7 +4268,6 @@
           <a:lstStyle/>
           <a:p>
             <a:pPr algn="ctr"/>
-            <a:endParaRPr/>
           </a:p>
         </p:txBody>
       </p:sp>
@@ -4491,7 +4312,6 @@
           <a:lstStyle/>
           <a:p>
             <a:pPr algn="ctr"/>
-            <a:endParaRPr/>
           </a:p>
         </p:txBody>
       </p:sp>
@@ -4536,7 +4356,6 @@
           <a:lstStyle/>
           <a:p>
             <a:pPr algn="ctr"/>
-            <a:endParaRPr/>
           </a:p>
         </p:txBody>
       </p:sp>
@@ -4557,7 +4376,7 @@
           <a:noFill/>
         </p:spPr>
         <p:txBody>
-          <a:bodyPr wrap="square" lIns="0" tIns="0" rIns="0" bIns="0" anchor="t">
+          <a:bodyPr wrap="square" lIns="0" rIns="0" tIns="0" bIns="0" anchor="t">
             <a:spAutoFit/>
           </a:bodyPr>
           <a:lstStyle/>
@@ -4596,7 +4415,7 @@
           <a:noFill/>
         </p:spPr>
         <p:txBody>
-          <a:bodyPr wrap="square" lIns="0" tIns="0" rIns="0" bIns="0" anchor="t">
+          <a:bodyPr wrap="square" lIns="0" rIns="0" tIns="0" bIns="0" anchor="t">
             <a:spAutoFit/>
           </a:bodyPr>
           <a:lstStyle/>
@@ -4651,7 +4470,7 @@
           <a:noFill/>
         </p:spPr>
         <p:txBody>
-          <a:bodyPr wrap="square" lIns="0" tIns="0" rIns="0" bIns="0" anchor="t">
+          <a:bodyPr wrap="square" lIns="0" rIns="0" tIns="0" bIns="0" anchor="t">
             <a:spAutoFit/>
           </a:bodyPr>
           <a:lstStyle/>
@@ -4690,7 +4509,7 @@
           <a:noFill/>
         </p:spPr>
         <p:txBody>
-          <a:bodyPr wrap="square" lIns="0" tIns="0" rIns="0" bIns="0" anchor="t">
+          <a:bodyPr wrap="square" lIns="0" rIns="0" tIns="0" bIns="0" anchor="t">
             <a:spAutoFit/>
           </a:bodyPr>
           <a:lstStyle/>
@@ -4701,116 +4520,53 @@
               </a:lnSpc>
             </a:pPr>
             <a:r>
-              <a:rPr sz="1300" b="0" i="1" dirty="0">
+              <a:rPr sz="1300" b="0" i="1">
                 <a:solidFill>
                   <a:srgbClr val="9AA6DA"/>
                 </a:solidFill>
                 <a:latin typeface="Calibri"/>
               </a:rPr>
-              <a:t>Primera Entrega — </a:t>
-            </a:r>
-            <a:r>
-              <a:rPr sz="1300" b="0" i="1" dirty="0" err="1">
-                <a:solidFill>
-                  <a:srgbClr val="9AA6DA"/>
+              <a:t>Primera Entrega — Obtención de insights a partir de visualizaciones</a:t>
+            </a:r>
+          </a:p>
+        </p:txBody>
+      </p:sp>
+      <p:sp>
+        <p:nvSpPr>
+          <p:cNvPr id="9" name="TextBox 8"/>
+          <p:cNvSpPr txBox="1"/>
+          <p:nvPr/>
+        </p:nvSpPr>
+        <p:spPr>
+          <a:xfrm>
+            <a:off x="822960" y="6217920"/>
+            <a:ext cx="8229600" cy="365760"/>
+          </a:xfrm>
+          <a:prstGeom prst="rect">
+            <a:avLst/>
+          </a:prstGeom>
+          <a:noFill/>
+        </p:spPr>
+        <p:txBody>
+          <a:bodyPr wrap="square" lIns="0" rIns="0" tIns="0" bIns="0" anchor="t">
+            <a:spAutoFit/>
+          </a:bodyPr>
+          <a:lstStyle/>
+          <a:p>
+            <a:pPr algn="l">
+              <a:lnSpc>
+                <a:spcPct val="100000"/>
+              </a:lnSpc>
+            </a:pPr>
+            <a:r>
+              <a:rPr sz="1300" b="1" i="0">
+                <a:solidFill>
+                  <a:srgbClr val="CADCFC"/>
                 </a:solidFill>
                 <a:latin typeface="Calibri"/>
               </a:rPr>
-              <a:t>Obtención</a:t>
-            </a:r>
-            <a:r>
-              <a:rPr sz="1300" b="0" i="1" dirty="0">
-                <a:solidFill>
-                  <a:srgbClr val="9AA6DA"/>
-                </a:solidFill>
-                <a:latin typeface="Calibri"/>
-              </a:rPr>
-              <a:t> de insights a </a:t>
-            </a:r>
-            <a:r>
-              <a:rPr sz="1300" b="0" i="1" dirty="0" err="1">
-                <a:solidFill>
-                  <a:srgbClr val="9AA6DA"/>
-                </a:solidFill>
-                <a:latin typeface="Calibri"/>
-              </a:rPr>
-              <a:t>partir</a:t>
-            </a:r>
-            <a:r>
-              <a:rPr sz="1300" b="0" i="1" dirty="0">
-                <a:solidFill>
-                  <a:srgbClr val="9AA6DA"/>
-                </a:solidFill>
-                <a:latin typeface="Calibri"/>
-              </a:rPr>
-              <a:t> de </a:t>
-            </a:r>
-            <a:r>
-              <a:rPr sz="1300" b="0" i="1" dirty="0" err="1">
-                <a:solidFill>
-                  <a:srgbClr val="9AA6DA"/>
-                </a:solidFill>
-                <a:latin typeface="Calibri"/>
-              </a:rPr>
-              <a:t>visualizaciones</a:t>
-            </a:r>
-            <a:endParaRPr sz="1300" b="0" i="1" dirty="0">
-              <a:solidFill>
-                <a:srgbClr val="9AA6DA"/>
-              </a:solidFill>
-              <a:latin typeface="Calibri"/>
-            </a:endParaRPr>
-          </a:p>
-        </p:txBody>
-      </p:sp>
-      <p:sp>
-        <p:nvSpPr>
-          <p:cNvPr id="10" name="TextBox 7">
-            <a:extLst>
-              <a:ext uri="{FF2B5EF4-FFF2-40B4-BE49-F238E27FC236}">
-                <a16:creationId xmlns:a16="http://schemas.microsoft.com/office/drawing/2014/main" id="{2EE31F7F-065B-44C3-480C-1E8D4F3036C9}"/>
-              </a:ext>
-            </a:extLst>
-          </p:cNvPr>
-          <p:cNvSpPr txBox="1"/>
-          <p:nvPr/>
-        </p:nvSpPr>
-        <p:spPr>
-          <a:xfrm>
-            <a:off x="822960" y="6217920"/>
-            <a:ext cx="8229600" cy="200055"/>
-          </a:xfrm>
-          <a:prstGeom prst="rect">
-            <a:avLst/>
-          </a:prstGeom>
-          <a:noFill/>
-        </p:spPr>
-        <p:txBody>
-          <a:bodyPr wrap="square" lIns="0" tIns="0" rIns="0" bIns="0" anchor="t">
-            <a:spAutoFit/>
-          </a:bodyPr>
-          <a:lstStyle/>
-          <a:p>
-            <a:pPr algn="l">
-              <a:lnSpc>
-                <a:spcPct val="100000"/>
-              </a:lnSpc>
-            </a:pPr>
-            <a:r>
-              <a:rPr lang="es-AR" sz="1300" b="1" dirty="0">
-                <a:solidFill>
-                  <a:srgbClr val="9AA6DA"/>
-                </a:solidFill>
-                <a:latin typeface="Calibri"/>
-              </a:rPr>
               <a:t>Sofia Algamiz</a:t>
             </a:r>
-            <a:endParaRPr sz="1300" b="1" dirty="0">
-              <a:solidFill>
-                <a:srgbClr val="9AA6DA"/>
-              </a:solidFill>
-              <a:latin typeface="Calibri"/>
-            </a:endParaRPr>
           </a:p>
         </p:txBody>
       </p:sp>
@@ -4823,7 +4579,7 @@
 </file>
 
 <file path=ppt/slides/slide10.xml><?xml version="1.0" encoding="utf-8"?>
-<p:sld xmlns:a="http://schemas.openxmlformats.org/drawingml/2006/main" xmlns:r="http://schemas.openxmlformats.org/officeDocument/2006/relationships" xmlns:p="http://schemas.openxmlformats.org/presentationml/2006/main">
+<p:sld xmlns:a="http://schemas.openxmlformats.org/drawingml/2006/main" xmlns:p="http://schemas.openxmlformats.org/presentationml/2006/main" xmlns:r="http://schemas.openxmlformats.org/officeDocument/2006/relationships">
   <p:cSld>
     <p:spTree>
       <p:nvGrpSpPr>
@@ -4831,14 +4587,7 @@
         <p:cNvGrpSpPr/>
         <p:nvPr/>
       </p:nvGrpSpPr>
-      <p:grpSpPr>
-        <a:xfrm>
-          <a:off x="0" y="0"/>
-          <a:ext cx="0" cy="0"/>
-          <a:chOff x="0" y="0"/>
-          <a:chExt cx="0" cy="0"/>
-        </a:xfrm>
-      </p:grpSpPr>
+      <p:grpSpPr/>
       <p:sp>
         <p:nvSpPr>
           <p:cNvPr id="2" name="Rectangle 1"/>
@@ -4880,7 +4629,6 @@
           <a:lstStyle/>
           <a:p>
             <a:pPr algn="ctr"/>
-            <a:endParaRPr/>
           </a:p>
         </p:txBody>
       </p:sp>
@@ -4901,7 +4649,7 @@
           <a:noFill/>
         </p:spPr>
         <p:txBody>
-          <a:bodyPr wrap="square" lIns="0" tIns="0" rIns="0" bIns="0" anchor="t">
+          <a:bodyPr wrap="square" lIns="0" rIns="0" tIns="0" bIns="0" anchor="t">
             <a:spAutoFit/>
           </a:bodyPr>
           <a:lstStyle/>
@@ -4940,7 +4688,7 @@
           <a:noFill/>
         </p:spPr>
         <p:txBody>
-          <a:bodyPr wrap="square" lIns="0" tIns="0" rIns="0" bIns="0" anchor="t">
+          <a:bodyPr wrap="square" lIns="0" rIns="0" tIns="0" bIns="0" anchor="t">
             <a:spAutoFit/>
           </a:bodyPr>
           <a:lstStyle/>
@@ -5005,7 +4753,6 @@
           <a:lstStyle/>
           <a:p>
             <a:pPr algn="ctr"/>
-            <a:endParaRPr/>
           </a:p>
         </p:txBody>
       </p:sp>
@@ -5050,7 +4797,6 @@
           <a:lstStyle/>
           <a:p>
             <a:pPr algn="ctr"/>
-            <a:endParaRPr/>
           </a:p>
         </p:txBody>
       </p:sp>
@@ -5071,7 +4817,7 @@
           <a:noFill/>
         </p:spPr>
         <p:txBody>
-          <a:bodyPr wrap="square" lIns="0" tIns="0" rIns="0" bIns="0" anchor="ctr">
+          <a:bodyPr wrap="square" lIns="0" rIns="0" tIns="0" bIns="0" anchor="ctr">
             <a:spAutoFit/>
           </a:bodyPr>
           <a:lstStyle/>
@@ -5110,7 +4856,7 @@
           <a:noFill/>
         </p:spPr>
         <p:txBody>
-          <a:bodyPr wrap="square" lIns="0" tIns="0" rIns="0" bIns="0" anchor="t">
+          <a:bodyPr wrap="square" lIns="0" rIns="0" tIns="0" bIns="0" anchor="t">
             <a:spAutoFit/>
           </a:bodyPr>
           <a:lstStyle/>
@@ -5149,7 +4895,7 @@
           <a:noFill/>
         </p:spPr>
         <p:txBody>
-          <a:bodyPr wrap="square" lIns="0" tIns="0" rIns="0" bIns="0" anchor="t">
+          <a:bodyPr wrap="square" lIns="0" rIns="0" tIns="0" bIns="0" anchor="t">
             <a:spAutoFit/>
           </a:bodyPr>
           <a:lstStyle/>
@@ -5214,7 +4960,6 @@
           <a:lstStyle/>
           <a:p>
             <a:pPr algn="ctr"/>
-            <a:endParaRPr/>
           </a:p>
         </p:txBody>
       </p:sp>
@@ -5259,7 +5004,6 @@
           <a:lstStyle/>
           <a:p>
             <a:pPr algn="ctr"/>
-            <a:endParaRPr/>
           </a:p>
         </p:txBody>
       </p:sp>
@@ -5280,7 +5024,7 @@
           <a:noFill/>
         </p:spPr>
         <p:txBody>
-          <a:bodyPr wrap="square" lIns="0" tIns="0" rIns="0" bIns="0" anchor="ctr">
+          <a:bodyPr wrap="square" lIns="0" rIns="0" tIns="0" bIns="0" anchor="ctr">
             <a:spAutoFit/>
           </a:bodyPr>
           <a:lstStyle/>
@@ -5319,7 +5063,7 @@
           <a:noFill/>
         </p:spPr>
         <p:txBody>
-          <a:bodyPr wrap="square" lIns="0" tIns="0" rIns="0" bIns="0" anchor="t">
+          <a:bodyPr wrap="square" lIns="0" rIns="0" tIns="0" bIns="0" anchor="t">
             <a:spAutoFit/>
           </a:bodyPr>
           <a:lstStyle/>
@@ -5358,7 +5102,7 @@
           <a:noFill/>
         </p:spPr>
         <p:txBody>
-          <a:bodyPr wrap="square" lIns="0" tIns="0" rIns="0" bIns="0" anchor="t">
+          <a:bodyPr wrap="square" lIns="0" rIns="0" tIns="0" bIns="0" anchor="t">
             <a:spAutoFit/>
           </a:bodyPr>
           <a:lstStyle/>
@@ -5423,7 +5167,6 @@
           <a:lstStyle/>
           <a:p>
             <a:pPr algn="ctr"/>
-            <a:endParaRPr/>
           </a:p>
         </p:txBody>
       </p:sp>
@@ -5468,7 +5211,6 @@
           <a:lstStyle/>
           <a:p>
             <a:pPr algn="ctr"/>
-            <a:endParaRPr/>
           </a:p>
         </p:txBody>
       </p:sp>
@@ -5489,7 +5231,7 @@
           <a:noFill/>
         </p:spPr>
         <p:txBody>
-          <a:bodyPr wrap="square" lIns="0" tIns="0" rIns="0" bIns="0" anchor="ctr">
+          <a:bodyPr wrap="square" lIns="0" rIns="0" tIns="0" bIns="0" anchor="ctr">
             <a:spAutoFit/>
           </a:bodyPr>
           <a:lstStyle/>
@@ -5528,7 +5270,7 @@
           <a:noFill/>
         </p:spPr>
         <p:txBody>
-          <a:bodyPr wrap="square" lIns="0" tIns="0" rIns="0" bIns="0" anchor="t">
+          <a:bodyPr wrap="square" lIns="0" rIns="0" tIns="0" bIns="0" anchor="t">
             <a:spAutoFit/>
           </a:bodyPr>
           <a:lstStyle/>
@@ -5567,7 +5309,7 @@
           <a:noFill/>
         </p:spPr>
         <p:txBody>
-          <a:bodyPr wrap="square" lIns="0" tIns="0" rIns="0" bIns="0" anchor="t">
+          <a:bodyPr wrap="square" lIns="0" rIns="0" tIns="0" bIns="0" anchor="t">
             <a:spAutoFit/>
           </a:bodyPr>
           <a:lstStyle/>
@@ -5606,7 +5348,7 @@
           <a:noFill/>
         </p:spPr>
         <p:txBody>
-          <a:bodyPr wrap="square" lIns="0" tIns="0" rIns="0" bIns="0" anchor="t">
+          <a:bodyPr wrap="square" lIns="0" rIns="0" tIns="0" bIns="0" anchor="t">
             <a:spAutoFit/>
           </a:bodyPr>
           <a:lstStyle/>
@@ -5645,7 +5387,7 @@
           <a:noFill/>
         </p:spPr>
         <p:txBody>
-          <a:bodyPr wrap="square" lIns="0" tIns="0" rIns="0" bIns="0" anchor="t">
+          <a:bodyPr wrap="square" lIns="0" rIns="0" tIns="0" bIns="0" anchor="t">
             <a:spAutoFit/>
           </a:bodyPr>
           <a:lstStyle/>
@@ -5676,7 +5418,7 @@
 </file>
 
 <file path=ppt/slides/slide11.xml><?xml version="1.0" encoding="utf-8"?>
-<p:sld xmlns:a="http://schemas.openxmlformats.org/drawingml/2006/main" xmlns:r="http://schemas.openxmlformats.org/officeDocument/2006/relationships" xmlns:p="http://schemas.openxmlformats.org/presentationml/2006/main">
+<p:sld xmlns:a="http://schemas.openxmlformats.org/drawingml/2006/main" xmlns:p="http://schemas.openxmlformats.org/presentationml/2006/main" xmlns:r="http://schemas.openxmlformats.org/officeDocument/2006/relationships">
   <p:cSld>
     <p:spTree>
       <p:nvGrpSpPr>
@@ -5684,14 +5426,7 @@
         <p:cNvGrpSpPr/>
         <p:nvPr/>
       </p:nvGrpSpPr>
-      <p:grpSpPr>
-        <a:xfrm>
-          <a:off x="0" y="0"/>
-          <a:ext cx="0" cy="0"/>
-          <a:chOff x="0" y="0"/>
-          <a:chExt cx="0" cy="0"/>
-        </a:xfrm>
-      </p:grpSpPr>
+      <p:grpSpPr/>
       <p:sp>
         <p:nvSpPr>
           <p:cNvPr id="2" name="Rectangle 1"/>
@@ -5733,7 +5468,6 @@
           <a:lstStyle/>
           <a:p>
             <a:pPr algn="ctr"/>
-            <a:endParaRPr/>
           </a:p>
         </p:txBody>
       </p:sp>
@@ -5754,7 +5488,7 @@
           <a:noFill/>
         </p:spPr>
         <p:txBody>
-          <a:bodyPr wrap="square" lIns="0" tIns="0" rIns="0" bIns="0" anchor="t">
+          <a:bodyPr wrap="square" lIns="0" rIns="0" tIns="0" bIns="0" anchor="t">
             <a:spAutoFit/>
           </a:bodyPr>
           <a:lstStyle/>
@@ -5793,7 +5527,7 @@
           <a:noFill/>
         </p:spPr>
         <p:txBody>
-          <a:bodyPr wrap="square" lIns="0" tIns="0" rIns="0" bIns="0" anchor="t">
+          <a:bodyPr wrap="square" lIns="0" rIns="0" tIns="0" bIns="0" anchor="t">
             <a:spAutoFit/>
           </a:bodyPr>
           <a:lstStyle/>
@@ -5832,7 +5566,7 @@
           <a:noFill/>
         </p:spPr>
         <p:txBody>
-          <a:bodyPr wrap="square" lIns="0" tIns="0" rIns="0" bIns="0" anchor="t">
+          <a:bodyPr wrap="square" lIns="0" rIns="0" tIns="0" bIns="0" anchor="t">
             <a:spAutoFit/>
           </a:bodyPr>
           <a:lstStyle/>
@@ -5897,7 +5631,6 @@
           <a:lstStyle/>
           <a:p>
             <a:pPr algn="ctr"/>
-            <a:endParaRPr/>
           </a:p>
         </p:txBody>
       </p:sp>
@@ -5942,7 +5675,6 @@
           <a:lstStyle/>
           <a:p>
             <a:pPr algn="ctr"/>
-            <a:endParaRPr/>
           </a:p>
         </p:txBody>
       </p:sp>
@@ -5963,7 +5695,7 @@
           <a:noFill/>
         </p:spPr>
         <p:txBody>
-          <a:bodyPr wrap="square" lIns="0" tIns="0" rIns="0" bIns="0" anchor="ctr">
+          <a:bodyPr wrap="square" lIns="0" rIns="0" tIns="0" bIns="0" anchor="ctr">
             <a:spAutoFit/>
           </a:bodyPr>
           <a:lstStyle/>
@@ -6002,7 +5734,7 @@
           <a:noFill/>
         </p:spPr>
         <p:txBody>
-          <a:bodyPr wrap="square" lIns="0" tIns="0" rIns="0" bIns="0" anchor="ctr">
+          <a:bodyPr wrap="square" lIns="0" rIns="0" tIns="0" bIns="0" anchor="ctr">
             <a:spAutoFit/>
           </a:bodyPr>
           <a:lstStyle/>
@@ -6041,7 +5773,7 @@
           <a:noFill/>
         </p:spPr>
         <p:txBody>
-          <a:bodyPr wrap="square" lIns="0" tIns="0" rIns="0" bIns="0" anchor="t">
+          <a:bodyPr wrap="square" lIns="0" rIns="0" tIns="0" bIns="0" anchor="t">
             <a:spAutoFit/>
           </a:bodyPr>
           <a:lstStyle/>
@@ -6106,7 +5838,6 @@
           <a:lstStyle/>
           <a:p>
             <a:pPr algn="ctr"/>
-            <a:endParaRPr/>
           </a:p>
         </p:txBody>
       </p:sp>
@@ -6151,7 +5882,6 @@
           <a:lstStyle/>
           <a:p>
             <a:pPr algn="ctr"/>
-            <a:endParaRPr/>
           </a:p>
         </p:txBody>
       </p:sp>
@@ -6172,7 +5902,7 @@
           <a:noFill/>
         </p:spPr>
         <p:txBody>
-          <a:bodyPr wrap="square" lIns="0" tIns="0" rIns="0" bIns="0" anchor="ctr">
+          <a:bodyPr wrap="square" lIns="0" rIns="0" tIns="0" bIns="0" anchor="ctr">
             <a:spAutoFit/>
           </a:bodyPr>
           <a:lstStyle/>
@@ -6211,7 +5941,7 @@
           <a:noFill/>
         </p:spPr>
         <p:txBody>
-          <a:bodyPr wrap="square" lIns="0" tIns="0" rIns="0" bIns="0" anchor="ctr">
+          <a:bodyPr wrap="square" lIns="0" rIns="0" tIns="0" bIns="0" anchor="ctr">
             <a:spAutoFit/>
           </a:bodyPr>
           <a:lstStyle/>
@@ -6250,7 +5980,7 @@
           <a:noFill/>
         </p:spPr>
         <p:txBody>
-          <a:bodyPr wrap="square" lIns="0" tIns="0" rIns="0" bIns="0" anchor="t">
+          <a:bodyPr wrap="square" lIns="0" rIns="0" tIns="0" bIns="0" anchor="t">
             <a:spAutoFit/>
           </a:bodyPr>
           <a:lstStyle/>
@@ -6315,7 +6045,6 @@
           <a:lstStyle/>
           <a:p>
             <a:pPr algn="ctr"/>
-            <a:endParaRPr/>
           </a:p>
         </p:txBody>
       </p:sp>
@@ -6360,7 +6089,6 @@
           <a:lstStyle/>
           <a:p>
             <a:pPr algn="ctr"/>
-            <a:endParaRPr/>
           </a:p>
         </p:txBody>
       </p:sp>
@@ -6381,7 +6109,7 @@
           <a:noFill/>
         </p:spPr>
         <p:txBody>
-          <a:bodyPr wrap="square" lIns="0" tIns="0" rIns="0" bIns="0" anchor="ctr">
+          <a:bodyPr wrap="square" lIns="0" rIns="0" tIns="0" bIns="0" anchor="ctr">
             <a:spAutoFit/>
           </a:bodyPr>
           <a:lstStyle/>
@@ -6420,7 +6148,7 @@
           <a:noFill/>
         </p:spPr>
         <p:txBody>
-          <a:bodyPr wrap="square" lIns="0" tIns="0" rIns="0" bIns="0" anchor="ctr">
+          <a:bodyPr wrap="square" lIns="0" rIns="0" tIns="0" bIns="0" anchor="ctr">
             <a:spAutoFit/>
           </a:bodyPr>
           <a:lstStyle/>
@@ -6459,7 +6187,7 @@
           <a:noFill/>
         </p:spPr>
         <p:txBody>
-          <a:bodyPr wrap="square" lIns="0" tIns="0" rIns="0" bIns="0" anchor="t">
+          <a:bodyPr wrap="square" lIns="0" rIns="0" tIns="0" bIns="0" anchor="t">
             <a:spAutoFit/>
           </a:bodyPr>
           <a:lstStyle/>
@@ -6483,7 +6211,175 @@
       </p:sp>
       <p:sp>
         <p:nvSpPr>
-          <p:cNvPr id="21" name="TextBox 20"/>
+          <p:cNvPr id="21" name="Rounded Rectangle 20"/>
+          <p:cNvSpPr/>
+          <p:nvPr/>
+        </p:nvSpPr>
+        <p:spPr>
+          <a:xfrm>
+            <a:off x="640080" y="5257800"/>
+            <a:ext cx="10789920" cy="640080"/>
+          </a:xfrm>
+          <a:prstGeom prst="roundRect">
+            <a:avLst>
+              <a:gd name="adj" fmla="val 8000"/>
+            </a:avLst>
+          </a:prstGeom>
+          <a:solidFill>
+            <a:srgbClr val="F4F6FC"/>
+          </a:solidFill>
+          <a:ln>
+            <a:noFill/>
+          </a:ln>
+          <a:effectLst/>
+        </p:spPr>
+        <p:style>
+          <a:lnRef idx="1">
+            <a:schemeClr val="accent1"/>
+          </a:lnRef>
+          <a:fillRef idx="3">
+            <a:schemeClr val="accent1"/>
+          </a:fillRef>
+          <a:effectRef idx="2">
+            <a:schemeClr val="accent1"/>
+          </a:effectRef>
+          <a:fontRef idx="minor">
+            <a:schemeClr val="lt1"/>
+          </a:fontRef>
+        </p:style>
+        <p:txBody>
+          <a:bodyPr rtlCol="0" anchor="ctr"/>
+          <a:lstStyle/>
+          <a:p>
+            <a:pPr algn="ctr"/>
+          </a:p>
+        </p:txBody>
+      </p:sp>
+      <p:sp>
+        <p:nvSpPr>
+          <p:cNvPr id="22" name="Oval 21"/>
+          <p:cNvSpPr/>
+          <p:nvPr/>
+        </p:nvSpPr>
+        <p:spPr>
+          <a:xfrm>
+            <a:off x="822959" y="5376672"/>
+            <a:ext cx="384048" cy="384048"/>
+          </a:xfrm>
+          <a:prstGeom prst="ellipse">
+            <a:avLst/>
+          </a:prstGeom>
+          <a:solidFill>
+            <a:srgbClr val="1E2761"/>
+          </a:solidFill>
+          <a:ln>
+            <a:noFill/>
+          </a:ln>
+          <a:effectLst/>
+        </p:spPr>
+        <p:style>
+          <a:lnRef idx="1">
+            <a:schemeClr val="accent1"/>
+          </a:lnRef>
+          <a:fillRef idx="3">
+            <a:schemeClr val="accent1"/>
+          </a:fillRef>
+          <a:effectRef idx="2">
+            <a:schemeClr val="accent1"/>
+          </a:effectRef>
+          <a:fontRef idx="minor">
+            <a:schemeClr val="lt1"/>
+          </a:fontRef>
+        </p:style>
+        <p:txBody>
+          <a:bodyPr rtlCol="0" anchor="ctr"/>
+          <a:lstStyle/>
+          <a:p>
+            <a:pPr algn="ctr"/>
+          </a:p>
+        </p:txBody>
+      </p:sp>
+      <p:sp>
+        <p:nvSpPr>
+          <p:cNvPr id="23" name="TextBox 22"/>
+          <p:cNvSpPr txBox="1"/>
+          <p:nvPr/>
+        </p:nvSpPr>
+        <p:spPr>
+          <a:xfrm>
+            <a:off x="822959" y="5376672"/>
+            <a:ext cx="384048" cy="384048"/>
+          </a:xfrm>
+          <a:prstGeom prst="rect">
+            <a:avLst/>
+          </a:prstGeom>
+          <a:noFill/>
+        </p:spPr>
+        <p:txBody>
+          <a:bodyPr wrap="square" lIns="0" rIns="0" tIns="0" bIns="0" anchor="ctr">
+            <a:spAutoFit/>
+          </a:bodyPr>
+          <a:lstStyle/>
+          <a:p>
+            <a:pPr algn="ctr">
+              <a:lnSpc>
+                <a:spcPct val="100000"/>
+              </a:lnSpc>
+            </a:pPr>
+            <a:r>
+              <a:rPr sz="1600" b="1" i="0">
+                <a:solidFill>
+                  <a:srgbClr val="FFFFFF"/>
+                </a:solidFill>
+                <a:latin typeface="Calibri"/>
+              </a:rPr>
+              <a:t>✓</a:t>
+            </a:r>
+          </a:p>
+        </p:txBody>
+      </p:sp>
+      <p:sp>
+        <p:nvSpPr>
+          <p:cNvPr id="24" name="TextBox 23"/>
+          <p:cNvSpPr txBox="1"/>
+          <p:nvPr/>
+        </p:nvSpPr>
+        <p:spPr>
+          <a:xfrm>
+            <a:off x="1371600" y="5257800"/>
+            <a:ext cx="9784080" cy="640080"/>
+          </a:xfrm>
+          <a:prstGeom prst="rect">
+            <a:avLst/>
+          </a:prstGeom>
+          <a:noFill/>
+        </p:spPr>
+        <p:txBody>
+          <a:bodyPr wrap="square" lIns="0" rIns="0" tIns="0" bIns="0" anchor="ctr">
+            <a:spAutoFit/>
+          </a:bodyPr>
+          <a:lstStyle/>
+          <a:p>
+            <a:pPr algn="l">
+              <a:lnSpc>
+                <a:spcPct val="120000"/>
+              </a:lnSpc>
+            </a:pPr>
+            <a:r>
+              <a:rPr sz="1200" b="0" i="1">
+                <a:solidFill>
+                  <a:srgbClr val="1B1F3B"/>
+                </a:solidFill>
+                <a:latin typeface="Calibri"/>
+              </a:rPr>
+              <a:t>Infraestructura de datos ya preparada: conexión validada con Google Analytics 4 (vía BigQuery) para sumar datos de comportamiento web de la operación propia en próximas iteraciones.</a:t>
+            </a:r>
+          </a:p>
+        </p:txBody>
+      </p:sp>
+      <p:sp>
+        <p:nvSpPr>
+          <p:cNvPr id="25" name="TextBox 24"/>
           <p:cNvSpPr txBox="1"/>
           <p:nvPr/>
         </p:nvSpPr>
@@ -6498,7 +6394,7 @@
           <a:noFill/>
         </p:spPr>
         <p:txBody>
-          <a:bodyPr wrap="square" lIns="0" tIns="0" rIns="0" bIns="0" anchor="t">
+          <a:bodyPr wrap="square" lIns="0" rIns="0" tIns="0" bIns="0" anchor="t">
             <a:spAutoFit/>
           </a:bodyPr>
           <a:lstStyle/>
@@ -6522,7 +6418,7 @@
       </p:sp>
       <p:sp>
         <p:nvSpPr>
-          <p:cNvPr id="22" name="TextBox 21"/>
+          <p:cNvPr id="26" name="TextBox 25"/>
           <p:cNvSpPr txBox="1"/>
           <p:nvPr/>
         </p:nvSpPr>
@@ -6537,7 +6433,7 @@
           <a:noFill/>
         </p:spPr>
         <p:txBody>
-          <a:bodyPr wrap="square" lIns="0" tIns="0" rIns="0" bIns="0" anchor="t">
+          <a:bodyPr wrap="square" lIns="0" rIns="0" tIns="0" bIns="0" anchor="t">
             <a:spAutoFit/>
           </a:bodyPr>
           <a:lstStyle/>
@@ -6568,7 +6464,7 @@
 </file>
 
 <file path=ppt/slides/slide12.xml><?xml version="1.0" encoding="utf-8"?>
-<p:sld xmlns:a="http://schemas.openxmlformats.org/drawingml/2006/main" xmlns:r="http://schemas.openxmlformats.org/officeDocument/2006/relationships" xmlns:p="http://schemas.openxmlformats.org/presentationml/2006/main">
+<p:sld xmlns:a="http://schemas.openxmlformats.org/drawingml/2006/main" xmlns:p="http://schemas.openxmlformats.org/presentationml/2006/main" xmlns:r="http://schemas.openxmlformats.org/officeDocument/2006/relationships">
   <p:cSld>
     <p:spTree>
       <p:nvGrpSpPr>
@@ -6576,14 +6472,7 @@
         <p:cNvGrpSpPr/>
         <p:nvPr/>
       </p:nvGrpSpPr>
-      <p:grpSpPr>
-        <a:xfrm>
-          <a:off x="0" y="0"/>
-          <a:ext cx="0" cy="0"/>
-          <a:chOff x="0" y="0"/>
-          <a:chExt cx="0" cy="0"/>
-        </a:xfrm>
-      </p:grpSpPr>
+      <p:grpSpPr/>
       <p:sp>
         <p:nvSpPr>
           <p:cNvPr id="2" name="Rectangle 1"/>
@@ -6625,7 +6514,6 @@
           <a:lstStyle/>
           <a:p>
             <a:pPr algn="ctr"/>
-            <a:endParaRPr/>
           </a:p>
         </p:txBody>
       </p:sp>
@@ -6670,7 +6558,6 @@
           <a:lstStyle/>
           <a:p>
             <a:pPr algn="ctr"/>
-            <a:endParaRPr/>
           </a:p>
         </p:txBody>
       </p:sp>
@@ -6691,7 +6578,7 @@
           <a:noFill/>
         </p:spPr>
         <p:txBody>
-          <a:bodyPr wrap="square" lIns="0" tIns="0" rIns="0" bIns="0" anchor="t">
+          <a:bodyPr wrap="square" lIns="0" rIns="0" tIns="0" bIns="0" anchor="t">
             <a:spAutoFit/>
           </a:bodyPr>
           <a:lstStyle/>
@@ -6730,7 +6617,7 @@
           <a:noFill/>
         </p:spPr>
         <p:txBody>
-          <a:bodyPr wrap="square" lIns="0" tIns="0" rIns="0" bIns="0" anchor="t">
+          <a:bodyPr wrap="square" lIns="0" rIns="0" tIns="0" bIns="0" anchor="t">
             <a:spAutoFit/>
           </a:bodyPr>
           <a:lstStyle/>
@@ -6769,7 +6656,7 @@
           <a:noFill/>
         </p:spPr>
         <p:txBody>
-          <a:bodyPr wrap="square" lIns="0" tIns="0" rIns="0" bIns="0" anchor="t">
+          <a:bodyPr wrap="square" lIns="0" rIns="0" tIns="0" bIns="0" anchor="t">
             <a:spAutoFit/>
           </a:bodyPr>
           <a:lstStyle/>
@@ -6808,7 +6695,7 @@
           <a:noFill/>
         </p:spPr>
         <p:txBody>
-          <a:bodyPr wrap="square" lIns="0" tIns="0" rIns="0" bIns="0" anchor="t">
+          <a:bodyPr wrap="square" lIns="0" rIns="0" tIns="0" bIns="0" anchor="t">
             <a:spAutoFit/>
           </a:bodyPr>
           <a:lstStyle/>
@@ -6847,7 +6734,7 @@
           <a:noFill/>
         </p:spPr>
         <p:txBody>
-          <a:bodyPr wrap="square" lIns="0" tIns="0" rIns="0" bIns="0" anchor="t">
+          <a:bodyPr wrap="square" lIns="0" rIns="0" tIns="0" bIns="0" anchor="t">
             <a:spAutoFit/>
           </a:bodyPr>
           <a:lstStyle/>
@@ -6878,7 +6765,7 @@
 </file>
 
 <file path=ppt/slides/slide2.xml><?xml version="1.0" encoding="utf-8"?>
-<p:sld xmlns:a="http://schemas.openxmlformats.org/drawingml/2006/main" xmlns:r="http://schemas.openxmlformats.org/officeDocument/2006/relationships" xmlns:p="http://schemas.openxmlformats.org/presentationml/2006/main">
+<p:sld xmlns:a="http://schemas.openxmlformats.org/drawingml/2006/main" xmlns:p="http://schemas.openxmlformats.org/presentationml/2006/main" xmlns:r="http://schemas.openxmlformats.org/officeDocument/2006/relationships">
   <p:cSld>
     <p:spTree>
       <p:nvGrpSpPr>
@@ -6886,14 +6773,7 @@
         <p:cNvGrpSpPr/>
         <p:nvPr/>
       </p:nvGrpSpPr>
-      <p:grpSpPr>
-        <a:xfrm>
-          <a:off x="0" y="0"/>
-          <a:ext cx="0" cy="0"/>
-          <a:chOff x="0" y="0"/>
-          <a:chExt cx="0" cy="0"/>
-        </a:xfrm>
-      </p:grpSpPr>
+      <p:grpSpPr/>
       <p:sp>
         <p:nvSpPr>
           <p:cNvPr id="2" name="Rectangle 1"/>
@@ -6935,7 +6815,6 @@
           <a:lstStyle/>
           <a:p>
             <a:pPr algn="ctr"/>
-            <a:endParaRPr/>
           </a:p>
         </p:txBody>
       </p:sp>
@@ -6956,7 +6835,7 @@
           <a:noFill/>
         </p:spPr>
         <p:txBody>
-          <a:bodyPr wrap="square" lIns="0" tIns="0" rIns="0" bIns="0" anchor="t">
+          <a:bodyPr wrap="square" lIns="0" rIns="0" tIns="0" bIns="0" anchor="t">
             <a:spAutoFit/>
           </a:bodyPr>
           <a:lstStyle/>
@@ -6995,7 +6874,7 @@
           <a:noFill/>
         </p:spPr>
         <p:txBody>
-          <a:bodyPr wrap="square" lIns="0" tIns="0" rIns="0" bIns="0" anchor="t">
+          <a:bodyPr wrap="square" lIns="0" rIns="0" tIns="0" bIns="0" anchor="t">
             <a:spAutoFit/>
           </a:bodyPr>
           <a:lstStyle/>
@@ -7034,7 +6913,7 @@
           <a:noFill/>
         </p:spPr>
         <p:txBody>
-          <a:bodyPr wrap="square" lIns="0" tIns="0" rIns="0" bIns="0" anchor="t">
+          <a:bodyPr wrap="square" lIns="0" rIns="0" tIns="0" bIns="0" anchor="t">
             <a:spAutoFit/>
           </a:bodyPr>
           <a:lstStyle/>
@@ -7073,7 +6952,7 @@
           <a:noFill/>
         </p:spPr>
         <p:txBody>
-          <a:bodyPr wrap="square" lIns="0" tIns="0" rIns="0" bIns="0" anchor="t">
+          <a:bodyPr wrap="square" lIns="0" rIns="0" tIns="0" bIns="0" anchor="t">
             <a:spAutoFit/>
           </a:bodyPr>
           <a:lstStyle/>
@@ -7138,7 +7017,6 @@
           <a:lstStyle/>
           <a:p>
             <a:pPr algn="ctr"/>
-            <a:endParaRPr/>
           </a:p>
         </p:txBody>
       </p:sp>
@@ -7183,7 +7061,6 @@
           <a:lstStyle/>
           <a:p>
             <a:pPr algn="ctr"/>
-            <a:endParaRPr/>
           </a:p>
         </p:txBody>
       </p:sp>
@@ -7204,7 +7081,7 @@
           <a:noFill/>
         </p:spPr>
         <p:txBody>
-          <a:bodyPr wrap="square" lIns="0" tIns="0" rIns="0" bIns="0" anchor="ctr">
+          <a:bodyPr wrap="square" lIns="0" rIns="0" tIns="0" bIns="0" anchor="ctr">
             <a:spAutoFit/>
           </a:bodyPr>
           <a:lstStyle/>
@@ -7243,7 +7120,7 @@
           <a:noFill/>
         </p:spPr>
         <p:txBody>
-          <a:bodyPr wrap="square" lIns="0" tIns="0" rIns="0" bIns="0" anchor="ctr">
+          <a:bodyPr wrap="square" lIns="0" rIns="0" tIns="0" bIns="0" anchor="ctr">
             <a:spAutoFit/>
           </a:bodyPr>
           <a:lstStyle/>
@@ -7282,7 +7159,7 @@
           <a:noFill/>
         </p:spPr>
         <p:txBody>
-          <a:bodyPr wrap="square" lIns="0" tIns="0" rIns="0" bIns="0" anchor="t">
+          <a:bodyPr wrap="square" lIns="0" rIns="0" tIns="0" bIns="0" anchor="t">
             <a:spAutoFit/>
           </a:bodyPr>
           <a:lstStyle/>
@@ -7321,7 +7198,7 @@
           <a:noFill/>
         </p:spPr>
         <p:txBody>
-          <a:bodyPr wrap="square" lIns="0" tIns="0" rIns="0" bIns="0" anchor="t">
+          <a:bodyPr wrap="square" lIns="0" rIns="0" tIns="0" bIns="0" anchor="t">
             <a:spAutoFit/>
           </a:bodyPr>
           <a:lstStyle/>
@@ -7360,7 +7237,7 @@
           <a:noFill/>
         </p:spPr>
         <p:txBody>
-          <a:bodyPr wrap="square" lIns="0" tIns="0" rIns="0" bIns="0" anchor="t">
+          <a:bodyPr wrap="square" lIns="0" rIns="0" tIns="0" bIns="0" anchor="t">
             <a:spAutoFit/>
           </a:bodyPr>
           <a:lstStyle/>
@@ -7399,7 +7276,7 @@
           <a:noFill/>
         </p:spPr>
         <p:txBody>
-          <a:bodyPr wrap="square" lIns="0" tIns="0" rIns="0" bIns="0" anchor="t">
+          <a:bodyPr wrap="square" lIns="0" rIns="0" tIns="0" bIns="0" anchor="t">
             <a:spAutoFit/>
           </a:bodyPr>
           <a:lstStyle/>
@@ -7430,7 +7307,7 @@
 </file>
 
 <file path=ppt/slides/slide3.xml><?xml version="1.0" encoding="utf-8"?>
-<p:sld xmlns:a="http://schemas.openxmlformats.org/drawingml/2006/main" xmlns:r="http://schemas.openxmlformats.org/officeDocument/2006/relationships" xmlns:p="http://schemas.openxmlformats.org/presentationml/2006/main">
+<p:sld xmlns:a="http://schemas.openxmlformats.org/drawingml/2006/main" xmlns:p="http://schemas.openxmlformats.org/presentationml/2006/main" xmlns:r="http://schemas.openxmlformats.org/officeDocument/2006/relationships">
   <p:cSld>
     <p:spTree>
       <p:nvGrpSpPr>
@@ -7438,14 +7315,7 @@
         <p:cNvGrpSpPr/>
         <p:nvPr/>
       </p:nvGrpSpPr>
-      <p:grpSpPr>
-        <a:xfrm>
-          <a:off x="0" y="0"/>
-          <a:ext cx="0" cy="0"/>
-          <a:chOff x="0" y="0"/>
-          <a:chExt cx="0" cy="0"/>
-        </a:xfrm>
-      </p:grpSpPr>
+      <p:grpSpPr/>
       <p:sp>
         <p:nvSpPr>
           <p:cNvPr id="2" name="Rectangle 1"/>
@@ -7487,7 +7357,6 @@
           <a:lstStyle/>
           <a:p>
             <a:pPr algn="ctr"/>
-            <a:endParaRPr/>
           </a:p>
         </p:txBody>
       </p:sp>
@@ -7508,7 +7377,7 @@
           <a:noFill/>
         </p:spPr>
         <p:txBody>
-          <a:bodyPr wrap="square" lIns="0" tIns="0" rIns="0" bIns="0" anchor="t">
+          <a:bodyPr wrap="square" lIns="0" rIns="0" tIns="0" bIns="0" anchor="t">
             <a:spAutoFit/>
           </a:bodyPr>
           <a:lstStyle/>
@@ -7547,7 +7416,7 @@
           <a:noFill/>
         </p:spPr>
         <p:txBody>
-          <a:bodyPr wrap="square" lIns="0" tIns="0" rIns="0" bIns="0" anchor="t">
+          <a:bodyPr wrap="square" lIns="0" rIns="0" tIns="0" bIns="0" anchor="t">
             <a:spAutoFit/>
           </a:bodyPr>
           <a:lstStyle/>
@@ -7586,7 +7455,7 @@
           <a:noFill/>
         </p:spPr>
         <p:txBody>
-          <a:bodyPr wrap="square" lIns="0" tIns="0" rIns="0" bIns="0" anchor="t">
+          <a:bodyPr wrap="square" lIns="0" rIns="0" tIns="0" bIns="0" anchor="t">
             <a:spAutoFit/>
           </a:bodyPr>
           <a:lstStyle/>
@@ -7616,8 +7485,8 @@
         </p:nvSpPr>
         <p:spPr>
           <a:xfrm>
-            <a:off x="640080" y="2057400"/>
-            <a:ext cx="3520440" cy="1783080"/>
+            <a:off x="640080" y="1920240"/>
+            <a:ext cx="3520440" cy="1554480"/>
           </a:xfrm>
           <a:prstGeom prst="roundRect">
             <a:avLst>
@@ -7651,7 +7520,6 @@
           <a:lstStyle/>
           <a:p>
             <a:pPr algn="ctr"/>
-            <a:endParaRPr/>
           </a:p>
         </p:txBody>
       </p:sp>
@@ -7663,16 +7531,16 @@
         </p:nvSpPr>
         <p:spPr>
           <a:xfrm>
-            <a:off x="868680" y="2221992"/>
-            <a:ext cx="3063240" cy="777240"/>
-          </a:xfrm>
-          <a:prstGeom prst="rect">
-            <a:avLst/>
-          </a:prstGeom>
-          <a:noFill/>
-        </p:spPr>
-        <p:txBody>
-          <a:bodyPr wrap="square" lIns="0" tIns="0" rIns="0" bIns="0" anchor="t">
+            <a:off x="868680" y="2057400"/>
+            <a:ext cx="3063240" cy="685800"/>
+          </a:xfrm>
+          <a:prstGeom prst="rect">
+            <a:avLst/>
+          </a:prstGeom>
+          <a:noFill/>
+        </p:spPr>
+        <p:txBody>
+          <a:bodyPr wrap="square" lIns="0" rIns="0" tIns="0" bIns="0" anchor="t">
             <a:spAutoFit/>
           </a:bodyPr>
           <a:lstStyle/>
@@ -7683,7 +7551,7 @@
               </a:lnSpc>
             </a:pPr>
             <a:r>
-              <a:rPr sz="3400" b="1" i="0">
+              <a:rPr sz="3000" b="1" i="0">
                 <a:solidFill>
                   <a:srgbClr val="1E2761"/>
                 </a:solidFill>
@@ -7702,27 +7570,27 @@
         </p:nvSpPr>
         <p:spPr>
           <a:xfrm>
-            <a:off x="868680" y="3017520"/>
-            <a:ext cx="3063240" cy="731520"/>
-          </a:xfrm>
-          <a:prstGeom prst="rect">
-            <a:avLst/>
-          </a:prstGeom>
-          <a:noFill/>
-        </p:spPr>
-        <p:txBody>
-          <a:bodyPr wrap="square" lIns="0" tIns="0" rIns="0" bIns="0" anchor="t">
+            <a:off x="868680" y="2724912"/>
+            <a:ext cx="3063240" cy="685800"/>
+          </a:xfrm>
+          <a:prstGeom prst="rect">
+            <a:avLst/>
+          </a:prstGeom>
+          <a:noFill/>
+        </p:spPr>
+        <p:txBody>
+          <a:bodyPr wrap="square" lIns="0" rIns="0" tIns="0" bIns="0" anchor="t">
             <a:spAutoFit/>
           </a:bodyPr>
           <a:lstStyle/>
           <a:p>
             <a:pPr algn="l">
               <a:lnSpc>
-                <a:spcPct val="115000"/>
-              </a:lnSpc>
-            </a:pPr>
-            <a:r>
-              <a:rPr sz="1250" b="0" i="0">
+                <a:spcPct val="110000"/>
+              </a:lnSpc>
+            </a:pPr>
+            <a:r>
+              <a:rPr sz="1200" b="0" i="0">
                 <a:solidFill>
                   <a:srgbClr val="6B7280"/>
                 </a:solidFill>
@@ -7734,11 +7602,11 @@
           <a:p>
             <a:pPr algn="l">
               <a:lnSpc>
-                <a:spcPct val="115000"/>
-              </a:lnSpc>
-            </a:pPr>
-            <a:r>
-              <a:rPr sz="1250" b="0" i="0">
+                <a:spcPct val="110000"/>
+              </a:lnSpc>
+            </a:pPr>
+            <a:r>
+              <a:rPr sz="1200" b="0" i="0">
                 <a:solidFill>
                   <a:srgbClr val="6B7280"/>
                 </a:solidFill>
@@ -7757,8 +7625,8 @@
         </p:nvSpPr>
         <p:spPr>
           <a:xfrm>
-            <a:off x="4389120" y="2057400"/>
-            <a:ext cx="3520440" cy="1783080"/>
+            <a:off x="4343400" y="1920240"/>
+            <a:ext cx="3520440" cy="1554480"/>
           </a:xfrm>
           <a:prstGeom prst="roundRect">
             <a:avLst>
@@ -7792,7 +7660,6 @@
           <a:lstStyle/>
           <a:p>
             <a:pPr algn="ctr"/>
-            <a:endParaRPr/>
           </a:p>
         </p:txBody>
       </p:sp>
@@ -7804,16 +7671,16 @@
         </p:nvSpPr>
         <p:spPr>
           <a:xfrm>
-            <a:off x="4617720" y="2221992"/>
-            <a:ext cx="3063240" cy="777240"/>
-          </a:xfrm>
-          <a:prstGeom prst="rect">
-            <a:avLst/>
-          </a:prstGeom>
-          <a:noFill/>
-        </p:spPr>
-        <p:txBody>
-          <a:bodyPr wrap="square" lIns="0" tIns="0" rIns="0" bIns="0" anchor="t">
+            <a:off x="4572000" y="2057400"/>
+            <a:ext cx="3063240" cy="685800"/>
+          </a:xfrm>
+          <a:prstGeom prst="rect">
+            <a:avLst/>
+          </a:prstGeom>
+          <a:noFill/>
+        </p:spPr>
+        <p:txBody>
+          <a:bodyPr wrap="square" lIns="0" rIns="0" tIns="0" bIns="0" anchor="t">
             <a:spAutoFit/>
           </a:bodyPr>
           <a:lstStyle/>
@@ -7824,7 +7691,7 @@
               </a:lnSpc>
             </a:pPr>
             <a:r>
-              <a:rPr sz="3400" b="1" i="0">
+              <a:rPr sz="3000" b="1" i="0">
                 <a:solidFill>
                   <a:srgbClr val="1E2761"/>
                 </a:solidFill>
@@ -7843,27 +7710,27 @@
         </p:nvSpPr>
         <p:spPr>
           <a:xfrm>
-            <a:off x="4617720" y="3017520"/>
-            <a:ext cx="3063240" cy="731520"/>
-          </a:xfrm>
-          <a:prstGeom prst="rect">
-            <a:avLst/>
-          </a:prstGeom>
-          <a:noFill/>
-        </p:spPr>
-        <p:txBody>
-          <a:bodyPr wrap="square" lIns="0" tIns="0" rIns="0" bIns="0" anchor="t">
+            <a:off x="4572000" y="2724912"/>
+            <a:ext cx="3063240" cy="685800"/>
+          </a:xfrm>
+          <a:prstGeom prst="rect">
+            <a:avLst/>
+          </a:prstGeom>
+          <a:noFill/>
+        </p:spPr>
+        <p:txBody>
+          <a:bodyPr wrap="square" lIns="0" rIns="0" tIns="0" bIns="0" anchor="t">
             <a:spAutoFit/>
           </a:bodyPr>
           <a:lstStyle/>
           <a:p>
             <a:pPr algn="l">
               <a:lnSpc>
-                <a:spcPct val="115000"/>
-              </a:lnSpc>
-            </a:pPr>
-            <a:r>
-              <a:rPr sz="1250" b="0" i="0">
+                <a:spcPct val="110000"/>
+              </a:lnSpc>
+            </a:pPr>
+            <a:r>
+              <a:rPr sz="1200" b="0" i="0">
                 <a:solidFill>
                   <a:srgbClr val="6B7280"/>
                 </a:solidFill>
@@ -7875,11 +7742,11 @@
           <a:p>
             <a:pPr algn="l">
               <a:lnSpc>
-                <a:spcPct val="115000"/>
-              </a:lnSpc>
-            </a:pPr>
-            <a:r>
-              <a:rPr sz="1250" b="0" i="0">
+                <a:spcPct val="110000"/>
+              </a:lnSpc>
+            </a:pPr>
+            <a:r>
+              <a:rPr sz="1200" b="0" i="0">
                 <a:solidFill>
                   <a:srgbClr val="6B7280"/>
                 </a:solidFill>
@@ -7898,8 +7765,8 @@
         </p:nvSpPr>
         <p:spPr>
           <a:xfrm>
-            <a:off x="8138159" y="2057400"/>
-            <a:ext cx="3520440" cy="1783080"/>
+            <a:off x="8046719" y="1920240"/>
+            <a:ext cx="3520440" cy="1554480"/>
           </a:xfrm>
           <a:prstGeom prst="roundRect">
             <a:avLst>
@@ -7933,7 +7800,6 @@
           <a:lstStyle/>
           <a:p>
             <a:pPr algn="ctr"/>
-            <a:endParaRPr/>
           </a:p>
         </p:txBody>
       </p:sp>
@@ -7945,16 +7811,16 @@
         </p:nvSpPr>
         <p:spPr>
           <a:xfrm>
-            <a:off x="8366759" y="2221992"/>
-            <a:ext cx="3063240" cy="777240"/>
-          </a:xfrm>
-          <a:prstGeom prst="rect">
-            <a:avLst/>
-          </a:prstGeom>
-          <a:noFill/>
-        </p:spPr>
-        <p:txBody>
-          <a:bodyPr wrap="square" lIns="0" tIns="0" rIns="0" bIns="0" anchor="t">
+            <a:off x="8275319" y="2057400"/>
+            <a:ext cx="3063240" cy="685800"/>
+          </a:xfrm>
+          <a:prstGeom prst="rect">
+            <a:avLst/>
+          </a:prstGeom>
+          <a:noFill/>
+        </p:spPr>
+        <p:txBody>
+          <a:bodyPr wrap="square" lIns="0" rIns="0" tIns="0" bIns="0" anchor="t">
             <a:spAutoFit/>
           </a:bodyPr>
           <a:lstStyle/>
@@ -7965,7 +7831,7 @@
               </a:lnSpc>
             </a:pPr>
             <a:r>
-              <a:rPr sz="3400" b="1" i="0">
+              <a:rPr sz="3000" b="1" i="0">
                 <a:solidFill>
                   <a:srgbClr val="1E2761"/>
                 </a:solidFill>
@@ -7984,27 +7850,27 @@
         </p:nvSpPr>
         <p:spPr>
           <a:xfrm>
-            <a:off x="8366759" y="3017520"/>
-            <a:ext cx="3063240" cy="731520"/>
-          </a:xfrm>
-          <a:prstGeom prst="rect">
-            <a:avLst/>
-          </a:prstGeom>
-          <a:noFill/>
-        </p:spPr>
-        <p:txBody>
-          <a:bodyPr wrap="square" lIns="0" tIns="0" rIns="0" bIns="0" anchor="t">
+            <a:off x="8275319" y="2724912"/>
+            <a:ext cx="3063240" cy="685800"/>
+          </a:xfrm>
+          <a:prstGeom prst="rect">
+            <a:avLst/>
+          </a:prstGeom>
+          <a:noFill/>
+        </p:spPr>
+        <p:txBody>
+          <a:bodyPr wrap="square" lIns="0" rIns="0" tIns="0" bIns="0" anchor="t">
             <a:spAutoFit/>
           </a:bodyPr>
           <a:lstStyle/>
           <a:p>
             <a:pPr algn="l">
               <a:lnSpc>
-                <a:spcPct val="115000"/>
-              </a:lnSpc>
-            </a:pPr>
-            <a:r>
-              <a:rPr sz="1250" b="0" i="0">
+                <a:spcPct val="110000"/>
+              </a:lnSpc>
+            </a:pPr>
+            <a:r>
+              <a:rPr sz="1200" b="0" i="0">
                 <a:solidFill>
                   <a:srgbClr val="6B7280"/>
                 </a:solidFill>
@@ -8016,11 +7882,11 @@
           <a:p>
             <a:pPr algn="l">
               <a:lnSpc>
-                <a:spcPct val="115000"/>
-              </a:lnSpc>
-            </a:pPr>
-            <a:r>
-              <a:rPr sz="1250" b="0" i="0">
+                <a:spcPct val="110000"/>
+              </a:lnSpc>
+            </a:pPr>
+            <a:r>
+              <a:rPr sz="1200" b="0" i="0">
                 <a:solidFill>
                   <a:srgbClr val="6B7280"/>
                 </a:solidFill>
@@ -8039,8 +7905,8 @@
         </p:nvSpPr>
         <p:spPr>
           <a:xfrm>
-            <a:off x="640080" y="4069080"/>
-            <a:ext cx="3520440" cy="1783080"/>
+            <a:off x="640080" y="3657600"/>
+            <a:ext cx="3520440" cy="1554480"/>
           </a:xfrm>
           <a:prstGeom prst="roundRect">
             <a:avLst>
@@ -8074,7 +7940,6 @@
           <a:lstStyle/>
           <a:p>
             <a:pPr algn="ctr"/>
-            <a:endParaRPr/>
           </a:p>
         </p:txBody>
       </p:sp>
@@ -8086,16 +7951,16 @@
         </p:nvSpPr>
         <p:spPr>
           <a:xfrm>
-            <a:off x="868680" y="4233672"/>
-            <a:ext cx="3063240" cy="777240"/>
-          </a:xfrm>
-          <a:prstGeom prst="rect">
-            <a:avLst/>
-          </a:prstGeom>
-          <a:noFill/>
-        </p:spPr>
-        <p:txBody>
-          <a:bodyPr wrap="square" lIns="0" tIns="0" rIns="0" bIns="0" anchor="t">
+            <a:off x="868680" y="3794760"/>
+            <a:ext cx="3063240" cy="685800"/>
+          </a:xfrm>
+          <a:prstGeom prst="rect">
+            <a:avLst/>
+          </a:prstGeom>
+          <a:noFill/>
+        </p:spPr>
+        <p:txBody>
+          <a:bodyPr wrap="square" lIns="0" rIns="0" tIns="0" bIns="0" anchor="t">
             <a:spAutoFit/>
           </a:bodyPr>
           <a:lstStyle/>
@@ -8106,7 +7971,7 @@
               </a:lnSpc>
             </a:pPr>
             <a:r>
-              <a:rPr sz="3400" b="1" i="0">
+              <a:rPr sz="3000" b="1" i="0">
                 <a:solidFill>
                   <a:srgbClr val="1E2761"/>
                 </a:solidFill>
@@ -8125,27 +7990,27 @@
         </p:nvSpPr>
         <p:spPr>
           <a:xfrm>
-            <a:off x="868680" y="5029200"/>
-            <a:ext cx="3063240" cy="731520"/>
-          </a:xfrm>
-          <a:prstGeom prst="rect">
-            <a:avLst/>
-          </a:prstGeom>
-          <a:noFill/>
-        </p:spPr>
-        <p:txBody>
-          <a:bodyPr wrap="square" lIns="0" tIns="0" rIns="0" bIns="0" anchor="t">
+            <a:off x="868680" y="4462272"/>
+            <a:ext cx="3063240" cy="685800"/>
+          </a:xfrm>
+          <a:prstGeom prst="rect">
+            <a:avLst/>
+          </a:prstGeom>
+          <a:noFill/>
+        </p:spPr>
+        <p:txBody>
+          <a:bodyPr wrap="square" lIns="0" rIns="0" tIns="0" bIns="0" anchor="t">
             <a:spAutoFit/>
           </a:bodyPr>
           <a:lstStyle/>
           <a:p>
             <a:pPr algn="l">
               <a:lnSpc>
-                <a:spcPct val="115000"/>
-              </a:lnSpc>
-            </a:pPr>
-            <a:r>
-              <a:rPr sz="1250" b="0" i="0">
+                <a:spcPct val="110000"/>
+              </a:lnSpc>
+            </a:pPr>
+            <a:r>
+              <a:rPr sz="1200" b="0" i="0">
                 <a:solidFill>
                   <a:srgbClr val="6B7280"/>
                 </a:solidFill>
@@ -8157,11 +8022,11 @@
           <a:p>
             <a:pPr algn="l">
               <a:lnSpc>
-                <a:spcPct val="115000"/>
-              </a:lnSpc>
-            </a:pPr>
-            <a:r>
-              <a:rPr sz="1250" b="0" i="0">
+                <a:spcPct val="110000"/>
+              </a:lnSpc>
+            </a:pPr>
+            <a:r>
+              <a:rPr sz="1200" b="0" i="0">
                 <a:solidFill>
                   <a:srgbClr val="6B7280"/>
                 </a:solidFill>
@@ -8180,8 +8045,8 @@
         </p:nvSpPr>
         <p:spPr>
           <a:xfrm>
-            <a:off x="4389120" y="4069080"/>
-            <a:ext cx="3520440" cy="1783080"/>
+            <a:off x="4343400" y="3657600"/>
+            <a:ext cx="3520440" cy="1554480"/>
           </a:xfrm>
           <a:prstGeom prst="roundRect">
             <a:avLst>
@@ -8215,7 +8080,6 @@
           <a:lstStyle/>
           <a:p>
             <a:pPr algn="ctr"/>
-            <a:endParaRPr/>
           </a:p>
         </p:txBody>
       </p:sp>
@@ -8227,16 +8091,16 @@
         </p:nvSpPr>
         <p:spPr>
           <a:xfrm>
-            <a:off x="4617720" y="4233672"/>
-            <a:ext cx="3063240" cy="777240"/>
-          </a:xfrm>
-          <a:prstGeom prst="rect">
-            <a:avLst/>
-          </a:prstGeom>
-          <a:noFill/>
-        </p:spPr>
-        <p:txBody>
-          <a:bodyPr wrap="square" lIns="0" tIns="0" rIns="0" bIns="0" anchor="t">
+            <a:off x="4572000" y="3794760"/>
+            <a:ext cx="3063240" cy="685800"/>
+          </a:xfrm>
+          <a:prstGeom prst="rect">
+            <a:avLst/>
+          </a:prstGeom>
+          <a:noFill/>
+        </p:spPr>
+        <p:txBody>
+          <a:bodyPr wrap="square" lIns="0" rIns="0" tIns="0" bIns="0" anchor="t">
             <a:spAutoFit/>
           </a:bodyPr>
           <a:lstStyle/>
@@ -8247,7 +8111,7 @@
               </a:lnSpc>
             </a:pPr>
             <a:r>
-              <a:rPr sz="3400" b="1" i="0">
+              <a:rPr sz="3000" b="1" i="0">
                 <a:solidFill>
                   <a:srgbClr val="1E2761"/>
                 </a:solidFill>
@@ -8266,27 +8130,27 @@
         </p:nvSpPr>
         <p:spPr>
           <a:xfrm>
-            <a:off x="4617720" y="5029200"/>
-            <a:ext cx="3063240" cy="731520"/>
-          </a:xfrm>
-          <a:prstGeom prst="rect">
-            <a:avLst/>
-          </a:prstGeom>
-          <a:noFill/>
-        </p:spPr>
-        <p:txBody>
-          <a:bodyPr wrap="square" lIns="0" tIns="0" rIns="0" bIns="0" anchor="t">
+            <a:off x="4572000" y="4462272"/>
+            <a:ext cx="3063240" cy="685800"/>
+          </a:xfrm>
+          <a:prstGeom prst="rect">
+            <a:avLst/>
+          </a:prstGeom>
+          <a:noFill/>
+        </p:spPr>
+        <p:txBody>
+          <a:bodyPr wrap="square" lIns="0" rIns="0" tIns="0" bIns="0" anchor="t">
             <a:spAutoFit/>
           </a:bodyPr>
           <a:lstStyle/>
           <a:p>
             <a:pPr algn="l">
               <a:lnSpc>
-                <a:spcPct val="115000"/>
-              </a:lnSpc>
-            </a:pPr>
-            <a:r>
-              <a:rPr sz="1250" b="0" i="0">
+                <a:spcPct val="110000"/>
+              </a:lnSpc>
+            </a:pPr>
+            <a:r>
+              <a:rPr sz="1200" b="0" i="0">
                 <a:solidFill>
                   <a:srgbClr val="6B7280"/>
                 </a:solidFill>
@@ -8298,11 +8162,11 @@
           <a:p>
             <a:pPr algn="l">
               <a:lnSpc>
-                <a:spcPct val="115000"/>
-              </a:lnSpc>
-            </a:pPr>
-            <a:r>
-              <a:rPr sz="1250" b="0" i="0">
+                <a:spcPct val="110000"/>
+              </a:lnSpc>
+            </a:pPr>
+            <a:r>
+              <a:rPr sz="1200" b="0" i="0">
                 <a:solidFill>
                   <a:srgbClr val="6B7280"/>
                 </a:solidFill>
@@ -8321,8 +8185,8 @@
         </p:nvSpPr>
         <p:spPr>
           <a:xfrm>
-            <a:off x="8138159" y="4069080"/>
-            <a:ext cx="3520440" cy="1783080"/>
+            <a:off x="8046719" y="3657600"/>
+            <a:ext cx="3520440" cy="1554480"/>
           </a:xfrm>
           <a:prstGeom prst="roundRect">
             <a:avLst>
@@ -8356,7 +8220,6 @@
           <a:lstStyle/>
           <a:p>
             <a:pPr algn="ctr"/>
-            <a:endParaRPr/>
           </a:p>
         </p:txBody>
       </p:sp>
@@ -8368,16 +8231,16 @@
         </p:nvSpPr>
         <p:spPr>
           <a:xfrm>
-            <a:off x="8366759" y="4233672"/>
-            <a:ext cx="3063240" cy="777240"/>
-          </a:xfrm>
-          <a:prstGeom prst="rect">
-            <a:avLst/>
-          </a:prstGeom>
-          <a:noFill/>
-        </p:spPr>
-        <p:txBody>
-          <a:bodyPr wrap="square" lIns="0" tIns="0" rIns="0" bIns="0" anchor="t">
+            <a:off x="8275319" y="3794760"/>
+            <a:ext cx="3063240" cy="685800"/>
+          </a:xfrm>
+          <a:prstGeom prst="rect">
+            <a:avLst/>
+          </a:prstGeom>
+          <a:noFill/>
+        </p:spPr>
+        <p:txBody>
+          <a:bodyPr wrap="square" lIns="0" rIns="0" tIns="0" bIns="0" anchor="t">
             <a:spAutoFit/>
           </a:bodyPr>
           <a:lstStyle/>
@@ -8388,7 +8251,7 @@
               </a:lnSpc>
             </a:pPr>
             <a:r>
-              <a:rPr sz="3400" b="1" i="0">
+              <a:rPr sz="3000" b="1" i="0">
                 <a:solidFill>
                   <a:srgbClr val="1E2761"/>
                 </a:solidFill>
@@ -8407,27 +8270,27 @@
         </p:nvSpPr>
         <p:spPr>
           <a:xfrm>
-            <a:off x="8366759" y="5029200"/>
-            <a:ext cx="3063240" cy="731520"/>
-          </a:xfrm>
-          <a:prstGeom prst="rect">
-            <a:avLst/>
-          </a:prstGeom>
-          <a:noFill/>
-        </p:spPr>
-        <p:txBody>
-          <a:bodyPr wrap="square" lIns="0" tIns="0" rIns="0" bIns="0" anchor="t">
+            <a:off x="8275319" y="4462272"/>
+            <a:ext cx="3063240" cy="685800"/>
+          </a:xfrm>
+          <a:prstGeom prst="rect">
+            <a:avLst/>
+          </a:prstGeom>
+          <a:noFill/>
+        </p:spPr>
+        <p:txBody>
+          <a:bodyPr wrap="square" lIns="0" rIns="0" tIns="0" bIns="0" anchor="t">
             <a:spAutoFit/>
           </a:bodyPr>
           <a:lstStyle/>
           <a:p>
             <a:pPr algn="l">
               <a:lnSpc>
-                <a:spcPct val="115000"/>
-              </a:lnSpc>
-            </a:pPr>
-            <a:r>
-              <a:rPr sz="1250" b="0" i="0">
+                <a:spcPct val="110000"/>
+              </a:lnSpc>
+            </a:pPr>
+            <a:r>
+              <a:rPr sz="1200" b="0" i="0">
                 <a:solidFill>
                   <a:srgbClr val="6B7280"/>
                 </a:solidFill>
@@ -8439,11 +8302,11 @@
           <a:p>
             <a:pPr algn="l">
               <a:lnSpc>
-                <a:spcPct val="115000"/>
-              </a:lnSpc>
-            </a:pPr>
-            <a:r>
-              <a:rPr sz="1250" b="0" i="0">
+                <a:spcPct val="110000"/>
+              </a:lnSpc>
+            </a:pPr>
+            <a:r>
+              <a:rPr sz="1200" b="0" i="0">
                 <a:solidFill>
                   <a:srgbClr val="6B7280"/>
                 </a:solidFill>
@@ -8456,7 +8319,390 @@
       </p:sp>
       <p:sp>
         <p:nvSpPr>
-          <p:cNvPr id="24" name="TextBox 23"/>
+          <p:cNvPr id="24" name="Rounded Rectangle 23"/>
+          <p:cNvSpPr/>
+          <p:nvPr/>
+        </p:nvSpPr>
+        <p:spPr>
+          <a:xfrm>
+            <a:off x="640080" y="5349240"/>
+            <a:ext cx="10789920" cy="777240"/>
+          </a:xfrm>
+          <a:prstGeom prst="roundRect">
+            <a:avLst>
+              <a:gd name="adj" fmla="val 8000"/>
+            </a:avLst>
+          </a:prstGeom>
+          <a:solidFill>
+            <a:srgbClr val="1E2761"/>
+          </a:solidFill>
+          <a:ln>
+            <a:noFill/>
+          </a:ln>
+          <a:effectLst/>
+        </p:spPr>
+        <p:style>
+          <a:lnRef idx="1">
+            <a:schemeClr val="accent1"/>
+          </a:lnRef>
+          <a:fillRef idx="3">
+            <a:schemeClr val="accent1"/>
+          </a:fillRef>
+          <a:effectRef idx="2">
+            <a:schemeClr val="accent1"/>
+          </a:effectRef>
+          <a:fontRef idx="minor">
+            <a:schemeClr val="lt1"/>
+          </a:fontRef>
+        </p:style>
+        <p:txBody>
+          <a:bodyPr rtlCol="0" anchor="ctr"/>
+          <a:lstStyle/>
+          <a:p>
+            <a:pPr algn="ctr"/>
+          </a:p>
+        </p:txBody>
+      </p:sp>
+      <p:sp>
+        <p:nvSpPr>
+          <p:cNvPr id="25" name="TextBox 24"/>
+          <p:cNvSpPr txBox="1"/>
+          <p:nvPr/>
+        </p:nvSpPr>
+        <p:spPr>
+          <a:xfrm>
+            <a:off x="914400" y="5477256"/>
+            <a:ext cx="2103120" cy="521207"/>
+          </a:xfrm>
+          <a:prstGeom prst="rect">
+            <a:avLst/>
+          </a:prstGeom>
+          <a:noFill/>
+        </p:spPr>
+        <p:txBody>
+          <a:bodyPr wrap="square" lIns="0" rIns="0" tIns="0" bIns="0" anchor="ctr">
+            <a:spAutoFit/>
+          </a:bodyPr>
+          <a:lstStyle/>
+          <a:p>
+            <a:pPr algn="l">
+              <a:lnSpc>
+                <a:spcPct val="105000"/>
+              </a:lnSpc>
+            </a:pPr>
+            <a:r>
+              <a:rPr sz="1100" b="1" i="0">
+                <a:solidFill>
+                  <a:srgbClr val="C9A227"/>
+                </a:solidFill>
+                <a:latin typeface="Calibri"/>
+              </a:rPr>
+              <a:t>TIPOS DE</a:t>
+            </a:r>
+          </a:p>
+          <a:p>
+            <a:pPr algn="l">
+              <a:lnSpc>
+                <a:spcPct val="105000"/>
+              </a:lnSpc>
+            </a:pPr>
+            <a:r>
+              <a:rPr sz="1100" b="1" i="0">
+                <a:solidFill>
+                  <a:srgbClr val="C9A227"/>
+                </a:solidFill>
+                <a:latin typeface="Calibri"/>
+              </a:rPr>
+              <a:t>VARIABLE</a:t>
+            </a:r>
+          </a:p>
+        </p:txBody>
+      </p:sp>
+      <p:sp>
+        <p:nvSpPr>
+          <p:cNvPr id="26" name="TextBox 25"/>
+          <p:cNvSpPr txBox="1"/>
+          <p:nvPr/>
+        </p:nvSpPr>
+        <p:spPr>
+          <a:xfrm>
+            <a:off x="3246120" y="5440680"/>
+            <a:ext cx="685800" cy="594360"/>
+          </a:xfrm>
+          <a:prstGeom prst="rect">
+            <a:avLst/>
+          </a:prstGeom>
+          <a:noFill/>
+        </p:spPr>
+        <p:txBody>
+          <a:bodyPr wrap="square" lIns="0" rIns="0" tIns="0" bIns="0" anchor="ctr">
+            <a:spAutoFit/>
+          </a:bodyPr>
+          <a:lstStyle/>
+          <a:p>
+            <a:pPr algn="l">
+              <a:lnSpc>
+                <a:spcPct val="100000"/>
+              </a:lnSpc>
+            </a:pPr>
+            <a:r>
+              <a:rPr sz="2200" b="1" i="0">
+                <a:solidFill>
+                  <a:srgbClr val="FFFFFF"/>
+                </a:solidFill>
+                <a:latin typeface="Cambria"/>
+              </a:rPr>
+              <a:t>19</a:t>
+            </a:r>
+          </a:p>
+        </p:txBody>
+      </p:sp>
+      <p:sp>
+        <p:nvSpPr>
+          <p:cNvPr id="27" name="TextBox 26"/>
+          <p:cNvSpPr txBox="1"/>
+          <p:nvPr/>
+        </p:nvSpPr>
+        <p:spPr>
+          <a:xfrm>
+            <a:off x="3931920" y="5440680"/>
+            <a:ext cx="1965960" cy="594360"/>
+          </a:xfrm>
+          <a:prstGeom prst="rect">
+            <a:avLst/>
+          </a:prstGeom>
+          <a:noFill/>
+        </p:spPr>
+        <p:txBody>
+          <a:bodyPr wrap="square" lIns="0" rIns="0" tIns="0" bIns="0" anchor="ctr">
+            <a:spAutoFit/>
+          </a:bodyPr>
+          <a:lstStyle/>
+          <a:p>
+            <a:pPr algn="l">
+              <a:lnSpc>
+                <a:spcPct val="110000"/>
+              </a:lnSpc>
+            </a:pPr>
+            <a:r>
+              <a:rPr sz="1050" b="0" i="0">
+                <a:solidFill>
+                  <a:srgbClr val="CADCFC"/>
+                </a:solidFill>
+                <a:latin typeface="Calibri"/>
+              </a:rPr>
+              <a:t>numéricas</a:t>
+            </a:r>
+          </a:p>
+          <a:p>
+            <a:pPr algn="l">
+              <a:lnSpc>
+                <a:spcPct val="110000"/>
+              </a:lnSpc>
+            </a:pPr>
+            <a:r>
+              <a:rPr sz="1050" b="0" i="0">
+                <a:solidFill>
+                  <a:srgbClr val="CADCFC"/>
+                </a:solidFill>
+                <a:latin typeface="Calibri"/>
+              </a:rPr>
+              <a:t>(precio, ocupación, reviews…)</a:t>
+            </a:r>
+          </a:p>
+        </p:txBody>
+      </p:sp>
+      <p:sp>
+        <p:nvSpPr>
+          <p:cNvPr id="28" name="TextBox 27"/>
+          <p:cNvSpPr txBox="1"/>
+          <p:nvPr/>
+        </p:nvSpPr>
+        <p:spPr>
+          <a:xfrm>
+            <a:off x="6035040" y="5440680"/>
+            <a:ext cx="685800" cy="594360"/>
+          </a:xfrm>
+          <a:prstGeom prst="rect">
+            <a:avLst/>
+          </a:prstGeom>
+          <a:noFill/>
+        </p:spPr>
+        <p:txBody>
+          <a:bodyPr wrap="square" lIns="0" rIns="0" tIns="0" bIns="0" anchor="ctr">
+            <a:spAutoFit/>
+          </a:bodyPr>
+          <a:lstStyle/>
+          <a:p>
+            <a:pPr algn="l">
+              <a:lnSpc>
+                <a:spcPct val="100000"/>
+              </a:lnSpc>
+            </a:pPr>
+            <a:r>
+              <a:rPr sz="2200" b="1" i="0">
+                <a:solidFill>
+                  <a:srgbClr val="FFFFFF"/>
+                </a:solidFill>
+                <a:latin typeface="Cambria"/>
+              </a:rPr>
+              <a:t>4</a:t>
+            </a:r>
+          </a:p>
+        </p:txBody>
+      </p:sp>
+      <p:sp>
+        <p:nvSpPr>
+          <p:cNvPr id="29" name="TextBox 28"/>
+          <p:cNvSpPr txBox="1"/>
+          <p:nvPr/>
+        </p:nvSpPr>
+        <p:spPr>
+          <a:xfrm>
+            <a:off x="6720840" y="5440680"/>
+            <a:ext cx="1965960" cy="594360"/>
+          </a:xfrm>
+          <a:prstGeom prst="rect">
+            <a:avLst/>
+          </a:prstGeom>
+          <a:noFill/>
+        </p:spPr>
+        <p:txBody>
+          <a:bodyPr wrap="square" lIns="0" rIns="0" tIns="0" bIns="0" anchor="ctr">
+            <a:spAutoFit/>
+          </a:bodyPr>
+          <a:lstStyle/>
+          <a:p>
+            <a:pPr algn="l">
+              <a:lnSpc>
+                <a:spcPct val="110000"/>
+              </a:lnSpc>
+            </a:pPr>
+            <a:r>
+              <a:rPr sz="1050" b="0" i="0">
+                <a:solidFill>
+                  <a:srgbClr val="CADCFC"/>
+                </a:solidFill>
+                <a:latin typeface="Calibri"/>
+              </a:rPr>
+              <a:t>categóricas</a:t>
+            </a:r>
+          </a:p>
+          <a:p>
+            <a:pPr algn="l">
+              <a:lnSpc>
+                <a:spcPct val="110000"/>
+              </a:lnSpc>
+            </a:pPr>
+            <a:r>
+              <a:rPr sz="1050" b="0" i="0">
+                <a:solidFill>
+                  <a:srgbClr val="CADCFC"/>
+                </a:solidFill>
+                <a:latin typeface="Calibri"/>
+              </a:rPr>
+              <a:t>(barrio, tipo de propiedad…)</a:t>
+            </a:r>
+          </a:p>
+        </p:txBody>
+      </p:sp>
+      <p:sp>
+        <p:nvSpPr>
+          <p:cNvPr id="30" name="TextBox 29"/>
+          <p:cNvSpPr txBox="1"/>
+          <p:nvPr/>
+        </p:nvSpPr>
+        <p:spPr>
+          <a:xfrm>
+            <a:off x="8823959" y="5440680"/>
+            <a:ext cx="685800" cy="594360"/>
+          </a:xfrm>
+          <a:prstGeom prst="rect">
+            <a:avLst/>
+          </a:prstGeom>
+          <a:noFill/>
+        </p:spPr>
+        <p:txBody>
+          <a:bodyPr wrap="square" lIns="0" rIns="0" tIns="0" bIns="0" anchor="ctr">
+            <a:spAutoFit/>
+          </a:bodyPr>
+          <a:lstStyle/>
+          <a:p>
+            <a:pPr algn="l">
+              <a:lnSpc>
+                <a:spcPct val="100000"/>
+              </a:lnSpc>
+            </a:pPr>
+            <a:r>
+              <a:rPr sz="2200" b="1" i="0">
+                <a:solidFill>
+                  <a:srgbClr val="FFFFFF"/>
+                </a:solidFill>
+                <a:latin typeface="Cambria"/>
+              </a:rPr>
+              <a:t>8</a:t>
+            </a:r>
+          </a:p>
+        </p:txBody>
+      </p:sp>
+      <p:sp>
+        <p:nvSpPr>
+          <p:cNvPr id="31" name="TextBox 30"/>
+          <p:cNvSpPr txBox="1"/>
+          <p:nvPr/>
+        </p:nvSpPr>
+        <p:spPr>
+          <a:xfrm>
+            <a:off x="9509759" y="5440680"/>
+            <a:ext cx="1965960" cy="594360"/>
+          </a:xfrm>
+          <a:prstGeom prst="rect">
+            <a:avLst/>
+          </a:prstGeom>
+          <a:noFill/>
+        </p:spPr>
+        <p:txBody>
+          <a:bodyPr wrap="square" lIns="0" rIns="0" tIns="0" bIns="0" anchor="ctr">
+            <a:spAutoFit/>
+          </a:bodyPr>
+          <a:lstStyle/>
+          <a:p>
+            <a:pPr algn="l">
+              <a:lnSpc>
+                <a:spcPct val="110000"/>
+              </a:lnSpc>
+            </a:pPr>
+            <a:r>
+              <a:rPr sz="1050" b="0" i="0">
+                <a:solidFill>
+                  <a:srgbClr val="CADCFC"/>
+                </a:solidFill>
+                <a:latin typeface="Calibri"/>
+              </a:rPr>
+              <a:t>binarias</a:t>
+            </a:r>
+          </a:p>
+          <a:p>
+            <a:pPr algn="l">
+              <a:lnSpc>
+                <a:spcPct val="110000"/>
+              </a:lnSpc>
+            </a:pPr>
+            <a:r>
+              <a:rPr sz="1050" b="0" i="0">
+                <a:solidFill>
+                  <a:srgbClr val="CADCFC"/>
+                </a:solidFill>
+                <a:latin typeface="Calibri"/>
+              </a:rPr>
+              <a:t>(amenities: sí / no)</a:t>
+            </a:r>
+          </a:p>
+        </p:txBody>
+      </p:sp>
+      <p:sp>
+        <p:nvSpPr>
+          <p:cNvPr id="32" name="TextBox 31"/>
           <p:cNvSpPr txBox="1"/>
           <p:nvPr/>
         </p:nvSpPr>
@@ -8471,7 +8717,7 @@
           <a:noFill/>
         </p:spPr>
         <p:txBody>
-          <a:bodyPr wrap="square" lIns="0" tIns="0" rIns="0" bIns="0" anchor="t">
+          <a:bodyPr wrap="square" lIns="0" rIns="0" tIns="0" bIns="0" anchor="t">
             <a:spAutoFit/>
           </a:bodyPr>
           <a:lstStyle/>
@@ -8495,7 +8741,7 @@
       </p:sp>
       <p:sp>
         <p:nvSpPr>
-          <p:cNvPr id="25" name="TextBox 24"/>
+          <p:cNvPr id="33" name="TextBox 32"/>
           <p:cNvSpPr txBox="1"/>
           <p:nvPr/>
         </p:nvSpPr>
@@ -8510,7 +8756,7 @@
           <a:noFill/>
         </p:spPr>
         <p:txBody>
-          <a:bodyPr wrap="square" lIns="0" tIns="0" rIns="0" bIns="0" anchor="t">
+          <a:bodyPr wrap="square" lIns="0" rIns="0" tIns="0" bIns="0" anchor="t">
             <a:spAutoFit/>
           </a:bodyPr>
           <a:lstStyle/>
@@ -8541,7 +8787,7 @@
 </file>
 
 <file path=ppt/slides/slide4.xml><?xml version="1.0" encoding="utf-8"?>
-<p:sld xmlns:a="http://schemas.openxmlformats.org/drawingml/2006/main" xmlns:r="http://schemas.openxmlformats.org/officeDocument/2006/relationships" xmlns:p="http://schemas.openxmlformats.org/presentationml/2006/main">
+<p:sld xmlns:a="http://schemas.openxmlformats.org/drawingml/2006/main" xmlns:p="http://schemas.openxmlformats.org/presentationml/2006/main" xmlns:r="http://schemas.openxmlformats.org/officeDocument/2006/relationships">
   <p:cSld>
     <p:spTree>
       <p:nvGrpSpPr>
@@ -8549,14 +8795,7 @@
         <p:cNvGrpSpPr/>
         <p:nvPr/>
       </p:nvGrpSpPr>
-      <p:grpSpPr>
-        <a:xfrm>
-          <a:off x="0" y="0"/>
-          <a:ext cx="0" cy="0"/>
-          <a:chOff x="0" y="0"/>
-          <a:chExt cx="0" cy="0"/>
-        </a:xfrm>
-      </p:grpSpPr>
+      <p:grpSpPr/>
       <p:sp>
         <p:nvSpPr>
           <p:cNvPr id="2" name="Rectangle 1"/>
@@ -8598,7 +8837,6 @@
           <a:lstStyle/>
           <a:p>
             <a:pPr algn="ctr"/>
-            <a:endParaRPr/>
           </a:p>
         </p:txBody>
       </p:sp>
@@ -8619,7 +8857,7 @@
           <a:noFill/>
         </p:spPr>
         <p:txBody>
-          <a:bodyPr wrap="square" lIns="0" tIns="0" rIns="0" bIns="0" anchor="t">
+          <a:bodyPr wrap="square" lIns="0" rIns="0" tIns="0" bIns="0" anchor="t">
             <a:spAutoFit/>
           </a:bodyPr>
           <a:lstStyle/>
@@ -8658,7 +8896,7 @@
           <a:noFill/>
         </p:spPr>
         <p:txBody>
-          <a:bodyPr wrap="square" lIns="0" tIns="0" rIns="0" bIns="0" anchor="t">
+          <a:bodyPr wrap="square" lIns="0" rIns="0" tIns="0" bIns="0" anchor="t">
             <a:spAutoFit/>
           </a:bodyPr>
           <a:lstStyle/>
@@ -8723,7 +8961,6 @@
           <a:lstStyle/>
           <a:p>
             <a:pPr algn="ctr"/>
-            <a:endParaRPr/>
           </a:p>
         </p:txBody>
       </p:sp>
@@ -8768,7 +9005,6 @@
           <a:lstStyle/>
           <a:p>
             <a:pPr algn="ctr"/>
-            <a:endParaRPr/>
           </a:p>
         </p:txBody>
       </p:sp>
@@ -8789,7 +9025,7 @@
           <a:noFill/>
         </p:spPr>
         <p:txBody>
-          <a:bodyPr wrap="square" lIns="0" tIns="0" rIns="0" bIns="0" anchor="ctr">
+          <a:bodyPr wrap="square" lIns="0" rIns="0" tIns="0" bIns="0" anchor="ctr">
             <a:spAutoFit/>
           </a:bodyPr>
           <a:lstStyle/>
@@ -8828,7 +9064,7 @@
           <a:noFill/>
         </p:spPr>
         <p:txBody>
-          <a:bodyPr wrap="square" lIns="0" tIns="0" rIns="0" bIns="0" anchor="t">
+          <a:bodyPr wrap="square" lIns="0" rIns="0" tIns="0" bIns="0" anchor="t">
             <a:spAutoFit/>
           </a:bodyPr>
           <a:lstStyle/>
@@ -8867,7 +9103,7 @@
           <a:noFill/>
         </p:spPr>
         <p:txBody>
-          <a:bodyPr wrap="square" lIns="0" tIns="0" rIns="0" bIns="0" anchor="t">
+          <a:bodyPr wrap="square" lIns="0" rIns="0" tIns="0" bIns="0" anchor="t">
             <a:spAutoFit/>
           </a:bodyPr>
           <a:lstStyle/>
@@ -8932,7 +9168,6 @@
           <a:lstStyle/>
           <a:p>
             <a:pPr algn="ctr"/>
-            <a:endParaRPr/>
           </a:p>
         </p:txBody>
       </p:sp>
@@ -8977,7 +9212,6 @@
           <a:lstStyle/>
           <a:p>
             <a:pPr algn="ctr"/>
-            <a:endParaRPr/>
           </a:p>
         </p:txBody>
       </p:sp>
@@ -8998,7 +9232,7 @@
           <a:noFill/>
         </p:spPr>
         <p:txBody>
-          <a:bodyPr wrap="square" lIns="0" tIns="0" rIns="0" bIns="0" anchor="ctr">
+          <a:bodyPr wrap="square" lIns="0" rIns="0" tIns="0" bIns="0" anchor="ctr">
             <a:spAutoFit/>
           </a:bodyPr>
           <a:lstStyle/>
@@ -9037,7 +9271,7 @@
           <a:noFill/>
         </p:spPr>
         <p:txBody>
-          <a:bodyPr wrap="square" lIns="0" tIns="0" rIns="0" bIns="0" anchor="t">
+          <a:bodyPr wrap="square" lIns="0" rIns="0" tIns="0" bIns="0" anchor="t">
             <a:spAutoFit/>
           </a:bodyPr>
           <a:lstStyle/>
@@ -9076,7 +9310,7 @@
           <a:noFill/>
         </p:spPr>
         <p:txBody>
-          <a:bodyPr wrap="square" lIns="0" tIns="0" rIns="0" bIns="0" anchor="t">
+          <a:bodyPr wrap="square" lIns="0" rIns="0" tIns="0" bIns="0" anchor="t">
             <a:spAutoFit/>
           </a:bodyPr>
           <a:lstStyle/>
@@ -9141,7 +9375,6 @@
           <a:lstStyle/>
           <a:p>
             <a:pPr algn="ctr"/>
-            <a:endParaRPr/>
           </a:p>
         </p:txBody>
       </p:sp>
@@ -9186,7 +9419,6 @@
           <a:lstStyle/>
           <a:p>
             <a:pPr algn="ctr"/>
-            <a:endParaRPr/>
           </a:p>
         </p:txBody>
       </p:sp>
@@ -9207,7 +9439,7 @@
           <a:noFill/>
         </p:spPr>
         <p:txBody>
-          <a:bodyPr wrap="square" lIns="0" tIns="0" rIns="0" bIns="0" anchor="ctr">
+          <a:bodyPr wrap="square" lIns="0" rIns="0" tIns="0" bIns="0" anchor="ctr">
             <a:spAutoFit/>
           </a:bodyPr>
           <a:lstStyle/>
@@ -9246,7 +9478,7 @@
           <a:noFill/>
         </p:spPr>
         <p:txBody>
-          <a:bodyPr wrap="square" lIns="0" tIns="0" rIns="0" bIns="0" anchor="t">
+          <a:bodyPr wrap="square" lIns="0" rIns="0" tIns="0" bIns="0" anchor="t">
             <a:spAutoFit/>
           </a:bodyPr>
           <a:lstStyle/>
@@ -9285,7 +9517,7 @@
           <a:noFill/>
         </p:spPr>
         <p:txBody>
-          <a:bodyPr wrap="square" lIns="0" tIns="0" rIns="0" bIns="0" anchor="t">
+          <a:bodyPr wrap="square" lIns="0" rIns="0" tIns="0" bIns="0" anchor="t">
             <a:spAutoFit/>
           </a:bodyPr>
           <a:lstStyle/>
@@ -9324,7 +9556,7 @@
           <a:noFill/>
         </p:spPr>
         <p:txBody>
-          <a:bodyPr wrap="square" lIns="0" tIns="0" rIns="0" bIns="0" anchor="t">
+          <a:bodyPr wrap="square" lIns="0" rIns="0" tIns="0" bIns="0" anchor="t">
             <a:spAutoFit/>
           </a:bodyPr>
           <a:lstStyle/>
@@ -9363,7 +9595,7 @@
           <a:noFill/>
         </p:spPr>
         <p:txBody>
-          <a:bodyPr wrap="square" lIns="0" tIns="0" rIns="0" bIns="0" anchor="t">
+          <a:bodyPr wrap="square" lIns="0" rIns="0" tIns="0" bIns="0" anchor="t">
             <a:spAutoFit/>
           </a:bodyPr>
           <a:lstStyle/>
@@ -9394,7 +9626,7 @@
 </file>
 
 <file path=ppt/slides/slide5.xml><?xml version="1.0" encoding="utf-8"?>
-<p:sld xmlns:a="http://schemas.openxmlformats.org/drawingml/2006/main" xmlns:r="http://schemas.openxmlformats.org/officeDocument/2006/relationships" xmlns:p="http://schemas.openxmlformats.org/presentationml/2006/main">
+<p:sld xmlns:a="http://schemas.openxmlformats.org/drawingml/2006/main" xmlns:p="http://schemas.openxmlformats.org/presentationml/2006/main" xmlns:r="http://schemas.openxmlformats.org/officeDocument/2006/relationships">
   <p:cSld>
     <p:spTree>
       <p:nvGrpSpPr>
@@ -9402,14 +9634,7 @@
         <p:cNvGrpSpPr/>
         <p:nvPr/>
       </p:nvGrpSpPr>
-      <p:grpSpPr>
-        <a:xfrm>
-          <a:off x="0" y="0"/>
-          <a:ext cx="0" cy="0"/>
-          <a:chOff x="0" y="0"/>
-          <a:chExt cx="0" cy="0"/>
-        </a:xfrm>
-      </p:grpSpPr>
+      <p:grpSpPr/>
       <p:sp>
         <p:nvSpPr>
           <p:cNvPr id="2" name="Rectangle 1"/>
@@ -9451,7 +9676,6 @@
           <a:lstStyle/>
           <a:p>
             <a:pPr algn="ctr"/>
-            <a:endParaRPr/>
           </a:p>
         </p:txBody>
       </p:sp>
@@ -9496,7 +9720,6 @@
           <a:lstStyle/>
           <a:p>
             <a:pPr algn="ctr"/>
-            <a:endParaRPr/>
           </a:p>
         </p:txBody>
       </p:sp>
@@ -9517,7 +9740,7 @@
           <a:noFill/>
         </p:spPr>
         <p:txBody>
-          <a:bodyPr wrap="square" lIns="0" tIns="0" rIns="0" bIns="0" anchor="ctr">
+          <a:bodyPr wrap="square" lIns="0" rIns="0" tIns="0" bIns="0" anchor="ctr">
             <a:spAutoFit/>
           </a:bodyPr>
           <a:lstStyle/>
@@ -9556,7 +9779,7 @@
           <a:noFill/>
         </p:spPr>
         <p:txBody>
-          <a:bodyPr wrap="square" lIns="0" tIns="0" rIns="0" bIns="0" anchor="ctr">
+          <a:bodyPr wrap="square" lIns="0" rIns="0" tIns="0" bIns="0" anchor="ctr">
             <a:spAutoFit/>
           </a:bodyPr>
           <a:lstStyle/>
@@ -9592,7 +9815,7 @@
         </p:xfrm>
         <a:graphic>
           <a:graphicData uri="http://schemas.openxmlformats.org/drawingml/2006/chart">
-            <c:chart xmlns:c="http://schemas.openxmlformats.org/drawingml/2006/chart" xmlns:r="http://schemas.openxmlformats.org/officeDocument/2006/relationships" r:id="rId2"/>
+            <c:chart xmlns:c="http://schemas.openxmlformats.org/drawingml/2006/chart" r:id="rId2"/>
           </a:graphicData>
         </a:graphic>
       </p:graphicFrame>
@@ -9639,7 +9862,6 @@
           <a:lstStyle/>
           <a:p>
             <a:pPr algn="ctr"/>
-            <a:endParaRPr/>
           </a:p>
         </p:txBody>
       </p:sp>
@@ -9660,7 +9882,7 @@
           <a:noFill/>
         </p:spPr>
         <p:txBody>
-          <a:bodyPr wrap="square" lIns="0" tIns="0" rIns="0" bIns="0" anchor="t">
+          <a:bodyPr wrap="square" lIns="0" rIns="0" tIns="0" bIns="0" anchor="t">
             <a:spAutoFit/>
           </a:bodyPr>
           <a:lstStyle/>
@@ -9699,7 +9921,7 @@
           <a:noFill/>
         </p:spPr>
         <p:txBody>
-          <a:bodyPr wrap="square" lIns="0" tIns="0" rIns="0" bIns="0" anchor="t">
+          <a:bodyPr wrap="square" lIns="0" rIns="0" tIns="0" bIns="0" anchor="t">
             <a:spAutoFit/>
           </a:bodyPr>
           <a:lstStyle/>
@@ -9738,7 +9960,7 @@
           <a:noFill/>
         </p:spPr>
         <p:txBody>
-          <a:bodyPr wrap="square" lIns="0" tIns="0" rIns="0" bIns="0" anchor="t">
+          <a:bodyPr wrap="square" lIns="0" rIns="0" tIns="0" bIns="0" anchor="t">
             <a:spAutoFit/>
           </a:bodyPr>
           <a:lstStyle/>
@@ -9777,7 +9999,7 @@
           <a:noFill/>
         </p:spPr>
         <p:txBody>
-          <a:bodyPr wrap="square" lIns="0" tIns="0" rIns="0" bIns="0" anchor="t">
+          <a:bodyPr wrap="square" lIns="0" rIns="0" tIns="0" bIns="0" anchor="t">
             <a:spAutoFit/>
           </a:bodyPr>
           <a:lstStyle/>
@@ -9816,7 +10038,7 @@
           <a:noFill/>
         </p:spPr>
         <p:txBody>
-          <a:bodyPr wrap="square" lIns="0" tIns="0" rIns="0" bIns="0" anchor="t">
+          <a:bodyPr wrap="square" lIns="0" rIns="0" tIns="0" bIns="0" anchor="t">
             <a:spAutoFit/>
           </a:bodyPr>
           <a:lstStyle/>
@@ -9855,7 +10077,7 @@
           <a:noFill/>
         </p:spPr>
         <p:txBody>
-          <a:bodyPr wrap="square" lIns="0" tIns="0" rIns="0" bIns="0" anchor="t">
+          <a:bodyPr wrap="square" lIns="0" rIns="0" tIns="0" bIns="0" anchor="t">
             <a:spAutoFit/>
           </a:bodyPr>
           <a:lstStyle/>
@@ -9886,7 +10108,7 @@
 </file>
 
 <file path=ppt/slides/slide6.xml><?xml version="1.0" encoding="utf-8"?>
-<p:sld xmlns:a="http://schemas.openxmlformats.org/drawingml/2006/main" xmlns:r="http://schemas.openxmlformats.org/officeDocument/2006/relationships" xmlns:p="http://schemas.openxmlformats.org/presentationml/2006/main">
+<p:sld xmlns:a="http://schemas.openxmlformats.org/drawingml/2006/main" xmlns:p="http://schemas.openxmlformats.org/presentationml/2006/main" xmlns:r="http://schemas.openxmlformats.org/officeDocument/2006/relationships">
   <p:cSld>
     <p:spTree>
       <p:nvGrpSpPr>
@@ -9894,14 +10116,7 @@
         <p:cNvGrpSpPr/>
         <p:nvPr/>
       </p:nvGrpSpPr>
-      <p:grpSpPr>
-        <a:xfrm>
-          <a:off x="0" y="0"/>
-          <a:ext cx="0" cy="0"/>
-          <a:chOff x="0" y="0"/>
-          <a:chExt cx="0" cy="0"/>
-        </a:xfrm>
-      </p:grpSpPr>
+      <p:grpSpPr/>
       <p:sp>
         <p:nvSpPr>
           <p:cNvPr id="2" name="Rectangle 1"/>
@@ -9943,7 +10158,6 @@
           <a:lstStyle/>
           <a:p>
             <a:pPr algn="ctr"/>
-            <a:endParaRPr/>
           </a:p>
         </p:txBody>
       </p:sp>
@@ -9988,7 +10202,6 @@
           <a:lstStyle/>
           <a:p>
             <a:pPr algn="ctr"/>
-            <a:endParaRPr/>
           </a:p>
         </p:txBody>
       </p:sp>
@@ -10009,7 +10222,7 @@
           <a:noFill/>
         </p:spPr>
         <p:txBody>
-          <a:bodyPr wrap="square" lIns="0" tIns="0" rIns="0" bIns="0" anchor="ctr">
+          <a:bodyPr wrap="square" lIns="0" rIns="0" tIns="0" bIns="0" anchor="ctr">
             <a:spAutoFit/>
           </a:bodyPr>
           <a:lstStyle/>
@@ -10048,7 +10261,7 @@
           <a:noFill/>
         </p:spPr>
         <p:txBody>
-          <a:bodyPr wrap="square" lIns="0" tIns="0" rIns="0" bIns="0" anchor="ctr">
+          <a:bodyPr wrap="square" lIns="0" rIns="0" tIns="0" bIns="0" anchor="ctr">
             <a:spAutoFit/>
           </a:bodyPr>
           <a:lstStyle/>
@@ -10084,7 +10297,7 @@
         </p:xfrm>
         <a:graphic>
           <a:graphicData uri="http://schemas.openxmlformats.org/drawingml/2006/chart">
-            <c:chart xmlns:c="http://schemas.openxmlformats.org/drawingml/2006/chart" xmlns:r="http://schemas.openxmlformats.org/officeDocument/2006/relationships" r:id="rId2"/>
+            <c:chart xmlns:c="http://schemas.openxmlformats.org/drawingml/2006/chart" r:id="rId2"/>
           </a:graphicData>
         </a:graphic>
       </p:graphicFrame>
@@ -10131,7 +10344,6 @@
           <a:lstStyle/>
           <a:p>
             <a:pPr algn="ctr"/>
-            <a:endParaRPr/>
           </a:p>
         </p:txBody>
       </p:sp>
@@ -10152,7 +10364,7 @@
           <a:noFill/>
         </p:spPr>
         <p:txBody>
-          <a:bodyPr wrap="square" lIns="0" tIns="0" rIns="0" bIns="0" anchor="t">
+          <a:bodyPr wrap="square" lIns="0" rIns="0" tIns="0" bIns="0" anchor="t">
             <a:spAutoFit/>
           </a:bodyPr>
           <a:lstStyle/>
@@ -10191,7 +10403,7 @@
           <a:noFill/>
         </p:spPr>
         <p:txBody>
-          <a:bodyPr wrap="square" lIns="0" tIns="0" rIns="0" bIns="0" anchor="t">
+          <a:bodyPr wrap="square" lIns="0" rIns="0" tIns="0" bIns="0" anchor="t">
             <a:spAutoFit/>
           </a:bodyPr>
           <a:lstStyle/>
@@ -10230,7 +10442,7 @@
           <a:noFill/>
         </p:spPr>
         <p:txBody>
-          <a:bodyPr wrap="square" lIns="0" tIns="0" rIns="0" bIns="0" anchor="t">
+          <a:bodyPr wrap="square" lIns="0" rIns="0" tIns="0" bIns="0" anchor="t">
             <a:spAutoFit/>
           </a:bodyPr>
           <a:lstStyle/>
@@ -10269,7 +10481,7 @@
           <a:noFill/>
         </p:spPr>
         <p:txBody>
-          <a:bodyPr wrap="square" lIns="0" tIns="0" rIns="0" bIns="0" anchor="t">
+          <a:bodyPr wrap="square" lIns="0" rIns="0" tIns="0" bIns="0" anchor="t">
             <a:spAutoFit/>
           </a:bodyPr>
           <a:lstStyle/>
@@ -10308,7 +10520,7 @@
           <a:noFill/>
         </p:spPr>
         <p:txBody>
-          <a:bodyPr wrap="square" lIns="0" tIns="0" rIns="0" bIns="0" anchor="t">
+          <a:bodyPr wrap="square" lIns="0" rIns="0" tIns="0" bIns="0" anchor="t">
             <a:spAutoFit/>
           </a:bodyPr>
           <a:lstStyle/>
@@ -10347,7 +10559,7 @@
           <a:noFill/>
         </p:spPr>
         <p:txBody>
-          <a:bodyPr wrap="square" lIns="0" tIns="0" rIns="0" bIns="0" anchor="t">
+          <a:bodyPr wrap="square" lIns="0" rIns="0" tIns="0" bIns="0" anchor="t">
             <a:spAutoFit/>
           </a:bodyPr>
           <a:lstStyle/>
@@ -10378,7 +10590,7 @@
 </file>
 
 <file path=ppt/slides/slide7.xml><?xml version="1.0" encoding="utf-8"?>
-<p:sld xmlns:a="http://schemas.openxmlformats.org/drawingml/2006/main" xmlns:r="http://schemas.openxmlformats.org/officeDocument/2006/relationships" xmlns:p="http://schemas.openxmlformats.org/presentationml/2006/main">
+<p:sld xmlns:a="http://schemas.openxmlformats.org/drawingml/2006/main" xmlns:p="http://schemas.openxmlformats.org/presentationml/2006/main" xmlns:r="http://schemas.openxmlformats.org/officeDocument/2006/relationships">
   <p:cSld>
     <p:spTree>
       <p:nvGrpSpPr>
@@ -10386,14 +10598,7 @@
         <p:cNvGrpSpPr/>
         <p:nvPr/>
       </p:nvGrpSpPr>
-      <p:grpSpPr>
-        <a:xfrm>
-          <a:off x="0" y="0"/>
-          <a:ext cx="0" cy="0"/>
-          <a:chOff x="0" y="0"/>
-          <a:chExt cx="0" cy="0"/>
-        </a:xfrm>
-      </p:grpSpPr>
+      <p:grpSpPr/>
       <p:sp>
         <p:nvSpPr>
           <p:cNvPr id="2" name="Rectangle 1"/>
@@ -10435,7 +10640,6 @@
           <a:lstStyle/>
           <a:p>
             <a:pPr algn="ctr"/>
-            <a:endParaRPr/>
           </a:p>
         </p:txBody>
       </p:sp>
@@ -10480,7 +10684,6 @@
           <a:lstStyle/>
           <a:p>
             <a:pPr algn="ctr"/>
-            <a:endParaRPr/>
           </a:p>
         </p:txBody>
       </p:sp>
@@ -10501,7 +10704,7 @@
           <a:noFill/>
         </p:spPr>
         <p:txBody>
-          <a:bodyPr wrap="square" lIns="0" tIns="0" rIns="0" bIns="0" anchor="ctr">
+          <a:bodyPr wrap="square" lIns="0" rIns="0" tIns="0" bIns="0" anchor="ctr">
             <a:spAutoFit/>
           </a:bodyPr>
           <a:lstStyle/>
@@ -10540,7 +10743,7 @@
           <a:noFill/>
         </p:spPr>
         <p:txBody>
-          <a:bodyPr wrap="square" lIns="0" tIns="0" rIns="0" bIns="0" anchor="ctr">
+          <a:bodyPr wrap="square" lIns="0" rIns="0" tIns="0" bIns="0" anchor="ctr">
             <a:spAutoFit/>
           </a:bodyPr>
           <a:lstStyle/>
@@ -10576,7 +10779,7 @@
         </p:xfrm>
         <a:graphic>
           <a:graphicData uri="http://schemas.openxmlformats.org/drawingml/2006/chart">
-            <c:chart xmlns:c="http://schemas.openxmlformats.org/drawingml/2006/chart" xmlns:r="http://schemas.openxmlformats.org/officeDocument/2006/relationships" r:id="rId2"/>
+            <c:chart xmlns:c="http://schemas.openxmlformats.org/drawingml/2006/chart" r:id="rId2"/>
           </a:graphicData>
         </a:graphic>
       </p:graphicFrame>
@@ -10623,7 +10826,6 @@
           <a:lstStyle/>
           <a:p>
             <a:pPr algn="ctr"/>
-            <a:endParaRPr/>
           </a:p>
         </p:txBody>
       </p:sp>
@@ -10644,7 +10846,7 @@
           <a:noFill/>
         </p:spPr>
         <p:txBody>
-          <a:bodyPr wrap="square" lIns="0" tIns="0" rIns="0" bIns="0" anchor="t">
+          <a:bodyPr wrap="square" lIns="0" rIns="0" tIns="0" bIns="0" anchor="t">
             <a:spAutoFit/>
           </a:bodyPr>
           <a:lstStyle/>
@@ -10683,7 +10885,7 @@
           <a:noFill/>
         </p:spPr>
         <p:txBody>
-          <a:bodyPr wrap="square" lIns="0" tIns="0" rIns="0" bIns="0" anchor="t">
+          <a:bodyPr wrap="square" lIns="0" rIns="0" tIns="0" bIns="0" anchor="t">
             <a:spAutoFit/>
           </a:bodyPr>
           <a:lstStyle/>
@@ -10722,7 +10924,7 @@
           <a:noFill/>
         </p:spPr>
         <p:txBody>
-          <a:bodyPr wrap="square" lIns="0" tIns="0" rIns="0" bIns="0" anchor="t">
+          <a:bodyPr wrap="square" lIns="0" rIns="0" tIns="0" bIns="0" anchor="t">
             <a:spAutoFit/>
           </a:bodyPr>
           <a:lstStyle/>
@@ -10761,7 +10963,7 @@
           <a:noFill/>
         </p:spPr>
         <p:txBody>
-          <a:bodyPr wrap="square" lIns="0" tIns="0" rIns="0" bIns="0" anchor="t">
+          <a:bodyPr wrap="square" lIns="0" rIns="0" tIns="0" bIns="0" anchor="t">
             <a:spAutoFit/>
           </a:bodyPr>
           <a:lstStyle/>
@@ -10816,7 +11018,7 @@
           <a:noFill/>
         </p:spPr>
         <p:txBody>
-          <a:bodyPr wrap="square" lIns="0" tIns="0" rIns="0" bIns="0" anchor="t">
+          <a:bodyPr wrap="square" lIns="0" rIns="0" tIns="0" bIns="0" anchor="t">
             <a:spAutoFit/>
           </a:bodyPr>
           <a:lstStyle/>
@@ -10855,7 +11057,7 @@
           <a:noFill/>
         </p:spPr>
         <p:txBody>
-          <a:bodyPr wrap="square" lIns="0" tIns="0" rIns="0" bIns="0" anchor="t">
+          <a:bodyPr wrap="square" lIns="0" rIns="0" tIns="0" bIns="0" anchor="t">
             <a:spAutoFit/>
           </a:bodyPr>
           <a:lstStyle/>
@@ -10894,7 +11096,7 @@
           <a:noFill/>
         </p:spPr>
         <p:txBody>
-          <a:bodyPr wrap="square" lIns="0" tIns="0" rIns="0" bIns="0" anchor="t">
+          <a:bodyPr wrap="square" lIns="0" rIns="0" tIns="0" bIns="0" anchor="t">
             <a:spAutoFit/>
           </a:bodyPr>
           <a:lstStyle/>
@@ -10949,7 +11151,7 @@
           <a:noFill/>
         </p:spPr>
         <p:txBody>
-          <a:bodyPr wrap="square" lIns="0" tIns="0" rIns="0" bIns="0" anchor="t">
+          <a:bodyPr wrap="square" lIns="0" rIns="0" tIns="0" bIns="0" anchor="t">
             <a:spAutoFit/>
           </a:bodyPr>
           <a:lstStyle/>
@@ -10988,7 +11190,7 @@
           <a:noFill/>
         </p:spPr>
         <p:txBody>
-          <a:bodyPr wrap="square" lIns="0" tIns="0" rIns="0" bIns="0" anchor="t">
+          <a:bodyPr wrap="square" lIns="0" rIns="0" tIns="0" bIns="0" anchor="t">
             <a:spAutoFit/>
           </a:bodyPr>
           <a:lstStyle/>
@@ -11027,7 +11229,7 @@
           <a:noFill/>
         </p:spPr>
         <p:txBody>
-          <a:bodyPr wrap="square" lIns="0" tIns="0" rIns="0" bIns="0" anchor="t">
+          <a:bodyPr wrap="square" lIns="0" rIns="0" tIns="0" bIns="0" anchor="t">
             <a:spAutoFit/>
           </a:bodyPr>
           <a:lstStyle/>
@@ -11082,7 +11284,7 @@
           <a:noFill/>
         </p:spPr>
         <p:txBody>
-          <a:bodyPr wrap="square" lIns="0" tIns="0" rIns="0" bIns="0" anchor="t">
+          <a:bodyPr wrap="square" lIns="0" rIns="0" tIns="0" bIns="0" anchor="t">
             <a:spAutoFit/>
           </a:bodyPr>
           <a:lstStyle/>
@@ -11121,7 +11323,7 @@
           <a:noFill/>
         </p:spPr>
         <p:txBody>
-          <a:bodyPr wrap="square" lIns="0" tIns="0" rIns="0" bIns="0" anchor="t">
+          <a:bodyPr wrap="square" lIns="0" rIns="0" tIns="0" bIns="0" anchor="t">
             <a:spAutoFit/>
           </a:bodyPr>
           <a:lstStyle/>
@@ -11152,7 +11354,7 @@
 </file>
 
 <file path=ppt/slides/slide8.xml><?xml version="1.0" encoding="utf-8"?>
-<p:sld xmlns:a="http://schemas.openxmlformats.org/drawingml/2006/main" xmlns:r="http://schemas.openxmlformats.org/officeDocument/2006/relationships" xmlns:p="http://schemas.openxmlformats.org/presentationml/2006/main">
+<p:sld xmlns:a="http://schemas.openxmlformats.org/drawingml/2006/main" xmlns:p="http://schemas.openxmlformats.org/presentationml/2006/main" xmlns:r="http://schemas.openxmlformats.org/officeDocument/2006/relationships">
   <p:cSld>
     <p:spTree>
       <p:nvGrpSpPr>
@@ -11160,14 +11362,7 @@
         <p:cNvGrpSpPr/>
         <p:nvPr/>
       </p:nvGrpSpPr>
-      <p:grpSpPr>
-        <a:xfrm>
-          <a:off x="0" y="0"/>
-          <a:ext cx="0" cy="0"/>
-          <a:chOff x="0" y="0"/>
-          <a:chExt cx="0" cy="0"/>
-        </a:xfrm>
-      </p:grpSpPr>
+      <p:grpSpPr/>
       <p:sp>
         <p:nvSpPr>
           <p:cNvPr id="2" name="Rectangle 1"/>
@@ -11209,7 +11404,6 @@
           <a:lstStyle/>
           <a:p>
             <a:pPr algn="ctr"/>
-            <a:endParaRPr/>
           </a:p>
         </p:txBody>
       </p:sp>
@@ -11230,7 +11424,7 @@
           <a:noFill/>
         </p:spPr>
         <p:txBody>
-          <a:bodyPr wrap="square" lIns="0" tIns="0" rIns="0" bIns="0" anchor="t">
+          <a:bodyPr wrap="square" lIns="0" rIns="0" tIns="0" bIns="0" anchor="t">
             <a:spAutoFit/>
           </a:bodyPr>
           <a:lstStyle/>
@@ -11269,7 +11463,7 @@
           <a:noFill/>
         </p:spPr>
         <p:txBody>
-          <a:bodyPr wrap="square" lIns="0" tIns="0" rIns="0" bIns="0" anchor="t">
+          <a:bodyPr wrap="square" lIns="0" rIns="0" tIns="0" bIns="0" anchor="t">
             <a:spAutoFit/>
           </a:bodyPr>
           <a:lstStyle/>
@@ -11308,7 +11502,7 @@
           <a:noFill/>
         </p:spPr>
         <p:txBody>
-          <a:bodyPr wrap="square" lIns="0" tIns="0" rIns="0" bIns="0" anchor="t">
+          <a:bodyPr wrap="square" lIns="0" rIns="0" tIns="0" bIns="0" anchor="t">
             <a:spAutoFit/>
           </a:bodyPr>
           <a:lstStyle/>
@@ -11344,7 +11538,7 @@
         </p:xfrm>
         <a:graphic>
           <a:graphicData uri="http://schemas.openxmlformats.org/drawingml/2006/chart">
-            <c:chart xmlns:c="http://schemas.openxmlformats.org/drawingml/2006/chart" xmlns:r="http://schemas.openxmlformats.org/officeDocument/2006/relationships" r:id="rId2"/>
+            <c:chart xmlns:c="http://schemas.openxmlformats.org/drawingml/2006/chart" r:id="rId2"/>
           </a:graphicData>
         </a:graphic>
       </p:graphicFrame>
@@ -11365,7 +11559,7 @@
           <a:noFill/>
         </p:spPr>
         <p:txBody>
-          <a:bodyPr wrap="square" lIns="0" tIns="0" rIns="0" bIns="0" anchor="t">
+          <a:bodyPr wrap="square" lIns="0" rIns="0" tIns="0" bIns="0" anchor="t">
             <a:spAutoFit/>
           </a:bodyPr>
           <a:lstStyle/>
@@ -11404,7 +11598,7 @@
           <a:noFill/>
         </p:spPr>
         <p:txBody>
-          <a:bodyPr wrap="square" lIns="0" tIns="0" rIns="0" bIns="0" anchor="t">
+          <a:bodyPr wrap="square" lIns="0" rIns="0" tIns="0" bIns="0" anchor="t">
             <a:spAutoFit/>
           </a:bodyPr>
           <a:lstStyle/>
@@ -11435,7 +11629,7 @@
 </file>
 
 <file path=ppt/slides/slide9.xml><?xml version="1.0" encoding="utf-8"?>
-<p:sld xmlns:a="http://schemas.openxmlformats.org/drawingml/2006/main" xmlns:r="http://schemas.openxmlformats.org/officeDocument/2006/relationships" xmlns:p="http://schemas.openxmlformats.org/presentationml/2006/main">
+<p:sld xmlns:a="http://schemas.openxmlformats.org/drawingml/2006/main" xmlns:p="http://schemas.openxmlformats.org/presentationml/2006/main" xmlns:r="http://schemas.openxmlformats.org/officeDocument/2006/relationships">
   <p:cSld>
     <p:spTree>
       <p:nvGrpSpPr>
@@ -11443,14 +11637,7 @@
         <p:cNvGrpSpPr/>
         <p:nvPr/>
       </p:nvGrpSpPr>
-      <p:grpSpPr>
-        <a:xfrm>
-          <a:off x="0" y="0"/>
-          <a:ext cx="0" cy="0"/>
-          <a:chOff x="0" y="0"/>
-          <a:chExt cx="0" cy="0"/>
-        </a:xfrm>
-      </p:grpSpPr>
+      <p:grpSpPr/>
       <p:sp>
         <p:nvSpPr>
           <p:cNvPr id="2" name="Rectangle 1"/>
@@ -11492,7 +11679,6 @@
           <a:lstStyle/>
           <a:p>
             <a:pPr algn="ctr"/>
-            <a:endParaRPr/>
           </a:p>
         </p:txBody>
       </p:sp>
@@ -11537,7 +11723,6 @@
           <a:lstStyle/>
           <a:p>
             <a:pPr algn="ctr"/>
-            <a:endParaRPr/>
           </a:p>
         </p:txBody>
       </p:sp>
@@ -11558,7 +11743,7 @@
           <a:noFill/>
         </p:spPr>
         <p:txBody>
-          <a:bodyPr wrap="square" lIns="0" tIns="0" rIns="0" bIns="0" anchor="t">
+          <a:bodyPr wrap="square" lIns="0" rIns="0" tIns="0" bIns="0" anchor="t">
             <a:spAutoFit/>
           </a:bodyPr>
           <a:lstStyle/>
@@ -11597,7 +11782,7 @@
           <a:noFill/>
         </p:spPr>
         <p:txBody>
-          <a:bodyPr wrap="square" lIns="0" tIns="0" rIns="0" bIns="0" anchor="t">
+          <a:bodyPr wrap="square" lIns="0" rIns="0" tIns="0" bIns="0" anchor="t">
             <a:spAutoFit/>
           </a:bodyPr>
           <a:lstStyle/>
@@ -11660,7 +11845,6 @@
           <a:lstStyle/>
           <a:p>
             <a:pPr algn="ctr"/>
-            <a:endParaRPr/>
           </a:p>
         </p:txBody>
       </p:sp>
@@ -11681,7 +11865,7 @@
           <a:noFill/>
         </p:spPr>
         <p:txBody>
-          <a:bodyPr wrap="square" lIns="0" tIns="0" rIns="0" bIns="0" anchor="ctr">
+          <a:bodyPr wrap="square" lIns="0" rIns="0" tIns="0" bIns="0" anchor="ctr">
             <a:spAutoFit/>
           </a:bodyPr>
           <a:lstStyle/>
@@ -11720,7 +11904,7 @@
           <a:noFill/>
         </p:spPr>
         <p:txBody>
-          <a:bodyPr wrap="square" lIns="0" tIns="0" rIns="0" bIns="0" anchor="ctr">
+          <a:bodyPr wrap="square" lIns="0" rIns="0" tIns="0" bIns="0" anchor="ctr">
             <a:spAutoFit/>
           </a:bodyPr>
           <a:lstStyle/>
@@ -11759,7 +11943,7 @@
           <a:noFill/>
         </p:spPr>
         <p:txBody>
-          <a:bodyPr wrap="square" lIns="0" tIns="0" rIns="0" bIns="0" anchor="ctr">
+          <a:bodyPr wrap="square" lIns="0" rIns="0" tIns="0" bIns="0" anchor="ctr">
             <a:spAutoFit/>
           </a:bodyPr>
           <a:lstStyle/>
@@ -11822,7 +12006,6 @@
           <a:lstStyle/>
           <a:p>
             <a:pPr algn="ctr"/>
-            <a:endParaRPr/>
           </a:p>
         </p:txBody>
       </p:sp>
@@ -11843,7 +12026,7 @@
           <a:noFill/>
         </p:spPr>
         <p:txBody>
-          <a:bodyPr wrap="square" lIns="0" tIns="0" rIns="0" bIns="0" anchor="ctr">
+          <a:bodyPr wrap="square" lIns="0" rIns="0" tIns="0" bIns="0" anchor="ctr">
             <a:spAutoFit/>
           </a:bodyPr>
           <a:lstStyle/>
@@ -11882,7 +12065,7 @@
           <a:noFill/>
         </p:spPr>
         <p:txBody>
-          <a:bodyPr wrap="square" lIns="0" tIns="0" rIns="0" bIns="0" anchor="ctr">
+          <a:bodyPr wrap="square" lIns="0" rIns="0" tIns="0" bIns="0" anchor="ctr">
             <a:spAutoFit/>
           </a:bodyPr>
           <a:lstStyle/>
@@ -11921,7 +12104,7 @@
           <a:noFill/>
         </p:spPr>
         <p:txBody>
-          <a:bodyPr wrap="square" lIns="0" tIns="0" rIns="0" bIns="0" anchor="ctr">
+          <a:bodyPr wrap="square" lIns="0" rIns="0" tIns="0" bIns="0" anchor="ctr">
             <a:spAutoFit/>
           </a:bodyPr>
           <a:lstStyle/>
@@ -11984,7 +12167,6 @@
           <a:lstStyle/>
           <a:p>
             <a:pPr algn="ctr"/>
-            <a:endParaRPr/>
           </a:p>
         </p:txBody>
       </p:sp>
@@ -12005,7 +12187,7 @@
           <a:noFill/>
         </p:spPr>
         <p:txBody>
-          <a:bodyPr wrap="square" lIns="0" tIns="0" rIns="0" bIns="0" anchor="ctr">
+          <a:bodyPr wrap="square" lIns="0" rIns="0" tIns="0" bIns="0" anchor="ctr">
             <a:spAutoFit/>
           </a:bodyPr>
           <a:lstStyle/>
@@ -12044,7 +12226,7 @@
           <a:noFill/>
         </p:spPr>
         <p:txBody>
-          <a:bodyPr wrap="square" lIns="0" tIns="0" rIns="0" bIns="0" anchor="ctr">
+          <a:bodyPr wrap="square" lIns="0" rIns="0" tIns="0" bIns="0" anchor="ctr">
             <a:spAutoFit/>
           </a:bodyPr>
           <a:lstStyle/>
@@ -12083,7 +12265,7 @@
           <a:noFill/>
         </p:spPr>
         <p:txBody>
-          <a:bodyPr wrap="square" lIns="0" tIns="0" rIns="0" bIns="0" anchor="ctr">
+          <a:bodyPr wrap="square" lIns="0" rIns="0" tIns="0" bIns="0" anchor="ctr">
             <a:spAutoFit/>
           </a:bodyPr>
           <a:lstStyle/>
@@ -12122,7 +12304,7 @@
           <a:noFill/>
         </p:spPr>
         <p:txBody>
-          <a:bodyPr wrap="square" lIns="0" tIns="0" rIns="0" bIns="0" anchor="t">
+          <a:bodyPr wrap="square" lIns="0" rIns="0" tIns="0" bIns="0" anchor="t">
             <a:spAutoFit/>
           </a:bodyPr>
           <a:lstStyle/>
@@ -12161,7 +12343,7 @@
           <a:noFill/>
         </p:spPr>
         <p:txBody>
-          <a:bodyPr wrap="square" lIns="0" tIns="0" rIns="0" bIns="0" anchor="t">
+          <a:bodyPr wrap="square" lIns="0" rIns="0" tIns="0" bIns="0" anchor="t">
             <a:spAutoFit/>
           </a:bodyPr>
           <a:lstStyle/>

</xml_diff>

<commit_message>
Simplificar lenguaje de la presentacion y quitar slide de proximos pasos
</commit_message>
<xml_diff>
--- a/Preentrega - Sofia Algamiz.pptx
+++ b/Preentrega - Sofia Algamiz.pptx
@@ -16,7 +16,6 @@
     <p:sldId id="264" r:id="rId15"/>
     <p:sldId id="265" r:id="rId16"/>
     <p:sldId id="266" r:id="rId17"/>
-    <p:sldId id="267" r:id="rId18"/>
   </p:sldIdLst>
   <p:sldSz cx="12191695" cy="6858000" type="screen4x3"/>
   <p:notesSz cx="6858000" cy="9144000"/>
@@ -4526,7 +4525,7 @@
                 </a:solidFill>
                 <a:latin typeface="Calibri"/>
               </a:rPr>
-              <a:t>Primera Entrega — Obtención de insights a partir de visualizaciones</a:t>
+              <a:t>Primera Entrega: Obtención de insights a partir de visualizaciones</a:t>
             </a:r>
           </a:p>
         </p:txBody>
@@ -5365,7 +5364,7 @@
                 </a:solidFill>
                 <a:latin typeface="Calibri"/>
               </a:rPr>
-              <a:t>Airbnb CABA — Data Science II · TP1</a:t>
+              <a:t>Airbnb CABA · Data Science II · TP1</a:t>
             </a:r>
           </a:p>
         </p:txBody>
@@ -5442,1052 +5441,6 @@
             <a:avLst/>
           </a:prstGeom>
           <a:solidFill>
-            <a:srgbClr val="FFFFFF"/>
-          </a:solidFill>
-          <a:ln>
-            <a:noFill/>
-          </a:ln>
-          <a:effectLst/>
-        </p:spPr>
-        <p:style>
-          <a:lnRef idx="1">
-            <a:schemeClr val="accent1"/>
-          </a:lnRef>
-          <a:fillRef idx="3">
-            <a:schemeClr val="accent1"/>
-          </a:fillRef>
-          <a:effectRef idx="2">
-            <a:schemeClr val="accent1"/>
-          </a:effectRef>
-          <a:fontRef idx="minor">
-            <a:schemeClr val="lt1"/>
-          </a:fontRef>
-        </p:style>
-        <p:txBody>
-          <a:bodyPr rtlCol="0" anchor="ctr"/>
-          <a:lstStyle/>
-          <a:p>
-            <a:pPr algn="ctr"/>
-          </a:p>
-        </p:txBody>
-      </p:sp>
-      <p:sp>
-        <p:nvSpPr>
-          <p:cNvPr id="3" name="TextBox 2"/>
-          <p:cNvSpPr txBox="1"/>
-          <p:nvPr/>
-        </p:nvSpPr>
-        <p:spPr>
-          <a:xfrm>
-            <a:off x="640080" y="502920"/>
-            <a:ext cx="5486400" cy="274320"/>
-          </a:xfrm>
-          <a:prstGeom prst="rect">
-            <a:avLst/>
-          </a:prstGeom>
-          <a:noFill/>
-        </p:spPr>
-        <p:txBody>
-          <a:bodyPr wrap="square" lIns="0" rIns="0" tIns="0" bIns="0" anchor="t">
-            <a:spAutoFit/>
-          </a:bodyPr>
-          <a:lstStyle/>
-          <a:p>
-            <a:pPr algn="l">
-              <a:lnSpc>
-                <a:spcPct val="100000"/>
-              </a:lnSpc>
-            </a:pPr>
-            <a:r>
-              <a:rPr sz="1200" b="1" i="0" spc="150">
-                <a:solidFill>
-                  <a:srgbClr val="1E2761"/>
-                </a:solidFill>
-                <a:latin typeface="Calibri"/>
-              </a:rPr>
-              <a:t>PRÓXIMOS PASOS</a:t>
-            </a:r>
-          </a:p>
-        </p:txBody>
-      </p:sp>
-      <p:sp>
-        <p:nvSpPr>
-          <p:cNvPr id="4" name="TextBox 3"/>
-          <p:cNvSpPr txBox="1"/>
-          <p:nvPr/>
-        </p:nvSpPr>
-        <p:spPr>
-          <a:xfrm>
-            <a:off x="640080" y="822960"/>
-            <a:ext cx="10515600" cy="548640"/>
-          </a:xfrm>
-          <a:prstGeom prst="rect">
-            <a:avLst/>
-          </a:prstGeom>
-          <a:noFill/>
-        </p:spPr>
-        <p:txBody>
-          <a:bodyPr wrap="square" lIns="0" rIns="0" tIns="0" bIns="0" anchor="t">
-            <a:spAutoFit/>
-          </a:bodyPr>
-          <a:lstStyle/>
-          <a:p>
-            <a:pPr algn="l">
-              <a:lnSpc>
-                <a:spcPct val="100000"/>
-              </a:lnSpc>
-            </a:pPr>
-            <a:r>
-              <a:rPr sz="2700" b="1" i="0">
-                <a:solidFill>
-                  <a:srgbClr val="1B1F3B"/>
-                </a:solidFill>
-                <a:latin typeface="Cambria"/>
-              </a:rPr>
-              <a:t>De insights descriptivos a modelos predictivos</a:t>
-            </a:r>
-          </a:p>
-        </p:txBody>
-      </p:sp>
-      <p:sp>
-        <p:nvSpPr>
-          <p:cNvPr id="5" name="TextBox 4"/>
-          <p:cNvSpPr txBox="1"/>
-          <p:nvPr/>
-        </p:nvSpPr>
-        <p:spPr>
-          <a:xfrm>
-            <a:off x="640080" y="1554480"/>
-            <a:ext cx="10515600" cy="822960"/>
-          </a:xfrm>
-          <a:prstGeom prst="rect">
-            <a:avLst/>
-          </a:prstGeom>
-          <a:noFill/>
-        </p:spPr>
-        <p:txBody>
-          <a:bodyPr wrap="square" lIns="0" rIns="0" tIns="0" bIns="0" anchor="t">
-            <a:spAutoFit/>
-          </a:bodyPr>
-          <a:lstStyle/>
-          <a:p>
-            <a:pPr algn="l">
-              <a:lnSpc>
-                <a:spcPct val="130000"/>
-              </a:lnSpc>
-            </a:pPr>
-            <a:r>
-              <a:rPr sz="1500" b="0" i="0">
-                <a:solidFill>
-                  <a:srgbClr val="1B1F3B"/>
-                </a:solidFill>
-                <a:latin typeface="Calibri"/>
-              </a:rPr>
-              <a:t>Este análisis es exploratorio y descriptivo (correlaciones), no causal. La segunda entrega del TP incorporará modelos de Machine Learning entrenados y optimizados para predecir precio y ocupación, cuantificando el efecto real de cada variable.</a:t>
-            </a:r>
-          </a:p>
-        </p:txBody>
-      </p:sp>
-      <p:sp>
-        <p:nvSpPr>
-          <p:cNvPr id="6" name="Rounded Rectangle 5"/>
-          <p:cNvSpPr/>
-          <p:nvPr/>
-        </p:nvSpPr>
-        <p:spPr>
-          <a:xfrm>
-            <a:off x="640080" y="2743200"/>
-            <a:ext cx="3520440" cy="2286000"/>
-          </a:xfrm>
-          <a:prstGeom prst="roundRect">
-            <a:avLst>
-              <a:gd name="adj" fmla="val 5000"/>
-            </a:avLst>
-          </a:prstGeom>
-          <a:solidFill>
-            <a:srgbClr val="F4F6FC"/>
-          </a:solidFill>
-          <a:ln>
-            <a:noFill/>
-          </a:ln>
-          <a:effectLst/>
-        </p:spPr>
-        <p:style>
-          <a:lnRef idx="1">
-            <a:schemeClr val="accent1"/>
-          </a:lnRef>
-          <a:fillRef idx="3">
-            <a:schemeClr val="accent1"/>
-          </a:fillRef>
-          <a:effectRef idx="2">
-            <a:schemeClr val="accent1"/>
-          </a:effectRef>
-          <a:fontRef idx="minor">
-            <a:schemeClr val="lt1"/>
-          </a:fontRef>
-        </p:style>
-        <p:txBody>
-          <a:bodyPr rtlCol="0" anchor="ctr"/>
-          <a:lstStyle/>
-          <a:p>
-            <a:pPr algn="ctr"/>
-          </a:p>
-        </p:txBody>
-      </p:sp>
-      <p:sp>
-        <p:nvSpPr>
-          <p:cNvPr id="7" name="Oval 6"/>
-          <p:cNvSpPr/>
-          <p:nvPr/>
-        </p:nvSpPr>
-        <p:spPr>
-          <a:xfrm>
-            <a:off x="914400" y="3017520"/>
-            <a:ext cx="502920" cy="502920"/>
-          </a:xfrm>
-          <a:prstGeom prst="ellipse">
-            <a:avLst/>
-          </a:prstGeom>
-          <a:solidFill>
-            <a:srgbClr val="1E2761"/>
-          </a:solidFill>
-          <a:ln>
-            <a:noFill/>
-          </a:ln>
-          <a:effectLst/>
-        </p:spPr>
-        <p:style>
-          <a:lnRef idx="1">
-            <a:schemeClr val="accent1"/>
-          </a:lnRef>
-          <a:fillRef idx="3">
-            <a:schemeClr val="accent1"/>
-          </a:fillRef>
-          <a:effectRef idx="2">
-            <a:schemeClr val="accent1"/>
-          </a:effectRef>
-          <a:fontRef idx="minor">
-            <a:schemeClr val="lt1"/>
-          </a:fontRef>
-        </p:style>
-        <p:txBody>
-          <a:bodyPr rtlCol="0" anchor="ctr"/>
-          <a:lstStyle/>
-          <a:p>
-            <a:pPr algn="ctr"/>
-          </a:p>
-        </p:txBody>
-      </p:sp>
-      <p:sp>
-        <p:nvSpPr>
-          <p:cNvPr id="8" name="TextBox 7"/>
-          <p:cNvSpPr txBox="1"/>
-          <p:nvPr/>
-        </p:nvSpPr>
-        <p:spPr>
-          <a:xfrm>
-            <a:off x="914400" y="3017520"/>
-            <a:ext cx="502920" cy="502920"/>
-          </a:xfrm>
-          <a:prstGeom prst="rect">
-            <a:avLst/>
-          </a:prstGeom>
-          <a:noFill/>
-        </p:spPr>
-        <p:txBody>
-          <a:bodyPr wrap="square" lIns="0" rIns="0" tIns="0" bIns="0" anchor="ctr">
-            <a:spAutoFit/>
-          </a:bodyPr>
-          <a:lstStyle/>
-          <a:p>
-            <a:pPr algn="ctr">
-              <a:lnSpc>
-                <a:spcPct val="100000"/>
-              </a:lnSpc>
-            </a:pPr>
-            <a:r>
-              <a:rPr sz="1800" b="1" i="0">
-                <a:solidFill>
-                  <a:srgbClr val="FFFFFF"/>
-                </a:solidFill>
-                <a:latin typeface="Calibri"/>
-              </a:rPr>
-              <a:t>1</a:t>
-            </a:r>
-          </a:p>
-        </p:txBody>
-      </p:sp>
-      <p:sp>
-        <p:nvSpPr>
-          <p:cNvPr id="9" name="TextBox 8"/>
-          <p:cNvSpPr txBox="1"/>
-          <p:nvPr/>
-        </p:nvSpPr>
-        <p:spPr>
-          <a:xfrm>
-            <a:off x="1600200" y="3017520"/>
-            <a:ext cx="2286000" cy="502920"/>
-          </a:xfrm>
-          <a:prstGeom prst="rect">
-            <a:avLst/>
-          </a:prstGeom>
-          <a:noFill/>
-        </p:spPr>
-        <p:txBody>
-          <a:bodyPr wrap="square" lIns="0" rIns="0" tIns="0" bIns="0" anchor="ctr">
-            <a:spAutoFit/>
-          </a:bodyPr>
-          <a:lstStyle/>
-          <a:p>
-            <a:pPr algn="l">
-              <a:lnSpc>
-                <a:spcPct val="100000"/>
-              </a:lnSpc>
-            </a:pPr>
-            <a:r>
-              <a:rPr sz="1500" b="1" i="0">
-                <a:solidFill>
-                  <a:srgbClr val="1B1F3B"/>
-                </a:solidFill>
-                <a:latin typeface="Cambria"/>
-              </a:rPr>
-              <a:t>Modelo de pricing</a:t>
-            </a:r>
-          </a:p>
-        </p:txBody>
-      </p:sp>
-      <p:sp>
-        <p:nvSpPr>
-          <p:cNvPr id="10" name="TextBox 9"/>
-          <p:cNvSpPr txBox="1"/>
-          <p:nvPr/>
-        </p:nvSpPr>
-        <p:spPr>
-          <a:xfrm>
-            <a:off x="914400" y="3703320"/>
-            <a:ext cx="2971800" cy="1188720"/>
-          </a:xfrm>
-          <a:prstGeom prst="rect">
-            <a:avLst/>
-          </a:prstGeom>
-          <a:noFill/>
-        </p:spPr>
-        <p:txBody>
-          <a:bodyPr wrap="square" lIns="0" rIns="0" tIns="0" bIns="0" anchor="t">
-            <a:spAutoFit/>
-          </a:bodyPr>
-          <a:lstStyle/>
-          <a:p>
-            <a:pPr algn="l">
-              <a:lnSpc>
-                <a:spcPct val="130000"/>
-              </a:lnSpc>
-            </a:pPr>
-            <a:r>
-              <a:rPr sz="1250" b="0" i="0">
-                <a:solidFill>
-                  <a:srgbClr val="6B7280"/>
-                </a:solidFill>
-                <a:latin typeface="Calibri"/>
-              </a:rPr>
-              <a:t>Regresión / gradient boosting para predecir precio óptimo por propiedad.</a:t>
-            </a:r>
-          </a:p>
-        </p:txBody>
-      </p:sp>
-      <p:sp>
-        <p:nvSpPr>
-          <p:cNvPr id="11" name="Rounded Rectangle 10"/>
-          <p:cNvSpPr/>
-          <p:nvPr/>
-        </p:nvSpPr>
-        <p:spPr>
-          <a:xfrm>
-            <a:off x="4389120" y="2743200"/>
-            <a:ext cx="3520440" cy="2286000"/>
-          </a:xfrm>
-          <a:prstGeom prst="roundRect">
-            <a:avLst>
-              <a:gd name="adj" fmla="val 5000"/>
-            </a:avLst>
-          </a:prstGeom>
-          <a:solidFill>
-            <a:srgbClr val="1E2761"/>
-          </a:solidFill>
-          <a:ln>
-            <a:noFill/>
-          </a:ln>
-          <a:effectLst/>
-        </p:spPr>
-        <p:style>
-          <a:lnRef idx="1">
-            <a:schemeClr val="accent1"/>
-          </a:lnRef>
-          <a:fillRef idx="3">
-            <a:schemeClr val="accent1"/>
-          </a:fillRef>
-          <a:effectRef idx="2">
-            <a:schemeClr val="accent1"/>
-          </a:effectRef>
-          <a:fontRef idx="minor">
-            <a:schemeClr val="lt1"/>
-          </a:fontRef>
-        </p:style>
-        <p:txBody>
-          <a:bodyPr rtlCol="0" anchor="ctr"/>
-          <a:lstStyle/>
-          <a:p>
-            <a:pPr algn="ctr"/>
-          </a:p>
-        </p:txBody>
-      </p:sp>
-      <p:sp>
-        <p:nvSpPr>
-          <p:cNvPr id="12" name="Oval 11"/>
-          <p:cNvSpPr/>
-          <p:nvPr/>
-        </p:nvSpPr>
-        <p:spPr>
-          <a:xfrm>
-            <a:off x="4663440" y="3017520"/>
-            <a:ext cx="502920" cy="502920"/>
-          </a:xfrm>
-          <a:prstGeom prst="ellipse">
-            <a:avLst/>
-          </a:prstGeom>
-          <a:solidFill>
-            <a:srgbClr val="C9A227"/>
-          </a:solidFill>
-          <a:ln>
-            <a:noFill/>
-          </a:ln>
-          <a:effectLst/>
-        </p:spPr>
-        <p:style>
-          <a:lnRef idx="1">
-            <a:schemeClr val="accent1"/>
-          </a:lnRef>
-          <a:fillRef idx="3">
-            <a:schemeClr val="accent1"/>
-          </a:fillRef>
-          <a:effectRef idx="2">
-            <a:schemeClr val="accent1"/>
-          </a:effectRef>
-          <a:fontRef idx="minor">
-            <a:schemeClr val="lt1"/>
-          </a:fontRef>
-        </p:style>
-        <p:txBody>
-          <a:bodyPr rtlCol="0" anchor="ctr"/>
-          <a:lstStyle/>
-          <a:p>
-            <a:pPr algn="ctr"/>
-          </a:p>
-        </p:txBody>
-      </p:sp>
-      <p:sp>
-        <p:nvSpPr>
-          <p:cNvPr id="13" name="TextBox 12"/>
-          <p:cNvSpPr txBox="1"/>
-          <p:nvPr/>
-        </p:nvSpPr>
-        <p:spPr>
-          <a:xfrm>
-            <a:off x="4663440" y="3017520"/>
-            <a:ext cx="502920" cy="502920"/>
-          </a:xfrm>
-          <a:prstGeom prst="rect">
-            <a:avLst/>
-          </a:prstGeom>
-          <a:noFill/>
-        </p:spPr>
-        <p:txBody>
-          <a:bodyPr wrap="square" lIns="0" rIns="0" tIns="0" bIns="0" anchor="ctr">
-            <a:spAutoFit/>
-          </a:bodyPr>
-          <a:lstStyle/>
-          <a:p>
-            <a:pPr algn="ctr">
-              <a:lnSpc>
-                <a:spcPct val="100000"/>
-              </a:lnSpc>
-            </a:pPr>
-            <a:r>
-              <a:rPr sz="1800" b="1" i="0">
-                <a:solidFill>
-                  <a:srgbClr val="1B1F3B"/>
-                </a:solidFill>
-                <a:latin typeface="Calibri"/>
-              </a:rPr>
-              <a:t>2</a:t>
-            </a:r>
-          </a:p>
-        </p:txBody>
-      </p:sp>
-      <p:sp>
-        <p:nvSpPr>
-          <p:cNvPr id="14" name="TextBox 13"/>
-          <p:cNvSpPr txBox="1"/>
-          <p:nvPr/>
-        </p:nvSpPr>
-        <p:spPr>
-          <a:xfrm>
-            <a:off x="5349240" y="3017520"/>
-            <a:ext cx="2286000" cy="502920"/>
-          </a:xfrm>
-          <a:prstGeom prst="rect">
-            <a:avLst/>
-          </a:prstGeom>
-          <a:noFill/>
-        </p:spPr>
-        <p:txBody>
-          <a:bodyPr wrap="square" lIns="0" rIns="0" tIns="0" bIns="0" anchor="ctr">
-            <a:spAutoFit/>
-          </a:bodyPr>
-          <a:lstStyle/>
-          <a:p>
-            <a:pPr algn="l">
-              <a:lnSpc>
-                <a:spcPct val="100000"/>
-              </a:lnSpc>
-            </a:pPr>
-            <a:r>
-              <a:rPr sz="1500" b="1" i="0">
-                <a:solidFill>
-                  <a:srgbClr val="FFFFFF"/>
-                </a:solidFill>
-                <a:latin typeface="Cambria"/>
-              </a:rPr>
-              <a:t>Modelo de ocupación</a:t>
-            </a:r>
-          </a:p>
-        </p:txBody>
-      </p:sp>
-      <p:sp>
-        <p:nvSpPr>
-          <p:cNvPr id="15" name="TextBox 14"/>
-          <p:cNvSpPr txBox="1"/>
-          <p:nvPr/>
-        </p:nvSpPr>
-        <p:spPr>
-          <a:xfrm>
-            <a:off x="4663440" y="3703320"/>
-            <a:ext cx="2971800" cy="1188720"/>
-          </a:xfrm>
-          <a:prstGeom prst="rect">
-            <a:avLst/>
-          </a:prstGeom>
-          <a:noFill/>
-        </p:spPr>
-        <p:txBody>
-          <a:bodyPr wrap="square" lIns="0" rIns="0" tIns="0" bIns="0" anchor="t">
-            <a:spAutoFit/>
-          </a:bodyPr>
-          <a:lstStyle/>
-          <a:p>
-            <a:pPr algn="l">
-              <a:lnSpc>
-                <a:spcPct val="130000"/>
-              </a:lnSpc>
-            </a:pPr>
-            <a:r>
-              <a:rPr sz="1250" b="0" i="0">
-                <a:solidFill>
-                  <a:srgbClr val="CADCFC"/>
-                </a:solidFill>
-                <a:latin typeface="Calibri"/>
-              </a:rPr>
-              <a:t>Clasificación de riesgo de baja ocupación según ubicación y equipamiento.</a:t>
-            </a:r>
-          </a:p>
-        </p:txBody>
-      </p:sp>
-      <p:sp>
-        <p:nvSpPr>
-          <p:cNvPr id="16" name="Rounded Rectangle 15"/>
-          <p:cNvSpPr/>
-          <p:nvPr/>
-        </p:nvSpPr>
-        <p:spPr>
-          <a:xfrm>
-            <a:off x="8138159" y="2743200"/>
-            <a:ext cx="3520440" cy="2286000"/>
-          </a:xfrm>
-          <a:prstGeom prst="roundRect">
-            <a:avLst>
-              <a:gd name="adj" fmla="val 5000"/>
-            </a:avLst>
-          </a:prstGeom>
-          <a:solidFill>
-            <a:srgbClr val="F4F6FC"/>
-          </a:solidFill>
-          <a:ln>
-            <a:noFill/>
-          </a:ln>
-          <a:effectLst/>
-        </p:spPr>
-        <p:style>
-          <a:lnRef idx="1">
-            <a:schemeClr val="accent1"/>
-          </a:lnRef>
-          <a:fillRef idx="3">
-            <a:schemeClr val="accent1"/>
-          </a:fillRef>
-          <a:effectRef idx="2">
-            <a:schemeClr val="accent1"/>
-          </a:effectRef>
-          <a:fontRef idx="minor">
-            <a:schemeClr val="lt1"/>
-          </a:fontRef>
-        </p:style>
-        <p:txBody>
-          <a:bodyPr rtlCol="0" anchor="ctr"/>
-          <a:lstStyle/>
-          <a:p>
-            <a:pPr algn="ctr"/>
-          </a:p>
-        </p:txBody>
-      </p:sp>
-      <p:sp>
-        <p:nvSpPr>
-          <p:cNvPr id="17" name="Oval 16"/>
-          <p:cNvSpPr/>
-          <p:nvPr/>
-        </p:nvSpPr>
-        <p:spPr>
-          <a:xfrm>
-            <a:off x="8412480" y="3017520"/>
-            <a:ext cx="502920" cy="502920"/>
-          </a:xfrm>
-          <a:prstGeom prst="ellipse">
-            <a:avLst/>
-          </a:prstGeom>
-          <a:solidFill>
-            <a:srgbClr val="1E2761"/>
-          </a:solidFill>
-          <a:ln>
-            <a:noFill/>
-          </a:ln>
-          <a:effectLst/>
-        </p:spPr>
-        <p:style>
-          <a:lnRef idx="1">
-            <a:schemeClr val="accent1"/>
-          </a:lnRef>
-          <a:fillRef idx="3">
-            <a:schemeClr val="accent1"/>
-          </a:fillRef>
-          <a:effectRef idx="2">
-            <a:schemeClr val="accent1"/>
-          </a:effectRef>
-          <a:fontRef idx="minor">
-            <a:schemeClr val="lt1"/>
-          </a:fontRef>
-        </p:style>
-        <p:txBody>
-          <a:bodyPr rtlCol="0" anchor="ctr"/>
-          <a:lstStyle/>
-          <a:p>
-            <a:pPr algn="ctr"/>
-          </a:p>
-        </p:txBody>
-      </p:sp>
-      <p:sp>
-        <p:nvSpPr>
-          <p:cNvPr id="18" name="TextBox 17"/>
-          <p:cNvSpPr txBox="1"/>
-          <p:nvPr/>
-        </p:nvSpPr>
-        <p:spPr>
-          <a:xfrm>
-            <a:off x="8412480" y="3017520"/>
-            <a:ext cx="502920" cy="502920"/>
-          </a:xfrm>
-          <a:prstGeom prst="rect">
-            <a:avLst/>
-          </a:prstGeom>
-          <a:noFill/>
-        </p:spPr>
-        <p:txBody>
-          <a:bodyPr wrap="square" lIns="0" rIns="0" tIns="0" bIns="0" anchor="ctr">
-            <a:spAutoFit/>
-          </a:bodyPr>
-          <a:lstStyle/>
-          <a:p>
-            <a:pPr algn="ctr">
-              <a:lnSpc>
-                <a:spcPct val="100000"/>
-              </a:lnSpc>
-            </a:pPr>
-            <a:r>
-              <a:rPr sz="1800" b="1" i="0">
-                <a:solidFill>
-                  <a:srgbClr val="FFFFFF"/>
-                </a:solidFill>
-                <a:latin typeface="Calibri"/>
-              </a:rPr>
-              <a:t>3</a:t>
-            </a:r>
-          </a:p>
-        </p:txBody>
-      </p:sp>
-      <p:sp>
-        <p:nvSpPr>
-          <p:cNvPr id="19" name="TextBox 18"/>
-          <p:cNvSpPr txBox="1"/>
-          <p:nvPr/>
-        </p:nvSpPr>
-        <p:spPr>
-          <a:xfrm>
-            <a:off x="9098280" y="3017520"/>
-            <a:ext cx="2286000" cy="502920"/>
-          </a:xfrm>
-          <a:prstGeom prst="rect">
-            <a:avLst/>
-          </a:prstGeom>
-          <a:noFill/>
-        </p:spPr>
-        <p:txBody>
-          <a:bodyPr wrap="square" lIns="0" rIns="0" tIns="0" bIns="0" anchor="ctr">
-            <a:spAutoFit/>
-          </a:bodyPr>
-          <a:lstStyle/>
-          <a:p>
-            <a:pPr algn="l">
-              <a:lnSpc>
-                <a:spcPct val="100000"/>
-              </a:lnSpc>
-            </a:pPr>
-            <a:r>
-              <a:rPr sz="1500" b="1" i="0">
-                <a:solidFill>
-                  <a:srgbClr val="1B1F3B"/>
-                </a:solidFill>
-                <a:latin typeface="Cambria"/>
-              </a:rPr>
-              <a:t>Optimización</a:t>
-            </a:r>
-          </a:p>
-        </p:txBody>
-      </p:sp>
-      <p:sp>
-        <p:nvSpPr>
-          <p:cNvPr id="20" name="TextBox 19"/>
-          <p:cNvSpPr txBox="1"/>
-          <p:nvPr/>
-        </p:nvSpPr>
-        <p:spPr>
-          <a:xfrm>
-            <a:off x="8412480" y="3703320"/>
-            <a:ext cx="2971800" cy="1188720"/>
-          </a:xfrm>
-          <a:prstGeom prst="rect">
-            <a:avLst/>
-          </a:prstGeom>
-          <a:noFill/>
-        </p:spPr>
-        <p:txBody>
-          <a:bodyPr wrap="square" lIns="0" rIns="0" tIns="0" bIns="0" anchor="t">
-            <a:spAutoFit/>
-          </a:bodyPr>
-          <a:lstStyle/>
-          <a:p>
-            <a:pPr algn="l">
-              <a:lnSpc>
-                <a:spcPct val="130000"/>
-              </a:lnSpc>
-            </a:pPr>
-            <a:r>
-              <a:rPr sz="1250" b="0" i="0">
-                <a:solidFill>
-                  <a:srgbClr val="6B7280"/>
-                </a:solidFill>
-                <a:latin typeface="Calibri"/>
-              </a:rPr>
-              <a:t>Recomendador de amenities e inversión con mejor retorno esperado por barrio.</a:t>
-            </a:r>
-          </a:p>
-        </p:txBody>
-      </p:sp>
-      <p:sp>
-        <p:nvSpPr>
-          <p:cNvPr id="21" name="Rounded Rectangle 20"/>
-          <p:cNvSpPr/>
-          <p:nvPr/>
-        </p:nvSpPr>
-        <p:spPr>
-          <a:xfrm>
-            <a:off x="640080" y="5257800"/>
-            <a:ext cx="10789920" cy="640080"/>
-          </a:xfrm>
-          <a:prstGeom prst="roundRect">
-            <a:avLst>
-              <a:gd name="adj" fmla="val 8000"/>
-            </a:avLst>
-          </a:prstGeom>
-          <a:solidFill>
-            <a:srgbClr val="F4F6FC"/>
-          </a:solidFill>
-          <a:ln>
-            <a:noFill/>
-          </a:ln>
-          <a:effectLst/>
-        </p:spPr>
-        <p:style>
-          <a:lnRef idx="1">
-            <a:schemeClr val="accent1"/>
-          </a:lnRef>
-          <a:fillRef idx="3">
-            <a:schemeClr val="accent1"/>
-          </a:fillRef>
-          <a:effectRef idx="2">
-            <a:schemeClr val="accent1"/>
-          </a:effectRef>
-          <a:fontRef idx="minor">
-            <a:schemeClr val="lt1"/>
-          </a:fontRef>
-        </p:style>
-        <p:txBody>
-          <a:bodyPr rtlCol="0" anchor="ctr"/>
-          <a:lstStyle/>
-          <a:p>
-            <a:pPr algn="ctr"/>
-          </a:p>
-        </p:txBody>
-      </p:sp>
-      <p:sp>
-        <p:nvSpPr>
-          <p:cNvPr id="22" name="Oval 21"/>
-          <p:cNvSpPr/>
-          <p:nvPr/>
-        </p:nvSpPr>
-        <p:spPr>
-          <a:xfrm>
-            <a:off x="822959" y="5376672"/>
-            <a:ext cx="384048" cy="384048"/>
-          </a:xfrm>
-          <a:prstGeom prst="ellipse">
-            <a:avLst/>
-          </a:prstGeom>
-          <a:solidFill>
-            <a:srgbClr val="1E2761"/>
-          </a:solidFill>
-          <a:ln>
-            <a:noFill/>
-          </a:ln>
-          <a:effectLst/>
-        </p:spPr>
-        <p:style>
-          <a:lnRef idx="1">
-            <a:schemeClr val="accent1"/>
-          </a:lnRef>
-          <a:fillRef idx="3">
-            <a:schemeClr val="accent1"/>
-          </a:fillRef>
-          <a:effectRef idx="2">
-            <a:schemeClr val="accent1"/>
-          </a:effectRef>
-          <a:fontRef idx="minor">
-            <a:schemeClr val="lt1"/>
-          </a:fontRef>
-        </p:style>
-        <p:txBody>
-          <a:bodyPr rtlCol="0" anchor="ctr"/>
-          <a:lstStyle/>
-          <a:p>
-            <a:pPr algn="ctr"/>
-          </a:p>
-        </p:txBody>
-      </p:sp>
-      <p:sp>
-        <p:nvSpPr>
-          <p:cNvPr id="23" name="TextBox 22"/>
-          <p:cNvSpPr txBox="1"/>
-          <p:nvPr/>
-        </p:nvSpPr>
-        <p:spPr>
-          <a:xfrm>
-            <a:off x="822959" y="5376672"/>
-            <a:ext cx="384048" cy="384048"/>
-          </a:xfrm>
-          <a:prstGeom prst="rect">
-            <a:avLst/>
-          </a:prstGeom>
-          <a:noFill/>
-        </p:spPr>
-        <p:txBody>
-          <a:bodyPr wrap="square" lIns="0" rIns="0" tIns="0" bIns="0" anchor="ctr">
-            <a:spAutoFit/>
-          </a:bodyPr>
-          <a:lstStyle/>
-          <a:p>
-            <a:pPr algn="ctr">
-              <a:lnSpc>
-                <a:spcPct val="100000"/>
-              </a:lnSpc>
-            </a:pPr>
-            <a:r>
-              <a:rPr sz="1600" b="1" i="0">
-                <a:solidFill>
-                  <a:srgbClr val="FFFFFF"/>
-                </a:solidFill>
-                <a:latin typeface="Calibri"/>
-              </a:rPr>
-              <a:t>✓</a:t>
-            </a:r>
-          </a:p>
-        </p:txBody>
-      </p:sp>
-      <p:sp>
-        <p:nvSpPr>
-          <p:cNvPr id="24" name="TextBox 23"/>
-          <p:cNvSpPr txBox="1"/>
-          <p:nvPr/>
-        </p:nvSpPr>
-        <p:spPr>
-          <a:xfrm>
-            <a:off x="1371600" y="5257800"/>
-            <a:ext cx="9784080" cy="640080"/>
-          </a:xfrm>
-          <a:prstGeom prst="rect">
-            <a:avLst/>
-          </a:prstGeom>
-          <a:noFill/>
-        </p:spPr>
-        <p:txBody>
-          <a:bodyPr wrap="square" lIns="0" rIns="0" tIns="0" bIns="0" anchor="ctr">
-            <a:spAutoFit/>
-          </a:bodyPr>
-          <a:lstStyle/>
-          <a:p>
-            <a:pPr algn="l">
-              <a:lnSpc>
-                <a:spcPct val="120000"/>
-              </a:lnSpc>
-            </a:pPr>
-            <a:r>
-              <a:rPr sz="1200" b="0" i="1">
-                <a:solidFill>
-                  <a:srgbClr val="1B1F3B"/>
-                </a:solidFill>
-                <a:latin typeface="Calibri"/>
-              </a:rPr>
-              <a:t>Infraestructura de datos ya preparada: conexión validada con Google Analytics 4 (vía BigQuery) para sumar datos de comportamiento web de la operación propia en próximas iteraciones.</a:t>
-            </a:r>
-          </a:p>
-        </p:txBody>
-      </p:sp>
-      <p:sp>
-        <p:nvSpPr>
-          <p:cNvPr id="25" name="TextBox 24"/>
-          <p:cNvSpPr txBox="1"/>
-          <p:nvPr/>
-        </p:nvSpPr>
-        <p:spPr>
-          <a:xfrm>
-            <a:off x="457200" y="6473952"/>
-            <a:ext cx="7315200" cy="274320"/>
-          </a:xfrm>
-          <a:prstGeom prst="rect">
-            <a:avLst/>
-          </a:prstGeom>
-          <a:noFill/>
-        </p:spPr>
-        <p:txBody>
-          <a:bodyPr wrap="square" lIns="0" rIns="0" tIns="0" bIns="0" anchor="t">
-            <a:spAutoFit/>
-          </a:bodyPr>
-          <a:lstStyle/>
-          <a:p>
-            <a:pPr algn="l">
-              <a:lnSpc>
-                <a:spcPct val="100000"/>
-              </a:lnSpc>
-            </a:pPr>
-            <a:r>
-              <a:rPr sz="900" b="0" i="0">
-                <a:solidFill>
-                  <a:srgbClr val="6B7280"/>
-                </a:solidFill>
-                <a:latin typeface="Calibri"/>
-              </a:rPr>
-              <a:t>Airbnb CABA — Data Science II · TP1</a:t>
-            </a:r>
-          </a:p>
-        </p:txBody>
-      </p:sp>
-      <p:sp>
-        <p:nvSpPr>
-          <p:cNvPr id="26" name="TextBox 25"/>
-          <p:cNvSpPr txBox="1"/>
-          <p:nvPr/>
-        </p:nvSpPr>
-        <p:spPr>
-          <a:xfrm>
-            <a:off x="11185855" y="6473952"/>
-            <a:ext cx="548640" cy="274320"/>
-          </a:xfrm>
-          <a:prstGeom prst="rect">
-            <a:avLst/>
-          </a:prstGeom>
-          <a:noFill/>
-        </p:spPr>
-        <p:txBody>
-          <a:bodyPr wrap="square" lIns="0" rIns="0" tIns="0" bIns="0" anchor="t">
-            <a:spAutoFit/>
-          </a:bodyPr>
-          <a:lstStyle/>
-          <a:p>
-            <a:pPr algn="r">
-              <a:lnSpc>
-                <a:spcPct val="100000"/>
-              </a:lnSpc>
-            </a:pPr>
-            <a:r>
-              <a:rPr sz="900" b="0" i="0">
-                <a:solidFill>
-                  <a:srgbClr val="6B7280"/>
-                </a:solidFill>
-                <a:latin typeface="Calibri"/>
-              </a:rPr>
-              <a:t>11</a:t>
-            </a:r>
-          </a:p>
-        </p:txBody>
-      </p:sp>
-    </p:spTree>
-  </p:cSld>
-  <p:clrMapOvr>
-    <a:masterClrMapping/>
-  </p:clrMapOvr>
-</p:sld>
-</file>
-
-<file path=ppt/slides/slide12.xml><?xml version="1.0" encoding="utf-8"?>
-<p:sld xmlns:a="http://schemas.openxmlformats.org/drawingml/2006/main" xmlns:p="http://schemas.openxmlformats.org/presentationml/2006/main" xmlns:r="http://schemas.openxmlformats.org/officeDocument/2006/relationships">
-  <p:cSld>
-    <p:spTree>
-      <p:nvGrpSpPr>
-        <p:cNvPr id="1" name=""/>
-        <p:cNvGrpSpPr/>
-        <p:nvPr/>
-      </p:nvGrpSpPr>
-      <p:grpSpPr/>
-      <p:sp>
-        <p:nvSpPr>
-          <p:cNvPr id="2" name="Rectangle 1"/>
-          <p:cNvSpPr/>
-          <p:nvPr/>
-        </p:nvSpPr>
-        <p:spPr>
-          <a:xfrm>
-            <a:off x="0" y="0"/>
-            <a:ext cx="12191695" cy="6858000"/>
-          </a:xfrm>
-          <a:prstGeom prst="rect">
-            <a:avLst/>
-          </a:prstGeom>
-          <a:solidFill>
             <a:srgbClr val="1E2761"/>
           </a:solidFill>
           <a:ln>
@@ -6634,7 +5587,7 @@
                 </a:solidFill>
                 <a:latin typeface="Calibri"/>
               </a:rPr>
-              <a:t>Optimización de Precios y Ocupación en Alquileres Temporarios — Airbnb CABA</a:t>
+              <a:t>Optimización de Precios y Ocupación en Alquileres Temporarios · Airbnb CABA</a:t>
             </a:r>
           </a:p>
         </p:txBody>
@@ -6673,7 +5626,7 @@
                 </a:solidFill>
                 <a:latin typeface="Calibri"/>
               </a:rPr>
-              <a:t>Fuentes: Inside Airbnb · OpenStreetMap / Overpass API</a:t>
+              <a:t>Fuentes: Inside Airbnb · OpenStreetMap (Overpass API) · Google Analytics 4 (BigQuery)</a:t>
             </a:r>
           </a:p>
         </p:txBody>
@@ -6712,7 +5665,7 @@
                 </a:solidFill>
                 <a:latin typeface="Calibri"/>
               </a:rPr>
-              <a:t>Airbnb CABA — Data Science II · TP1</a:t>
+              <a:t>Airbnb CABA · Data Science II · TP1</a:t>
             </a:r>
           </a:p>
         </p:txBody>
@@ -6751,7 +5704,7 @@
                 </a:solidFill>
                 <a:latin typeface="Calibri"/>
               </a:rPr>
-              <a:t>12</a:t>
+              <a:t>11</a:t>
             </a:r>
           </a:p>
         </p:txBody>
@@ -7254,7 +6207,7 @@
                 </a:solidFill>
                 <a:latin typeface="Calibri"/>
               </a:rPr>
-              <a:t>Airbnb CABA — Data Science II · TP1</a:t>
+              <a:t>Airbnb CABA · Data Science II · TP1</a:t>
             </a:r>
           </a:p>
         </p:txBody>
@@ -8734,7 +7687,7 @@
                 </a:solidFill>
                 <a:latin typeface="Calibri"/>
               </a:rPr>
-              <a:t>Airbnb CABA — Data Science II · TP1</a:t>
+              <a:t>Airbnb CABA · Data Science II · TP1</a:t>
             </a:r>
           </a:p>
         </p:txBody>
@@ -9573,7 +8526,7 @@
                 </a:solidFill>
                 <a:latin typeface="Calibri"/>
               </a:rPr>
-              <a:t>Airbnb CABA — Data Science II · TP1</a:t>
+              <a:t>Airbnb CABA · Data Science II · TP1</a:t>
             </a:r>
           </a:p>
         </p:txBody>
@@ -10016,7 +8969,7 @@
                 </a:solidFill>
                 <a:latin typeface="Calibri"/>
               </a:rPr>
-              <a:t>Lectura ejecutiva: la caminabilidad hacia oferta gastronómica y transporte es un factor de pricing a considerar junto con el tamaño y tipo de propiedad — no sustituye a otras variables, pero suma valor de ubicación medible.</a:t>
+              <a:t>La caminabilidad hacia oferta gastronómica y transporte suma valor de ubicación medible, junto con el tamaño y tipo de propiedad.</a:t>
             </a:r>
           </a:p>
         </p:txBody>
@@ -10055,7 +9008,7 @@
                 </a:solidFill>
                 <a:latin typeface="Calibri"/>
               </a:rPr>
-              <a:t>Airbnb CABA — Data Science II · TP1</a:t>
+              <a:t>Airbnb CABA · Data Science II · TP1</a:t>
             </a:r>
           </a:p>
         </p:txBody>
@@ -10498,7 +9451,7 @@
                 </a:solidFill>
                 <a:latin typeface="Calibri"/>
               </a:rPr>
-              <a:t>Lectura ejecutiva: la relación es más débil de lo que la intuición sugiere. Un buen puntaje es casi una condición necesaria para sostenerse en el mercado, pero por sí solo no explica tarifas más altas — no es una palanca de pricing fuerte.</a:t>
+              <a:t>La relación es más débil de lo que la intuición sugiere. Un buen puntaje sostiene al host en el mercado, pero no explica tarifas más altas por sí solo.</a:t>
             </a:r>
           </a:p>
         </p:txBody>
@@ -10537,7 +9490,7 @@
                 </a:solidFill>
                 <a:latin typeface="Calibri"/>
               </a:rPr>
-              <a:t>Airbnb CABA — Data Science II · TP1</a:t>
+              <a:t>Airbnb CABA · Data Science II · TP1</a:t>
             </a:r>
           </a:p>
         </p:txBody>
@@ -11301,7 +10254,7 @@
                 </a:solidFill>
                 <a:latin typeface="Calibri"/>
               </a:rPr>
-              <a:t>Airbnb CABA — Data Science II · TP1</a:t>
+              <a:t>Airbnb CABA · Data Science II · TP1</a:t>
             </a:r>
           </a:p>
         </p:txBody>
@@ -11576,7 +10529,7 @@
                 </a:solidFill>
                 <a:latin typeface="Calibri"/>
               </a:rPr>
-              <a:t>Airbnb CABA — Data Science II · TP1</a:t>
+              <a:t>Airbnb CABA · Data Science II · TP1</a:t>
             </a:r>
           </a:p>
         </p:txBody>
@@ -12321,7 +11274,7 @@
                 </a:solidFill>
                 <a:latin typeface="Calibri"/>
               </a:rPr>
-              <a:t>Airbnb CABA — Data Science II · TP1</a:t>
+              <a:t>Airbnb CABA · Data Science II · TP1</a:t>
             </a:r>
           </a:p>
         </p:txBody>

</xml_diff>